<commit_message>
Add presentation guide generation script and update .gitignore for local files
</commit_message>
<xml_diff>
--- a/reports/ToolFinder_presentation.pptx
+++ b/reports/ToolFinder_presentation.pptx
@@ -115,6 +115,339 @@
     </a:lvl9pPr>
   </p:defaultTextStyle>
 </p:presentation>
+</file>
+
+<file path=ppt/charts/chart1.xml><?xml version="1.0" encoding="utf-8"?>
+<c:chartSpace xmlns:c="http://schemas.openxmlformats.org/drawingml/2006/chart" xmlns:a="http://schemas.openxmlformats.org/drawingml/2006/main" xmlns:r="http://schemas.openxmlformats.org/officeDocument/2006/relationships">
+  <c:date1904 val="0"/>
+  <c:roundedCorners val="1"/>
+  <c:chart>
+    <c:autoTitleDeleted val="1"/>
+    <c:plotArea>
+      <c:layout/>
+      <c:barChart>
+        <c:barDir val="col"/>
+        <c:grouping val="clustered"/>
+        <c:varyColors val="0"/>
+        <c:ser>
+          <c:idx val="0"/>
+          <c:order val="0"/>
+          <c:tx>
+            <c:strRef>
+              <c:f>Sheet1!$B$1</c:f>
+              <c:strCache>
+                <c:ptCount val="1"/>
+                <c:pt idx="0">
+                  <c:v>Model A (bi-encoder)</c:v>
+                </c:pt>
+              </c:strCache>
+            </c:strRef>
+          </c:tx>
+          <c:spPr>
+            <a:solidFill>
+              <a:srgbClr val="4878A8"/>
+            </a:solidFill>
+            <a:effectLst/>
+          </c:spPr>
+          <c:invertIfNegative val="0"/>
+          <c:dLbls>
+            <c:numFmt formatCode="0.00" sourceLinked="0"/>
+            <c:txPr>
+              <a:bodyPr/>
+              <a:lstStyle/>
+              <a:p>
+                <a:pPr>
+                  <a:defRPr b="0" i="0" strike="noStrike" sz="700" u="none">
+                    <a:solidFill>
+                      <a:srgbClr val="1E293B"/>
+                    </a:solidFill>
+                    <a:latin typeface="Arial"/>
+                  </a:defRPr>
+                </a:pPr>
+              </a:p>
+            </c:txPr>
+            <c:showLegendKey val="0"/>
+            <c:showVal val="1"/>
+            <c:showCatName val="0"/>
+            <c:showSerName val="0"/>
+            <c:showPercent val="0"/>
+            <c:showBubbleSize val="0"/>
+            <c:showLeaderLines val="0"/>
+          </c:dLbls>
+          <c:cat>
+            <c:multiLvlStrRef>
+              <c:f>Sheet1!$A$2:$A$4</c:f>
+              <c:multiLvlStrCache>
+                <c:ptCount val="3"/>
+                <c:lvl>
+                  <c:pt idx="0">
+                    <c:v>Regime 1</c:v>
+                  </c:pt>
+                  <c:pt idx="1">
+                    <c:v>Regime 2</c:v>
+                  </c:pt>
+                  <c:pt idx="2">
+                    <c:v>Regime 3</c:v>
+                  </c:pt>
+                </c:lvl>
+              </c:multiLvlStrCache>
+            </c:multiLvlStrRef>
+          </c:cat>
+          <c:val>
+            <c:numRef>
+              <c:f>Sheet1!$B$2:$B$4</c:f>
+              <c:numCache>
+                <c:formatCode>General</c:formatCode>
+                <c:ptCount val="3"/>
+                <c:pt idx="0">
+                  <c:v>0.988</c:v>
+                </c:pt>
+                <c:pt idx="1">
+                  <c:v>0.909</c:v>
+                </c:pt>
+                <c:pt idx="2">
+                  <c:v>0.667</c:v>
+                </c:pt>
+              </c:numCache>
+            </c:numRef>
+          </c:val>
+        </c:ser>
+        <c:ser>
+          <c:idx val="1"/>
+          <c:order val="1"/>
+          <c:tx>
+            <c:strRef>
+              <c:f>Sheet1!$C$1</c:f>
+              <c:strCache>
+                <c:ptCount val="1"/>
+                <c:pt idx="0">
+                  <c:v>Model B (+ rerank)</c:v>
+                </c:pt>
+              </c:strCache>
+            </c:strRef>
+          </c:tx>
+          <c:spPr>
+            <a:solidFill>
+              <a:srgbClr val="E1812C"/>
+            </a:solidFill>
+            <a:effectLst/>
+          </c:spPr>
+          <c:invertIfNegative val="0"/>
+          <c:dLbls>
+            <c:numFmt formatCode="0.00" sourceLinked="0"/>
+            <c:txPr>
+              <a:bodyPr/>
+              <a:lstStyle/>
+              <a:p>
+                <a:pPr>
+                  <a:defRPr b="0" i="0" strike="noStrike" sz="700" u="none">
+                    <a:solidFill>
+                      <a:srgbClr val="1E293B"/>
+                    </a:solidFill>
+                    <a:latin typeface="Arial"/>
+                  </a:defRPr>
+                </a:pPr>
+              </a:p>
+            </c:txPr>
+            <c:showLegendKey val="0"/>
+            <c:showVal val="1"/>
+            <c:showCatName val="0"/>
+            <c:showSerName val="0"/>
+            <c:showPercent val="0"/>
+            <c:showBubbleSize val="0"/>
+            <c:showLeaderLines val="0"/>
+          </c:dLbls>
+          <c:cat>
+            <c:multiLvlStrRef>
+              <c:f>Sheet1!$A$2:$A$4</c:f>
+              <c:multiLvlStrCache>
+                <c:ptCount val="3"/>
+                <c:lvl>
+                  <c:pt idx="0">
+                    <c:v>Regime 1</c:v>
+                  </c:pt>
+                  <c:pt idx="1">
+                    <c:v>Regime 2</c:v>
+                  </c:pt>
+                  <c:pt idx="2">
+                    <c:v>Regime 3</c:v>
+                  </c:pt>
+                </c:lvl>
+              </c:multiLvlStrCache>
+            </c:multiLvlStrRef>
+          </c:cat>
+          <c:val>
+            <c:numRef>
+              <c:f>Sheet1!$C$2:$C$4</c:f>
+              <c:numCache>
+                <c:formatCode>General</c:formatCode>
+                <c:ptCount val="3"/>
+                <c:pt idx="0">
+                  <c:v>0.944</c:v>
+                </c:pt>
+                <c:pt idx="1">
+                  <c:v>0.867</c:v>
+                </c:pt>
+                <c:pt idx="2">
+                  <c:v>0.632</c:v>
+                </c:pt>
+              </c:numCache>
+            </c:numRef>
+          </c:val>
+        </c:ser>
+        <c:dLbls>
+          <c:numFmt formatCode="0.00" sourceLinked="0"/>
+          <c:txPr>
+            <a:bodyPr/>
+            <a:lstStyle/>
+            <a:p>
+              <a:pPr>
+                <a:defRPr b="0" i="0" strike="noStrike" sz="700" u="none">
+                  <a:solidFill>
+                    <a:srgbClr val="1E293B"/>
+                  </a:solidFill>
+                  <a:latin typeface="Arial"/>
+                </a:defRPr>
+              </a:pPr>
+            </a:p>
+          </c:txPr>
+          <c:showLegendKey val="0"/>
+          <c:showVal val="1"/>
+          <c:showCatName val="0"/>
+          <c:showSerName val="0"/>
+          <c:showPercent val="0"/>
+          <c:showBubbleSize val="0"/>
+          <c:showLeaderLines val="0"/>
+        </c:dLbls>
+        <c:gapWidth val="150"/>
+        <c:overlap val="0"/>
+        <c:axId val="2094734554"/>
+        <c:axId val="2094734552"/>
+        <c:axId val="2094734556"/>
+      </c:barChart>
+      <c:catAx>
+        <c:axId val="2094734554"/>
+        <c:scaling>
+          <c:orientation val="minMax"/>
+        </c:scaling>
+        <c:delete val="0"/>
+        <c:axPos val="b"/>
+        <c:numFmt formatCode="General" sourceLinked="1"/>
+        <c:majorTickMark val="out"/>
+        <c:minorTickMark val="none"/>
+        <c:tickLblPos val="low"/>
+        <c:spPr>
+          <a:ln w="12700" cap="flat">
+            <a:solidFill>
+              <a:srgbClr val="888888"/>
+            </a:solidFill>
+            <a:prstDash val="solid"/>
+            <a:round/>
+          </a:ln>
+        </c:spPr>
+        <c:txPr>
+          <a:bodyPr/>
+          <a:lstStyle/>
+          <a:p>
+            <a:pPr>
+              <a:defRPr sz="800" b="0" i="0" u="none" strike="noStrike">
+                <a:solidFill>
+                  <a:srgbClr val="64748B"/>
+                </a:solidFill>
+                <a:latin typeface="Arial"/>
+              </a:defRPr>
+            </a:pPr>
+            <a:endParaRPr lang="en-US"/>
+          </a:p>
+        </c:txPr>
+        <c:crossAx val="2094734552"/>
+        <c:crosses val="autoZero"/>
+        <c:auto val="1"/>
+        <c:lblAlgn val="ctr"/>
+        <c:noMultiLvlLbl val="1"/>
+      </c:catAx>
+      <c:valAx>
+        <c:axId val="2094734552"/>
+        <c:scaling>
+          <c:orientation val="minMax"/>
+          <c:max val="1"/>
+          <c:min val="0"/>
+        </c:scaling>
+        <c:delete val="1"/>
+        <c:axPos val="l"/>
+        <c:numFmt formatCode="General" sourceLinked="0"/>
+        <c:majorTickMark val="out"/>
+        <c:minorTickMark val="none"/>
+        <c:tickLblPos val="nextTo"/>
+        <c:spPr>
+          <a:ln w="12700" cap="flat">
+            <a:solidFill>
+              <a:srgbClr val="888888"/>
+            </a:solidFill>
+            <a:prstDash val="solid"/>
+            <a:round/>
+          </a:ln>
+        </c:spPr>
+        <c:txPr>
+          <a:bodyPr/>
+          <a:lstStyle/>
+          <a:p>
+            <a:pPr>
+              <a:defRPr sz="1200" b="0" i="0" u="none" strike="noStrike">
+                <a:solidFill>
+                  <a:srgbClr val="000000"/>
+                </a:solidFill>
+                <a:latin typeface="Arial"/>
+              </a:defRPr>
+            </a:pPr>
+            <a:endParaRPr lang="en-US"/>
+          </a:p>
+        </c:txPr>
+        <c:crossAx val="2094734554"/>
+        <c:crosses val="autoZero"/>
+        <c:crossBetween val="between"/>
+        <c:majorUnit val="0.25"/>
+      </c:valAx>
+      <c:spPr>
+        <a:noFill/>
+        <a:ln>
+          <a:noFill/>
+        </a:ln>
+        <a:effectLst/>
+      </c:spPr>
+    </c:plotArea>
+    <c:legend>
+      <c:legendPos val="b"/>
+      <c:overlay val="0"/>
+      <c:txPr>
+        <a:bodyPr/>
+        <a:lstStyle/>
+        <a:p>
+          <a:pPr>
+            <a:defRPr sz="800">
+              <a:solidFill>
+                <a:srgbClr val="1E293B"/>
+              </a:solidFill>
+            </a:defRPr>
+          </a:pPr>
+          <a:endParaRPr lang="en-US"/>
+        </a:p>
+      </c:txPr>
+    </c:legend>
+    <c:plotVisOnly val="1"/>
+    <c:dispBlanksAs val="span"/>
+  </c:chart>
+  <c:spPr>
+    <a:noFill/>
+    <a:ln>
+      <a:noFill/>
+    </a:ln>
+    <a:effectLst/>
+  </c:spPr>
+  <c:externalData r:id="rId1">
+    <c:autoUpdate val="0"/>
+  </c:externalData>
+</c:chartSpace>
 </file>
 
 <file path=ppt/notesMasters/notesMaster1.xml><?xml version="1.0" encoding="utf-8"?>
@@ -2550,8 +2883,8 @@
         </p:nvSpPr>
         <p:spPr>
           <a:xfrm>
-            <a:off x="5888736" y="1575496"/>
-            <a:ext cx="2944368" cy="2701167"/>
+            <a:off x="5852160" y="1554480"/>
+            <a:ext cx="2880360" cy="2697480"/>
           </a:xfrm>
           <a:prstGeom prst="rect">
             <a:avLst/>
@@ -2574,30 +2907,22 @@
           </a:effectLst>
         </p:spPr>
       </p:sp>
-      <p:pic>
-        <p:nvPicPr>
-          <p:cNvPr id="19" name="Image 0" descr="C:\Users\dimit\Desktop\GEORGAML\ToolFinder\experiments\results\figures\fig_confusion_regime1.png">    </p:cNvPr>
-          <p:cNvPicPr>
-            <a:picLocks noChangeAspect="1"/>
-          </p:cNvPicPr>
-          <p:nvPr/>
-        </p:nvPicPr>
-        <p:blipFill>
-          <a:blip r:embed="rId1"/>
-          <a:stretch>
-            <a:fillRect/>
-          </a:stretch>
-        </p:blipFill>
-        <p:spPr>
-          <a:xfrm>
-            <a:off x="5943600" y="1630360"/>
-            <a:ext cx="2834640" cy="2591439"/>
-          </a:xfrm>
-          <a:prstGeom prst="rect">
-            <a:avLst/>
-          </a:prstGeom>
-        </p:spPr>
-      </p:pic>
+      <p:graphicFrame>
+        <p:nvGraphicFramePr>
+          <p:cNvPr id="19" name="Chart 0" descr=""/>
+          <p:cNvGraphicFramePr/>
+          <p:nvPr/>
+        </p:nvGraphicFramePr>
+        <p:xfrm>
+          <a:off x="5943600" y="1627632"/>
+          <a:ext cx="2697480" cy="2542032"/>
+        </p:xfrm>
+        <a:graphic xmlns:a="http://schemas.openxmlformats.org/drawingml/2006/main">
+          <a:graphicData uri="http://schemas.openxmlformats.org/drawingml/2006/chart">
+            <c:chart xmlns:c="http://schemas.openxmlformats.org/drawingml/2006/chart" r:id="rId1"/>
+          </a:graphicData>
+        </a:graphic>
+      </p:graphicFrame>
       <p:sp>
         <p:nvSpPr>
           <p:cNvPr id="20" name="Text 17"/>
@@ -2606,8 +2931,8 @@
         </p:nvSpPr>
         <p:spPr>
           <a:xfrm>
-            <a:off x="5943600" y="4224528"/>
-            <a:ext cx="2834640" cy="274320"/>
+            <a:off x="5852160" y="4279392"/>
+            <a:ext cx="2880360" cy="310896"/>
           </a:xfrm>
           <a:prstGeom prst="rect">
             <a:avLst/>
@@ -2631,7 +2956,7 @@
                 <a:ea typeface="Calibri" pitchFamily="34" charset="-122"/>
                 <a:cs typeface="Calibri" pitchFamily="34" charset="-120"/>
               </a:rPr>
-              <a:t>Residual errors: confusable pairs</a:t>
+              <a:t>Reranking (B) sits below the bi-encoder (A) in every regime.</a:t>
             </a:r>
             <a:endParaRPr lang="en-US" sz="950" dirty="0"/>
           </a:p>

</xml_diff>

<commit_message>
Update LLM-in-context baseline results and presentation; document accuracy and latency metrics
</commit_message>
<xml_diff>
--- a/reports/ToolFinder_presentation.pptx
+++ b/reports/ToolFinder_presentation.pptx
@@ -16,9 +16,10 @@
     <p:sldId id="264" r:id="rId10"/>
     <p:sldId id="265" r:id="rId11"/>
     <p:sldId id="266" r:id="rId12"/>
+    <p:sldId id="267" r:id="rId13"/>
   </p:sldIdLst>
   <p:notesMasterIdLst>
-    <p:notesMasterId r:id="rId13"/>
+    <p:notesMasterId r:id="rId14"/>
   </p:notesMasterIdLst>
   <p:sldSz cx="9144000" cy="5143500"/>
   <p:notesSz cx="5143500" cy="9144000"/>
@@ -118,6 +119,237 @@
 </file>
 
 <file path=ppt/charts/chart1.xml><?xml version="1.0" encoding="utf-8"?>
+<c:chartSpace xmlns:c="http://schemas.openxmlformats.org/drawingml/2006/chart" xmlns:a="http://schemas.openxmlformats.org/drawingml/2006/main" xmlns:r="http://schemas.openxmlformats.org/officeDocument/2006/relationships">
+  <c:date1904 val="0"/>
+  <c:roundedCorners val="1"/>
+  <c:chart>
+    <c:autoTitleDeleted val="1"/>
+    <c:plotArea>
+      <c:layout/>
+      <c:barChart>
+        <c:barDir val="col"/>
+        <c:grouping val="clustered"/>
+        <c:varyColors val="0"/>
+        <c:ser>
+          <c:idx val="0"/>
+          <c:order val="0"/>
+          <c:tx>
+            <c:strRef>
+              <c:f>Sheet1!$B$1</c:f>
+              <c:strCache>
+                <c:ptCount val="1"/>
+                <c:pt idx="0">
+                  <c:v>llama3.2 in-context accuracy</c:v>
+                </c:pt>
+              </c:strCache>
+            </c:strRef>
+          </c:tx>
+          <c:spPr>
+            <a:solidFill>
+              <a:srgbClr val="E1812C"/>
+            </a:solidFill>
+            <a:effectLst/>
+          </c:spPr>
+          <c:invertIfNegative val="0"/>
+          <c:dLbls>
+            <c:numFmt formatCode="0.00" sourceLinked="0"/>
+            <c:txPr>
+              <a:bodyPr/>
+              <a:lstStyle/>
+              <a:p>
+                <a:pPr>
+                  <a:defRPr b="0" i="0" strike="noStrike" sz="800" u="none">
+                    <a:solidFill>
+                      <a:srgbClr val="1E293B"/>
+                    </a:solidFill>
+                    <a:latin typeface="Arial"/>
+                  </a:defRPr>
+                </a:pPr>
+              </a:p>
+            </c:txPr>
+            <c:showLegendKey val="0"/>
+            <c:showVal val="1"/>
+            <c:showCatName val="0"/>
+            <c:showSerName val="0"/>
+            <c:showPercent val="0"/>
+            <c:showBubbleSize val="0"/>
+            <c:showLeaderLines val="0"/>
+          </c:dLbls>
+          <c:cat>
+            <c:multiLvlStrRef>
+              <c:f>Sheet1!$A$2:$A$4</c:f>
+              <c:multiLvlStrCache>
+                <c:ptCount val="3"/>
+                <c:lvl>
+                  <c:pt idx="0">
+                    <c:v>5 tools</c:v>
+                  </c:pt>
+                  <c:pt idx="1">
+                    <c:v>15 tools</c:v>
+                  </c:pt>
+                  <c:pt idx="2">
+                    <c:v>30 tools</c:v>
+                  </c:pt>
+                </c:lvl>
+              </c:multiLvlStrCache>
+            </c:multiLvlStrRef>
+          </c:cat>
+          <c:val>
+            <c:numRef>
+              <c:f>Sheet1!$B$2:$B$4</c:f>
+              <c:numCache>
+                <c:formatCode>General</c:formatCode>
+                <c:ptCount val="3"/>
+                <c:pt idx="0">
+                  <c:v>0.41</c:v>
+                </c:pt>
+                <c:pt idx="1">
+                  <c:v>0.299</c:v>
+                </c:pt>
+                <c:pt idx="2">
+                  <c:v>0.174</c:v>
+                </c:pt>
+              </c:numCache>
+            </c:numRef>
+          </c:val>
+        </c:ser>
+        <c:dLbls>
+          <c:numFmt formatCode="0.00" sourceLinked="0"/>
+          <c:txPr>
+            <a:bodyPr/>
+            <a:lstStyle/>
+            <a:p>
+              <a:pPr>
+                <a:defRPr b="0" i="0" strike="noStrike" sz="800" u="none">
+                  <a:solidFill>
+                    <a:srgbClr val="1E293B"/>
+                  </a:solidFill>
+                  <a:latin typeface="Arial"/>
+                </a:defRPr>
+              </a:pPr>
+            </a:p>
+          </c:txPr>
+          <c:showLegendKey val="0"/>
+          <c:showVal val="1"/>
+          <c:showCatName val="0"/>
+          <c:showSerName val="0"/>
+          <c:showPercent val="0"/>
+          <c:showBubbleSize val="0"/>
+          <c:showLeaderLines val="0"/>
+        </c:dLbls>
+        <c:gapWidth val="150"/>
+        <c:overlap val="0"/>
+        <c:axId val="2094734554"/>
+        <c:axId val="2094734552"/>
+        <c:axId val="2094734556"/>
+      </c:barChart>
+      <c:catAx>
+        <c:axId val="2094734554"/>
+        <c:scaling>
+          <c:orientation val="minMax"/>
+        </c:scaling>
+        <c:delete val="0"/>
+        <c:axPos val="b"/>
+        <c:numFmt formatCode="General" sourceLinked="1"/>
+        <c:majorTickMark val="out"/>
+        <c:minorTickMark val="none"/>
+        <c:tickLblPos val="low"/>
+        <c:spPr>
+          <a:ln w="12700" cap="flat">
+            <a:solidFill>
+              <a:srgbClr val="888888"/>
+            </a:solidFill>
+            <a:prstDash val="solid"/>
+            <a:round/>
+          </a:ln>
+        </c:spPr>
+        <c:txPr>
+          <a:bodyPr/>
+          <a:lstStyle/>
+          <a:p>
+            <a:pPr>
+              <a:defRPr sz="900" b="0" i="0" u="none" strike="noStrike">
+                <a:solidFill>
+                  <a:srgbClr val="64748B"/>
+                </a:solidFill>
+                <a:latin typeface="Arial"/>
+              </a:defRPr>
+            </a:pPr>
+            <a:endParaRPr lang="en-US"/>
+          </a:p>
+        </c:txPr>
+        <c:crossAx val="2094734552"/>
+        <c:crosses val="autoZero"/>
+        <c:auto val="1"/>
+        <c:lblAlgn val="ctr"/>
+        <c:noMultiLvlLbl val="1"/>
+      </c:catAx>
+      <c:valAx>
+        <c:axId val="2094734552"/>
+        <c:scaling>
+          <c:orientation val="minMax"/>
+          <c:max val="1"/>
+          <c:min val="0"/>
+        </c:scaling>
+        <c:delete val="1"/>
+        <c:axPos val="l"/>
+        <c:numFmt formatCode="General" sourceLinked="0"/>
+        <c:majorTickMark val="out"/>
+        <c:minorTickMark val="none"/>
+        <c:tickLblPos val="nextTo"/>
+        <c:spPr>
+          <a:ln w="12700" cap="flat">
+            <a:solidFill>
+              <a:srgbClr val="888888"/>
+            </a:solidFill>
+            <a:prstDash val="solid"/>
+            <a:round/>
+          </a:ln>
+        </c:spPr>
+        <c:txPr>
+          <a:bodyPr/>
+          <a:lstStyle/>
+          <a:p>
+            <a:pPr>
+              <a:defRPr sz="1200" b="0" i="0" u="none" strike="noStrike">
+                <a:solidFill>
+                  <a:srgbClr val="000000"/>
+                </a:solidFill>
+                <a:latin typeface="Arial"/>
+              </a:defRPr>
+            </a:pPr>
+            <a:endParaRPr lang="en-US"/>
+          </a:p>
+        </c:txPr>
+        <c:crossAx val="2094734554"/>
+        <c:crosses val="autoZero"/>
+        <c:crossBetween val="between"/>
+      </c:valAx>
+      <c:spPr>
+        <a:noFill/>
+        <a:ln>
+          <a:noFill/>
+        </a:ln>
+        <a:effectLst/>
+      </c:spPr>
+    </c:plotArea>
+    <c:plotVisOnly val="1"/>
+    <c:dispBlanksAs val="span"/>
+  </c:chart>
+  <c:spPr>
+    <a:noFill/>
+    <a:ln>
+      <a:noFill/>
+    </a:ln>
+    <a:effectLst/>
+  </c:spPr>
+  <c:externalData r:id="rId1">
+    <c:autoUpdate val="0"/>
+  </c:externalData>
+</c:chartSpace>
+</file>
+
+<file path=ppt/charts/chart2.xml><?xml version="1.0" encoding="utf-8"?>
 <c:chartSpace xmlns:c="http://schemas.openxmlformats.org/drawingml/2006/chart" xmlns:a="http://schemas.openxmlformats.org/drawingml/2006/main" xmlns:r="http://schemas.openxmlformats.org/officeDocument/2006/relationships">
   <c:date1904 val="0"/>
   <c:roundedCorners val="1"/>
@@ -1045,6 +1277,94 @@
             <a:fld id="{F7021451-1387-4CA6-816F-3879F97B5CBC}" type="slidenum">
               <a:rPr lang="en-US"/>
               <a:t>11</a:t>
+            </a:fld>
+            <a:endParaRPr lang="en-US"/>
+          </a:p>
+        </p:txBody>
+      </p:sp>
+    </p:spTree>
+    <p:extLst>
+      <p:ext uri="{BB962C8B-B14F-4D97-AF65-F5344CB8AC3E}">
+        <p14:creationId xmlns:p14="http://schemas.microsoft.com/office/powerpoint/2010/main" val="1024086991"/>
+      </p:ext>
+    </p:extLst>
+  </p:cSld>
+  <p:clrMapOvr>
+    <a:masterClrMapping/>
+  </p:clrMapOvr>
+</p:notes>
+</file>
+
+<file path=ppt/notesSlides/notesSlide12.xml><?xml version="1.0" encoding="utf-8"?>
+<p:notes xmlns:a="http://schemas.openxmlformats.org/drawingml/2006/main" xmlns:r="http://schemas.openxmlformats.org/officeDocument/2006/relationships" xmlns:p="http://schemas.openxmlformats.org/presentationml/2006/main">
+  <p:cSld>
+    <p:spTree>
+      <p:nvGrpSpPr>
+        <p:cNvPr id="1" name=""/>
+        <p:cNvGrpSpPr/>
+        <p:nvPr/>
+      </p:nvGrpSpPr>
+      <p:grpSpPr>
+        <a:xfrm>
+          <a:off x="0" y="0"/>
+          <a:ext cx="0" cy="0"/>
+          <a:chOff x="0" y="0"/>
+          <a:chExt cx="0" cy="0"/>
+        </a:xfrm>
+      </p:grpSpPr>
+      <p:sp>
+        <p:nvSpPr>
+          <p:cNvPr id="2" name="Slide Image Placeholder 1"/>
+          <p:cNvSpPr>
+            <a:spLocks noGrp="1" noRot="1" noChangeAspect="1"/>
+          </p:cNvSpPr>
+          <p:nvPr>
+            <p:ph type="sldImg"/>
+          </p:nvPr>
+        </p:nvSpPr>
+        <p:spPr/>
+      </p:sp>
+      <p:sp>
+        <p:nvSpPr>
+          <p:cNvPr id="3" name="Notes Placeholder 2"/>
+          <p:cNvSpPr>
+            <a:spLocks noGrp="1"/>
+          </p:cNvSpPr>
+          <p:nvPr>
+            <p:ph type="body" idx="1"/>
+          </p:nvPr>
+        </p:nvSpPr>
+        <p:spPr/>
+        <p:txBody>
+          <a:bodyPr/>
+          <a:lstStyle/>
+          <a:p>
+            <a:r>
+              <a:rPr lang="en-US" dirty="0"/>
+              <a:t/>
+            </a:r>
+            <a:endParaRPr lang="en-US" dirty="0"/>
+          </a:p>
+        </p:txBody>
+      </p:sp>
+      <p:sp>
+        <p:nvSpPr>
+          <p:cNvPr id="4" name="Slide Number Placeholder 3"/>
+          <p:cNvSpPr>
+            <a:spLocks noGrp="1"/>
+          </p:cNvSpPr>
+          <p:nvPr>
+            <p:ph type="sldNum" sz="quarter" idx="10"/>
+          </p:nvPr>
+        </p:nvSpPr>
+        <p:spPr/>
+        <p:txBody>
+          <a:bodyPr/>
+          <a:lstStyle/>
+          <a:p>
+            <a:fld id="{F7021451-1387-4CA6-816F-3879F97B5CBC}" type="slidenum">
+              <a:rPr lang="en-US"/>
+              <a:t>12</a:t>
             </a:fld>
             <a:endParaRPr lang="en-US"/>
           </a:p>
@@ -2394,7 +2714,7 @@
         <p:spPr>
           <a:xfrm>
             <a:off x="502920" y="384048"/>
-            <a:ext cx="2080260" cy="310896"/>
+            <a:ext cx="2157984" cy="310896"/>
           </a:xfrm>
           <a:prstGeom prst="roundRect">
             <a:avLst>
@@ -2416,7 +2736,7 @@
         <p:spPr>
           <a:xfrm>
             <a:off x="502920" y="384048"/>
-            <a:ext cx="2080260" cy="310896"/>
+            <a:ext cx="2157984" cy="310896"/>
           </a:xfrm>
           <a:prstGeom prst="rect">
             <a:avLst/>
@@ -2440,7 +2760,7 @@
                 <a:ea typeface="Calibri" pitchFamily="34" charset="-122"/>
                 <a:cs typeface="Calibri" pitchFamily="34" charset="-120"/>
               </a:rPr>
-              <a:t>HONEST FINDINGS</a:t>
+              <a:t>SAFETY &amp; SYSTEMS</a:t>
             </a:r>
             <a:endParaRPr lang="en-US" sz="1000" dirty="0"/>
           </a:p>
@@ -2479,7 +2799,7 @@
                 <a:ea typeface="Georgia" pitchFamily="34" charset="-122"/>
                 <a:cs typeface="Georgia" pitchFamily="34" charset="-120"/>
               </a:rPr>
-              <a:t>What did not work — reported, not hidden</a:t>
+              <a:t>Rejection, robustness, and the right index</a:t>
             </a:r>
             <a:endParaRPr lang="en-US" sz="2600" dirty="0"/>
           </a:p>
@@ -2493,8 +2813,8 @@
         </p:nvSpPr>
         <p:spPr>
           <a:xfrm>
-            <a:off x="640080" y="1554480"/>
-            <a:ext cx="5074920" cy="868680"/>
+            <a:off x="4288536" y="1910439"/>
+            <a:ext cx="4636008" cy="1985562"/>
           </a:xfrm>
           <a:prstGeom prst="rect">
             <a:avLst/>
@@ -2517,114 +2837,40 @@
           </a:effectLst>
         </p:spPr>
       </p:sp>
-      <p:sp>
-        <p:nvSpPr>
-          <p:cNvPr id="7" name="Shape 5"/>
-          <p:cNvSpPr/>
-          <p:nvPr/>
-        </p:nvSpPr>
-        <p:spPr>
-          <a:xfrm>
-            <a:off x="640080" y="1554480"/>
-            <a:ext cx="64008" cy="868680"/>
-          </a:xfrm>
-          <a:prstGeom prst="rect">
-            <a:avLst/>
-          </a:prstGeom>
-          <a:solidFill>
-            <a:srgbClr val="E1812C"/>
-          </a:solidFill>
-          <a:ln/>
-        </p:spPr>
-      </p:sp>
-      <p:sp>
-        <p:nvSpPr>
-          <p:cNvPr id="8" name="Text 6"/>
-          <p:cNvSpPr/>
-          <p:nvPr/>
-        </p:nvSpPr>
-        <p:spPr>
-          <a:xfrm>
-            <a:off x="777240" y="1645920"/>
-            <a:ext cx="4846320" cy="292608"/>
-          </a:xfrm>
-          <a:prstGeom prst="rect">
-            <a:avLst/>
-          </a:prstGeom>
-          <a:noFill/>
-          <a:ln/>
-        </p:spPr>
-        <p:txBody>
-          <a:bodyPr wrap="square" lIns="0" tIns="0" rIns="0" bIns="0" rtlCol="0" anchor="ctr"/>
-          <a:lstStyle/>
-          <a:p>
-            <a:pPr indent="0" marL="0">
-              <a:buNone/>
-            </a:pPr>
-            <a:r>
-              <a:rPr lang="en-US" sz="1400" b="1" dirty="0">
-                <a:solidFill>
-                  <a:srgbClr val="1B2A4A"/>
-                </a:solidFill>
-                <a:latin typeface="Calibri" pitchFamily="34" charset="0"/>
-                <a:ea typeface="Calibri" pitchFamily="34" charset="-122"/>
-                <a:cs typeface="Calibri" pitchFamily="34" charset="-120"/>
-              </a:rPr>
-              <a:t>Reranking hurts</a:t>
-            </a:r>
-            <a:endParaRPr lang="en-US" sz="1400" dirty="0"/>
-          </a:p>
-        </p:txBody>
-      </p:sp>
-      <p:sp>
-        <p:nvSpPr>
-          <p:cNvPr id="9" name="Text 7"/>
-          <p:cNvSpPr/>
-          <p:nvPr/>
-        </p:nvSpPr>
-        <p:spPr>
-          <a:xfrm>
-            <a:off x="777240" y="1938528"/>
-            <a:ext cx="4846320" cy="457200"/>
-          </a:xfrm>
-          <a:prstGeom prst="rect">
-            <a:avLst/>
-          </a:prstGeom>
-          <a:noFill/>
-          <a:ln/>
-        </p:spPr>
-        <p:txBody>
-          <a:bodyPr wrap="square" lIns="0" tIns="0" rIns="0" bIns="0" rtlCol="0" anchor="ctr"/>
-          <a:lstStyle/>
-          <a:p>
-            <a:pPr indent="0" marL="0">
-              <a:buNone/>
-            </a:pPr>
-            <a:r>
-              <a:rPr lang="en-US" sz="1050" dirty="0">
-                <a:solidFill>
-                  <a:srgbClr val="1E293B"/>
-                </a:solidFill>
-                <a:latin typeface="Calibri" pitchFamily="34" charset="0"/>
-                <a:ea typeface="Calibri" pitchFamily="34" charset="-122"/>
-                <a:cs typeface="Calibri" pitchFamily="34" charset="-120"/>
-              </a:rPr>
-              <a:t>Model B degrades Model A (0.944 vs 0.988) at ~140× the per-query cost — a stronger retriever + weaker reranker.</a:t>
-            </a:r>
-            <a:endParaRPr lang="en-US" sz="1050" dirty="0"/>
-          </a:p>
-        </p:txBody>
-      </p:sp>
-      <p:sp>
-        <p:nvSpPr>
-          <p:cNvPr id="10" name="Shape 8"/>
-          <p:cNvSpPr/>
-          <p:nvPr/>
-        </p:nvSpPr>
-        <p:spPr>
-          <a:xfrm>
-            <a:off x="640080" y="2514600"/>
-            <a:ext cx="5074920" cy="868680"/>
+      <p:pic>
+        <p:nvPicPr>
+          <p:cNvPr id="7" name="Image 0" descr="C:\Users\dimit\Desktop\GEORGAML\ToolFinder\experiments\results\figures\fig_scaling.png">    </p:cNvPr>
+          <p:cNvPicPr>
+            <a:picLocks noChangeAspect="1"/>
+          </p:cNvPicPr>
+          <p:nvPr/>
+        </p:nvPicPr>
+        <p:blipFill>
+          <a:blip r:embed="rId1"/>
+          <a:stretch>
+            <a:fillRect/>
+          </a:stretch>
+        </p:blipFill>
+        <p:spPr>
+          <a:xfrm>
+            <a:off x="4343400" y="1965303"/>
+            <a:ext cx="4526280" cy="1875834"/>
+          </a:xfrm>
+          <a:prstGeom prst="rect">
+            <a:avLst/>
+          </a:prstGeom>
+        </p:spPr>
+      </p:pic>
+      <p:sp>
+        <p:nvSpPr>
+          <p:cNvPr id="8" name="Shape 5"/>
+          <p:cNvSpPr/>
+          <p:nvPr/>
+        </p:nvSpPr>
+        <p:spPr>
+          <a:xfrm>
+            <a:off x="640080" y="1508760"/>
+            <a:ext cx="3383280" cy="1234440"/>
           </a:xfrm>
           <a:prstGeom prst="rect">
             <a:avLst/>
@@ -2649,34 +2895,34 @@
       </p:sp>
       <p:sp>
         <p:nvSpPr>
-          <p:cNvPr id="11" name="Shape 9"/>
-          <p:cNvSpPr/>
-          <p:nvPr/>
-        </p:nvSpPr>
-        <p:spPr>
-          <a:xfrm>
-            <a:off x="640080" y="2514600"/>
-            <a:ext cx="64008" cy="868680"/>
+          <p:cNvPr id="9" name="Shape 6"/>
+          <p:cNvSpPr/>
+          <p:nvPr/>
+        </p:nvSpPr>
+        <p:spPr>
+          <a:xfrm>
+            <a:off x="640080" y="1508760"/>
+            <a:ext cx="64008" cy="1234440"/>
           </a:xfrm>
           <a:prstGeom prst="rect">
             <a:avLst/>
           </a:prstGeom>
           <a:solidFill>
-            <a:srgbClr val="E1812C"/>
+            <a:srgbClr val="4878A8"/>
           </a:solidFill>
           <a:ln/>
         </p:spPr>
       </p:sp>
       <p:sp>
         <p:nvSpPr>
-          <p:cNvPr id="12" name="Text 10"/>
-          <p:cNvSpPr/>
-          <p:nvPr/>
-        </p:nvSpPr>
-        <p:spPr>
-          <a:xfrm>
-            <a:off x="777240" y="2606040"/>
-            <a:ext cx="4846320" cy="292608"/>
+          <p:cNvPr id="10" name="Text 7"/>
+          <p:cNvSpPr/>
+          <p:nvPr/>
+        </p:nvSpPr>
+        <p:spPr>
+          <a:xfrm>
+            <a:off x="804672" y="1618488"/>
+            <a:ext cx="3108960" cy="566928"/>
           </a:xfrm>
           <a:prstGeom prst="rect">
             <a:avLst/>
@@ -2692,69 +2938,69 @@
               <a:buNone/>
             </a:pPr>
             <a:r>
-              <a:rPr lang="en-US" sz="1400" b="1" dirty="0">
-                <a:solidFill>
-                  <a:srgbClr val="1B2A4A"/>
+              <a:rPr lang="en-US" sz="3000" b="1" dirty="0">
+                <a:solidFill>
+                  <a:srgbClr val="4878A8"/>
+                </a:solidFill>
+                <a:latin typeface="Georgia" pitchFamily="34" charset="0"/>
+                <a:ea typeface="Georgia" pitchFamily="34" charset="-122"/>
+                <a:cs typeface="Georgia" pitchFamily="34" charset="-120"/>
+              </a:rPr>
+              <a:t>0.99 ROC-AUC</a:t>
+            </a:r>
+            <a:endParaRPr lang="en-US" sz="3000" dirty="0"/>
+          </a:p>
+        </p:txBody>
+      </p:sp>
+      <p:sp>
+        <p:nvSpPr>
+          <p:cNvPr id="11" name="Text 8"/>
+          <p:cNvSpPr/>
+          <p:nvPr/>
+        </p:nvSpPr>
+        <p:spPr>
+          <a:xfrm>
+            <a:off x="804672" y="2185416"/>
+            <a:ext cx="3108960" cy="457200"/>
+          </a:xfrm>
+          <a:prstGeom prst="rect">
+            <a:avLst/>
+          </a:prstGeom>
+          <a:noFill/>
+          <a:ln/>
+        </p:spPr>
+        <p:txBody>
+          <a:bodyPr wrap="square" lIns="0" tIns="0" rIns="0" bIns="0" rtlCol="0" anchor="t"/>
+          <a:lstStyle/>
+          <a:p>
+            <a:pPr indent="0" marL="0">
+              <a:buNone/>
+            </a:pPr>
+            <a:r>
+              <a:rPr lang="en-US" sz="1100" dirty="0">
+                <a:solidFill>
+                  <a:srgbClr val="1E293B"/>
                 </a:solidFill>
                 <a:latin typeface="Calibri" pitchFamily="34" charset="0"/>
                 <a:ea typeface="Calibri" pitchFamily="34" charset="-122"/>
                 <a:cs typeface="Calibri" pitchFamily="34" charset="-120"/>
               </a:rPr>
-              <a:t>Default ≠ best</a:t>
-            </a:r>
-            <a:endParaRPr lang="en-US" sz="1400" dirty="0"/>
-          </a:p>
-        </p:txBody>
-      </p:sp>
-      <p:sp>
-        <p:nvSpPr>
-          <p:cNvPr id="13" name="Text 11"/>
-          <p:cNvSpPr/>
-          <p:nvPr/>
-        </p:nvSpPr>
-        <p:spPr>
-          <a:xfrm>
-            <a:off x="777240" y="2898648"/>
-            <a:ext cx="4846320" cy="457200"/>
-          </a:xfrm>
-          <a:prstGeom prst="rect">
-            <a:avLst/>
-          </a:prstGeom>
-          <a:noFill/>
-          <a:ln/>
-        </p:spPr>
-        <p:txBody>
-          <a:bodyPr wrap="square" lIns="0" tIns="0" rIns="0" bIns="0" rtlCol="0" anchor="ctr"/>
-          <a:lstStyle/>
-          <a:p>
-            <a:pPr indent="0" marL="0">
-              <a:buNone/>
-            </a:pPr>
-            <a:r>
-              <a:rPr lang="en-US" sz="1050" dirty="0">
-                <a:solidFill>
-                  <a:srgbClr val="1E293B"/>
-                </a:solidFill>
-                <a:latin typeface="Calibri" pitchFamily="34" charset="0"/>
-                <a:ea typeface="Calibri" pitchFamily="34" charset="-122"/>
-                <a:cs typeface="Calibri" pitchFamily="34" charset="-120"/>
-              </a:rPr>
-              <a:t>The shipped router loads a zero-shot encoder; the fine-tuned weights that win are regenerable but not committed.</a:t>
-            </a:r>
-            <a:endParaRPr lang="en-US" sz="1050" dirty="0"/>
-          </a:p>
-        </p:txBody>
-      </p:sp>
-      <p:sp>
-        <p:nvSpPr>
-          <p:cNvPr id="14" name="Shape 12"/>
-          <p:cNvSpPr/>
-          <p:nvPr/>
-        </p:nvSpPr>
-        <p:spPr>
-          <a:xfrm>
-            <a:off x="640080" y="3474720"/>
-            <a:ext cx="5074920" cy="868680"/>
+              <a:t>out-of-scope rejection (fine-tuned encoder)</a:t>
+            </a:r>
+            <a:endParaRPr lang="en-US" sz="1100" dirty="0"/>
+          </a:p>
+        </p:txBody>
+      </p:sp>
+      <p:sp>
+        <p:nvSpPr>
+          <p:cNvPr id="12" name="Shape 9"/>
+          <p:cNvSpPr/>
+          <p:nvPr/>
+        </p:nvSpPr>
+        <p:spPr>
+          <a:xfrm>
+            <a:off x="640080" y="2852928"/>
+            <a:ext cx="3383280" cy="1234440"/>
           </a:xfrm>
           <a:prstGeom prst="rect">
             <a:avLst/>
@@ -2779,14 +3025,14 @@
       </p:sp>
       <p:sp>
         <p:nvSpPr>
-          <p:cNvPr id="15" name="Shape 13"/>
-          <p:cNvSpPr/>
-          <p:nvPr/>
-        </p:nvSpPr>
-        <p:spPr>
-          <a:xfrm>
-            <a:off x="640080" y="3474720"/>
-            <a:ext cx="64008" cy="868680"/>
+          <p:cNvPr id="13" name="Shape 10"/>
+          <p:cNvSpPr/>
+          <p:nvPr/>
+        </p:nvSpPr>
+        <p:spPr>
+          <a:xfrm>
+            <a:off x="640080" y="2852928"/>
+            <a:ext cx="64008" cy="1234440"/>
           </a:xfrm>
           <a:prstGeom prst="rect">
             <a:avLst/>
@@ -2799,14 +3045,14 @@
       </p:sp>
       <p:sp>
         <p:nvSpPr>
-          <p:cNvPr id="16" name="Text 14"/>
-          <p:cNvSpPr/>
-          <p:nvPr/>
-        </p:nvSpPr>
-        <p:spPr>
-          <a:xfrm>
-            <a:off x="777240" y="3566160"/>
-            <a:ext cx="4846320" cy="292608"/>
+          <p:cNvPr id="14" name="Text 11"/>
+          <p:cNvSpPr/>
+          <p:nvPr/>
+        </p:nvSpPr>
+        <p:spPr>
+          <a:xfrm>
+            <a:off x="804672" y="2962656"/>
+            <a:ext cx="3108960" cy="566928"/>
           </a:xfrm>
           <a:prstGeom prst="rect">
             <a:avLst/>
@@ -2822,30 +3068,69 @@
               <a:buNone/>
             </a:pPr>
             <a:r>
-              <a:rPr lang="en-US" sz="1400" b="1" dirty="0">
-                <a:solidFill>
-                  <a:srgbClr val="1B2A4A"/>
+              <a:rPr lang="en-US" sz="3000" b="1" dirty="0">
+                <a:solidFill>
+                  <a:srgbClr val="E1812C"/>
+                </a:solidFill>
+                <a:latin typeface="Georgia" pitchFamily="34" charset="0"/>
+                <a:ea typeface="Georgia" pitchFamily="34" charset="-122"/>
+                <a:cs typeface="Georgia" pitchFamily="34" charset="-120"/>
+              </a:rPr>
+              <a:t>0% vs 83%</a:t>
+            </a:r>
+            <a:endParaRPr lang="en-US" sz="3000" dirty="0"/>
+          </a:p>
+        </p:txBody>
+      </p:sp>
+      <p:sp>
+        <p:nvSpPr>
+          <p:cNvPr id="15" name="Text 12"/>
+          <p:cNvSpPr/>
+          <p:nvPr/>
+        </p:nvSpPr>
+        <p:spPr>
+          <a:xfrm>
+            <a:off x="804672" y="3529584"/>
+            <a:ext cx="3108960" cy="457200"/>
+          </a:xfrm>
+          <a:prstGeom prst="rect">
+            <a:avLst/>
+          </a:prstGeom>
+          <a:noFill/>
+          <a:ln/>
+        </p:spPr>
+        <p:txBody>
+          <a:bodyPr wrap="square" lIns="0" tIns="0" rIns="0" bIns="0" rtlCol="0" anchor="t"/>
+          <a:lstStyle/>
+          <a:p>
+            <a:pPr indent="0" marL="0">
+              <a:buNone/>
+            </a:pPr>
+            <a:r>
+              <a:rPr lang="en-US" sz="1100" dirty="0">
+                <a:solidFill>
+                  <a:srgbClr val="1E293B"/>
                 </a:solidFill>
                 <a:latin typeface="Calibri" pitchFamily="34" charset="0"/>
                 <a:ea typeface="Calibri" pitchFamily="34" charset="-122"/>
                 <a:cs typeface="Calibri" pitchFamily="34" charset="-120"/>
               </a:rPr>
-              <a:t>Synthetic data</a:t>
-            </a:r>
-            <a:endParaRPr lang="en-US" sz="1400" dirty="0"/>
-          </a:p>
-        </p:txBody>
-      </p:sp>
-      <p:sp>
-        <p:nvSpPr>
-          <p:cNvPr id="17" name="Text 15"/>
-          <p:cNvSpPr/>
-          <p:nvPr/>
-        </p:nvSpPr>
-        <p:spPr>
-          <a:xfrm>
-            <a:off x="777240" y="3858768"/>
-            <a:ext cx="4846320" cy="457200"/>
+              <a:t>poisoning hijack: fine-tuned vs BM25 (fine-tuning is the defense)</a:t>
+            </a:r>
+            <a:endParaRPr lang="en-US" sz="1100" dirty="0"/>
+          </a:p>
+        </p:txBody>
+      </p:sp>
+      <p:sp>
+        <p:nvSpPr>
+          <p:cNvPr id="16" name="Text 13"/>
+          <p:cNvSpPr/>
+          <p:nvPr/>
+        </p:nvSpPr>
+        <p:spPr>
+          <a:xfrm>
+            <a:off x="4343400" y="4114800"/>
+            <a:ext cx="4526280" cy="548640"/>
           </a:xfrm>
           <a:prstGeom prst="rect">
             <a:avLst/>
@@ -2857,34 +3142,264 @@
           <a:bodyPr wrap="square" lIns="0" tIns="0" rIns="0" bIns="0" rtlCol="0" anchor="ctr"/>
           <a:lstStyle/>
           <a:p>
-            <a:pPr indent="0" marL="0">
-              <a:buNone/>
-            </a:pPr>
-            <a:r>
-              <a:rPr lang="en-US" sz="1050" dirty="0">
-                <a:solidFill>
-                  <a:srgbClr val="1E293B"/>
+            <a:pPr algn="ctr" indent="0" marL="0">
+              <a:buNone/>
+            </a:pPr>
+            <a:r>
+              <a:rPr lang="en-US" sz="1000" i="1" dirty="0">
+                <a:solidFill>
+                  <a:srgbClr val="64748B"/>
                 </a:solidFill>
                 <a:latin typeface="Calibri" pitchFamily="34" charset="0"/>
                 <a:ea typeface="Calibri" pitchFamily="34" charset="-122"/>
                 <a:cs typeface="Calibri" pitchFamily="34" charset="-120"/>
               </a:rPr>
-              <a:t>All queries follow a known grammar; no production traffic, single domain — disclosed as the data's ceiling.</a:t>
-            </a:r>
-            <a:endParaRPr lang="en-US" sz="1050" dirty="0"/>
-          </a:p>
-        </p:txBody>
-      </p:sp>
-      <p:sp>
-        <p:nvSpPr>
-          <p:cNvPr id="18" name="Shape 16"/>
-          <p:cNvSpPr/>
-          <p:nvPr/>
-        </p:nvSpPr>
-        <p:spPr>
-          <a:xfrm>
-            <a:off x="5852160" y="1554480"/>
-            <a:ext cx="2880360" cy="2697480"/>
+              <a:t>Query encoding (~86 ms CPU) dominates routing latency, so exact Flat is the right default; HNSW only cuts search time beyond ~10³ tools, at a recall cost.</a:t>
+            </a:r>
+            <a:endParaRPr lang="en-US" sz="1000" dirty="0"/>
+          </a:p>
+        </p:txBody>
+      </p:sp>
+      <p:sp>
+        <p:nvSpPr>
+          <p:cNvPr id="17" name="Text 14"/>
+          <p:cNvSpPr/>
+          <p:nvPr/>
+        </p:nvSpPr>
+        <p:spPr>
+          <a:xfrm>
+            <a:off x="502920" y="4777740"/>
+            <a:ext cx="6858000" cy="274320"/>
+          </a:xfrm>
+          <a:prstGeom prst="rect">
+            <a:avLst/>
+          </a:prstGeom>
+          <a:noFill/>
+          <a:ln/>
+        </p:spPr>
+        <p:txBody>
+          <a:bodyPr wrap="square" lIns="0" tIns="0" rIns="0" bIns="0" rtlCol="0" anchor="ctr"/>
+          <a:lstStyle/>
+          <a:p>
+            <a:pPr indent="0" marL="0">
+              <a:buNone/>
+            </a:pPr>
+            <a:r>
+              <a:rPr lang="en-US" sz="800" dirty="0">
+                <a:solidFill>
+                  <a:srgbClr val="64748B"/>
+                </a:solidFill>
+                <a:latin typeface="Calibri" pitchFamily="34" charset="0"/>
+                <a:ea typeface="Calibri" pitchFamily="34" charset="-122"/>
+                <a:cs typeface="Calibri" pitchFamily="34" charset="-120"/>
+              </a:rPr>
+              <a:t>ToolFinder — Dense Retrieval for Open-Set MCP Tool Routing</a:t>
+            </a:r>
+            <a:endParaRPr lang="en-US" sz="800" dirty="0"/>
+          </a:p>
+        </p:txBody>
+      </p:sp>
+      <p:sp>
+        <p:nvSpPr>
+          <p:cNvPr id="18" name="Text 15"/>
+          <p:cNvSpPr/>
+          <p:nvPr/>
+        </p:nvSpPr>
+        <p:spPr>
+          <a:xfrm>
+            <a:off x="8321040" y="4777740"/>
+            <a:ext cx="365760" cy="274320"/>
+          </a:xfrm>
+          <a:prstGeom prst="rect">
+            <a:avLst/>
+          </a:prstGeom>
+          <a:noFill/>
+          <a:ln/>
+        </p:spPr>
+        <p:txBody>
+          <a:bodyPr wrap="square" lIns="0" tIns="0" rIns="0" bIns="0" rtlCol="0" anchor="ctr"/>
+          <a:lstStyle/>
+          <a:p>
+            <a:pPr algn="r" indent="0" marL="0">
+              <a:buNone/>
+            </a:pPr>
+            <a:r>
+              <a:rPr lang="en-US" sz="900" dirty="0">
+                <a:solidFill>
+                  <a:srgbClr val="64748B"/>
+                </a:solidFill>
+                <a:latin typeface="Calibri" pitchFamily="34" charset="0"/>
+                <a:ea typeface="Calibri" pitchFamily="34" charset="-122"/>
+                <a:cs typeface="Calibri" pitchFamily="34" charset="-120"/>
+              </a:rPr>
+              <a:t>10</a:t>
+            </a:r>
+            <a:endParaRPr lang="en-US" sz="900" dirty="0"/>
+          </a:p>
+        </p:txBody>
+      </p:sp>
+    </p:spTree>
+  </p:cSld>
+  <p:clrMapOvr>
+    <a:masterClrMapping/>
+  </p:clrMapOvr>
+</p:sld>
+</file>
+
+<file path=ppt/slides/slide11.xml><?xml version="1.0" encoding="utf-8"?>
+<p:sld xmlns:a="http://schemas.openxmlformats.org/drawingml/2006/main" xmlns:r="http://schemas.openxmlformats.org/officeDocument/2006/relationships" xmlns:p="http://schemas.openxmlformats.org/presentationml/2006/main">
+  <p:cSld name="Slide 11">
+    <p:bg>
+      <p:bgPr>
+        <a:solidFill>
+          <a:srgbClr val="F4F6F9"/>
+        </a:solidFill>
+      </p:bgPr>
+    </p:bg>
+    <p:spTree>
+      <p:nvGrpSpPr>
+        <p:cNvPr id="1" name=""/>
+        <p:cNvGrpSpPr/>
+        <p:nvPr/>
+      </p:nvGrpSpPr>
+      <p:grpSpPr>
+        <a:xfrm>
+          <a:off x="0" y="0"/>
+          <a:ext cx="0" cy="0"/>
+          <a:chOff x="0" y="0"/>
+          <a:chExt cx="0" cy="0"/>
+        </a:xfrm>
+      </p:grpSpPr>
+      <p:sp>
+        <p:nvSpPr>
+          <p:cNvPr id="2" name="Shape 0"/>
+          <p:cNvSpPr/>
+          <p:nvPr/>
+        </p:nvSpPr>
+        <p:spPr>
+          <a:xfrm>
+            <a:off x="0" y="0"/>
+            <a:ext cx="146304" cy="5143500"/>
+          </a:xfrm>
+          <a:prstGeom prst="rect">
+            <a:avLst/>
+          </a:prstGeom>
+          <a:solidFill>
+            <a:srgbClr val="4878A8"/>
+          </a:solidFill>
+          <a:ln/>
+        </p:spPr>
+      </p:sp>
+      <p:sp>
+        <p:nvSpPr>
+          <p:cNvPr id="3" name="Shape 1"/>
+          <p:cNvSpPr/>
+          <p:nvPr/>
+        </p:nvSpPr>
+        <p:spPr>
+          <a:xfrm>
+            <a:off x="502920" y="384048"/>
+            <a:ext cx="2080260" cy="310896"/>
+          </a:xfrm>
+          <a:prstGeom prst="roundRect">
+            <a:avLst>
+              <a:gd name="adj" fmla="val 14706"/>
+            </a:avLst>
+          </a:prstGeom>
+          <a:solidFill>
+            <a:srgbClr val="1B2A4A"/>
+          </a:solidFill>
+          <a:ln/>
+        </p:spPr>
+      </p:sp>
+      <p:sp>
+        <p:nvSpPr>
+          <p:cNvPr id="4" name="Text 2"/>
+          <p:cNvSpPr/>
+          <p:nvPr/>
+        </p:nvSpPr>
+        <p:spPr>
+          <a:xfrm>
+            <a:off x="502920" y="384048"/>
+            <a:ext cx="2080260" cy="310896"/>
+          </a:xfrm>
+          <a:prstGeom prst="rect">
+            <a:avLst/>
+          </a:prstGeom>
+          <a:noFill/>
+          <a:ln/>
+        </p:spPr>
+        <p:txBody>
+          <a:bodyPr wrap="square" lIns="0" tIns="0" rIns="0" bIns="0" rtlCol="0" anchor="ctr"/>
+          <a:lstStyle/>
+          <a:p>
+            <a:pPr algn="ctr" indent="0" marL="0">
+              <a:buNone/>
+            </a:pPr>
+            <a:r>
+              <a:rPr lang="en-US" sz="1000" b="1" spc="100" kern="0" dirty="0">
+                <a:solidFill>
+                  <a:srgbClr val="FFFFFF"/>
+                </a:solidFill>
+                <a:latin typeface="Calibri" pitchFamily="34" charset="0"/>
+                <a:ea typeface="Calibri" pitchFamily="34" charset="-122"/>
+                <a:cs typeface="Calibri" pitchFamily="34" charset="-120"/>
+              </a:rPr>
+              <a:t>HONEST FINDINGS</a:t>
+            </a:r>
+            <a:endParaRPr lang="en-US" sz="1000" dirty="0"/>
+          </a:p>
+        </p:txBody>
+      </p:sp>
+      <p:sp>
+        <p:nvSpPr>
+          <p:cNvPr id="5" name="Text 3"/>
+          <p:cNvSpPr/>
+          <p:nvPr/>
+        </p:nvSpPr>
+        <p:spPr>
+          <a:xfrm>
+            <a:off x="475488" y="768096"/>
+            <a:ext cx="8229600" cy="566928"/>
+          </a:xfrm>
+          <a:prstGeom prst="rect">
+            <a:avLst/>
+          </a:prstGeom>
+          <a:noFill/>
+          <a:ln/>
+        </p:spPr>
+        <p:txBody>
+          <a:bodyPr wrap="square" lIns="0" tIns="0" rIns="0" bIns="0" rtlCol="0" anchor="ctr"/>
+          <a:lstStyle/>
+          <a:p>
+            <a:pPr indent="0" marL="0">
+              <a:buNone/>
+            </a:pPr>
+            <a:r>
+              <a:rPr lang="en-US" sz="2600" b="1" dirty="0">
+                <a:solidFill>
+                  <a:srgbClr val="1B2A4A"/>
+                </a:solidFill>
+                <a:latin typeface="Georgia" pitchFamily="34" charset="0"/>
+                <a:ea typeface="Georgia" pitchFamily="34" charset="-122"/>
+                <a:cs typeface="Georgia" pitchFamily="34" charset="-120"/>
+              </a:rPr>
+              <a:t>What did not work — reported, not hidden</a:t>
+            </a:r>
+            <a:endParaRPr lang="en-US" sz="2600" dirty="0"/>
+          </a:p>
+        </p:txBody>
+      </p:sp>
+      <p:sp>
+        <p:nvSpPr>
+          <p:cNvPr id="6" name="Shape 4"/>
+          <p:cNvSpPr/>
+          <p:nvPr/>
+        </p:nvSpPr>
+        <p:spPr>
+          <a:xfrm>
+            <a:off x="640080" y="1554480"/>
+            <a:ext cx="5074920" cy="868680"/>
           </a:xfrm>
           <a:prstGeom prst="rect">
             <a:avLst/>
@@ -2907,6 +3422,396 @@
           </a:effectLst>
         </p:spPr>
       </p:sp>
+      <p:sp>
+        <p:nvSpPr>
+          <p:cNvPr id="7" name="Shape 5"/>
+          <p:cNvSpPr/>
+          <p:nvPr/>
+        </p:nvSpPr>
+        <p:spPr>
+          <a:xfrm>
+            <a:off x="640080" y="1554480"/>
+            <a:ext cx="64008" cy="868680"/>
+          </a:xfrm>
+          <a:prstGeom prst="rect">
+            <a:avLst/>
+          </a:prstGeom>
+          <a:solidFill>
+            <a:srgbClr val="E1812C"/>
+          </a:solidFill>
+          <a:ln/>
+        </p:spPr>
+      </p:sp>
+      <p:sp>
+        <p:nvSpPr>
+          <p:cNvPr id="8" name="Text 6"/>
+          <p:cNvSpPr/>
+          <p:nvPr/>
+        </p:nvSpPr>
+        <p:spPr>
+          <a:xfrm>
+            <a:off x="777240" y="1645920"/>
+            <a:ext cx="4846320" cy="292608"/>
+          </a:xfrm>
+          <a:prstGeom prst="rect">
+            <a:avLst/>
+          </a:prstGeom>
+          <a:noFill/>
+          <a:ln/>
+        </p:spPr>
+        <p:txBody>
+          <a:bodyPr wrap="square" lIns="0" tIns="0" rIns="0" bIns="0" rtlCol="0" anchor="ctr"/>
+          <a:lstStyle/>
+          <a:p>
+            <a:pPr indent="0" marL="0">
+              <a:buNone/>
+            </a:pPr>
+            <a:r>
+              <a:rPr lang="en-US" sz="1400" b="1" dirty="0">
+                <a:solidFill>
+                  <a:srgbClr val="1B2A4A"/>
+                </a:solidFill>
+                <a:latin typeface="Calibri" pitchFamily="34" charset="0"/>
+                <a:ea typeface="Calibri" pitchFamily="34" charset="-122"/>
+                <a:cs typeface="Calibri" pitchFamily="34" charset="-120"/>
+              </a:rPr>
+              <a:t>Reranking hurts</a:t>
+            </a:r>
+            <a:endParaRPr lang="en-US" sz="1400" dirty="0"/>
+          </a:p>
+        </p:txBody>
+      </p:sp>
+      <p:sp>
+        <p:nvSpPr>
+          <p:cNvPr id="9" name="Text 7"/>
+          <p:cNvSpPr/>
+          <p:nvPr/>
+        </p:nvSpPr>
+        <p:spPr>
+          <a:xfrm>
+            <a:off x="777240" y="1938528"/>
+            <a:ext cx="4846320" cy="457200"/>
+          </a:xfrm>
+          <a:prstGeom prst="rect">
+            <a:avLst/>
+          </a:prstGeom>
+          <a:noFill/>
+          <a:ln/>
+        </p:spPr>
+        <p:txBody>
+          <a:bodyPr wrap="square" lIns="0" tIns="0" rIns="0" bIns="0" rtlCol="0" anchor="ctr"/>
+          <a:lstStyle/>
+          <a:p>
+            <a:pPr indent="0" marL="0">
+              <a:buNone/>
+            </a:pPr>
+            <a:r>
+              <a:rPr lang="en-US" sz="1050" dirty="0">
+                <a:solidFill>
+                  <a:srgbClr val="1E293B"/>
+                </a:solidFill>
+                <a:latin typeface="Calibri" pitchFamily="34" charset="0"/>
+                <a:ea typeface="Calibri" pitchFamily="34" charset="-122"/>
+                <a:cs typeface="Calibri" pitchFamily="34" charset="-120"/>
+              </a:rPr>
+              <a:t>Model B degrades Model A (0.944 vs 0.988) at ~140× the per-query cost — a stronger retriever + weaker reranker.</a:t>
+            </a:r>
+            <a:endParaRPr lang="en-US" sz="1050" dirty="0"/>
+          </a:p>
+        </p:txBody>
+      </p:sp>
+      <p:sp>
+        <p:nvSpPr>
+          <p:cNvPr id="10" name="Shape 8"/>
+          <p:cNvSpPr/>
+          <p:nvPr/>
+        </p:nvSpPr>
+        <p:spPr>
+          <a:xfrm>
+            <a:off x="640080" y="2514600"/>
+            <a:ext cx="5074920" cy="868680"/>
+          </a:xfrm>
+          <a:prstGeom prst="rect">
+            <a:avLst/>
+          </a:prstGeom>
+          <a:solidFill>
+            <a:srgbClr val="FFFFFF"/>
+          </a:solidFill>
+          <a:ln w="12700">
+            <a:solidFill>
+              <a:srgbClr val="DCE3EC"/>
+            </a:solidFill>
+            <a:prstDash val="solid"/>
+          </a:ln>
+          <a:effectLst>
+            <a:outerShdw sx="100000" sy="100000" kx="0" ky="0" algn="bl" rotWithShape="0" blurRad="88900" dist="38100" dir="8100000">
+              <a:srgbClr val="000000">
+                <a:alpha val="16000"/>
+              </a:srgbClr>
+            </a:outerShdw>
+          </a:effectLst>
+        </p:spPr>
+      </p:sp>
+      <p:sp>
+        <p:nvSpPr>
+          <p:cNvPr id="11" name="Shape 9"/>
+          <p:cNvSpPr/>
+          <p:nvPr/>
+        </p:nvSpPr>
+        <p:spPr>
+          <a:xfrm>
+            <a:off x="640080" y="2514600"/>
+            <a:ext cx="64008" cy="868680"/>
+          </a:xfrm>
+          <a:prstGeom prst="rect">
+            <a:avLst/>
+          </a:prstGeom>
+          <a:solidFill>
+            <a:srgbClr val="E1812C"/>
+          </a:solidFill>
+          <a:ln/>
+        </p:spPr>
+      </p:sp>
+      <p:sp>
+        <p:nvSpPr>
+          <p:cNvPr id="12" name="Text 10"/>
+          <p:cNvSpPr/>
+          <p:nvPr/>
+        </p:nvSpPr>
+        <p:spPr>
+          <a:xfrm>
+            <a:off x="777240" y="2606040"/>
+            <a:ext cx="4846320" cy="292608"/>
+          </a:xfrm>
+          <a:prstGeom prst="rect">
+            <a:avLst/>
+          </a:prstGeom>
+          <a:noFill/>
+          <a:ln/>
+        </p:spPr>
+        <p:txBody>
+          <a:bodyPr wrap="square" lIns="0" tIns="0" rIns="0" bIns="0" rtlCol="0" anchor="ctr"/>
+          <a:lstStyle/>
+          <a:p>
+            <a:pPr indent="0" marL="0">
+              <a:buNone/>
+            </a:pPr>
+            <a:r>
+              <a:rPr lang="en-US" sz="1400" b="1" dirty="0">
+                <a:solidFill>
+                  <a:srgbClr val="1B2A4A"/>
+                </a:solidFill>
+                <a:latin typeface="Calibri" pitchFamily="34" charset="0"/>
+                <a:ea typeface="Calibri" pitchFamily="34" charset="-122"/>
+                <a:cs typeface="Calibri" pitchFamily="34" charset="-120"/>
+              </a:rPr>
+              <a:t>Default ≠ best</a:t>
+            </a:r>
+            <a:endParaRPr lang="en-US" sz="1400" dirty="0"/>
+          </a:p>
+        </p:txBody>
+      </p:sp>
+      <p:sp>
+        <p:nvSpPr>
+          <p:cNvPr id="13" name="Text 11"/>
+          <p:cNvSpPr/>
+          <p:nvPr/>
+        </p:nvSpPr>
+        <p:spPr>
+          <a:xfrm>
+            <a:off x="777240" y="2898648"/>
+            <a:ext cx="4846320" cy="457200"/>
+          </a:xfrm>
+          <a:prstGeom prst="rect">
+            <a:avLst/>
+          </a:prstGeom>
+          <a:noFill/>
+          <a:ln/>
+        </p:spPr>
+        <p:txBody>
+          <a:bodyPr wrap="square" lIns="0" tIns="0" rIns="0" bIns="0" rtlCol="0" anchor="ctr"/>
+          <a:lstStyle/>
+          <a:p>
+            <a:pPr indent="0" marL="0">
+              <a:buNone/>
+            </a:pPr>
+            <a:r>
+              <a:rPr lang="en-US" sz="1050" dirty="0">
+                <a:solidFill>
+                  <a:srgbClr val="1E293B"/>
+                </a:solidFill>
+                <a:latin typeface="Calibri" pitchFamily="34" charset="0"/>
+                <a:ea typeface="Calibri" pitchFamily="34" charset="-122"/>
+                <a:cs typeface="Calibri" pitchFamily="34" charset="-120"/>
+              </a:rPr>
+              <a:t>The shipped router loads a zero-shot encoder; the fine-tuned weights that win are regenerable but not committed.</a:t>
+            </a:r>
+            <a:endParaRPr lang="en-US" sz="1050" dirty="0"/>
+          </a:p>
+        </p:txBody>
+      </p:sp>
+      <p:sp>
+        <p:nvSpPr>
+          <p:cNvPr id="14" name="Shape 12"/>
+          <p:cNvSpPr/>
+          <p:nvPr/>
+        </p:nvSpPr>
+        <p:spPr>
+          <a:xfrm>
+            <a:off x="640080" y="3474720"/>
+            <a:ext cx="5074920" cy="868680"/>
+          </a:xfrm>
+          <a:prstGeom prst="rect">
+            <a:avLst/>
+          </a:prstGeom>
+          <a:solidFill>
+            <a:srgbClr val="FFFFFF"/>
+          </a:solidFill>
+          <a:ln w="12700">
+            <a:solidFill>
+              <a:srgbClr val="DCE3EC"/>
+            </a:solidFill>
+            <a:prstDash val="solid"/>
+          </a:ln>
+          <a:effectLst>
+            <a:outerShdw sx="100000" sy="100000" kx="0" ky="0" algn="bl" rotWithShape="0" blurRad="88900" dist="38100" dir="8100000">
+              <a:srgbClr val="000000">
+                <a:alpha val="16000"/>
+              </a:srgbClr>
+            </a:outerShdw>
+          </a:effectLst>
+        </p:spPr>
+      </p:sp>
+      <p:sp>
+        <p:nvSpPr>
+          <p:cNvPr id="15" name="Shape 13"/>
+          <p:cNvSpPr/>
+          <p:nvPr/>
+        </p:nvSpPr>
+        <p:spPr>
+          <a:xfrm>
+            <a:off x="640080" y="3474720"/>
+            <a:ext cx="64008" cy="868680"/>
+          </a:xfrm>
+          <a:prstGeom prst="rect">
+            <a:avLst/>
+          </a:prstGeom>
+          <a:solidFill>
+            <a:srgbClr val="E1812C"/>
+          </a:solidFill>
+          <a:ln/>
+        </p:spPr>
+      </p:sp>
+      <p:sp>
+        <p:nvSpPr>
+          <p:cNvPr id="16" name="Text 14"/>
+          <p:cNvSpPr/>
+          <p:nvPr/>
+        </p:nvSpPr>
+        <p:spPr>
+          <a:xfrm>
+            <a:off x="777240" y="3566160"/>
+            <a:ext cx="4846320" cy="292608"/>
+          </a:xfrm>
+          <a:prstGeom prst="rect">
+            <a:avLst/>
+          </a:prstGeom>
+          <a:noFill/>
+          <a:ln/>
+        </p:spPr>
+        <p:txBody>
+          <a:bodyPr wrap="square" lIns="0" tIns="0" rIns="0" bIns="0" rtlCol="0" anchor="ctr"/>
+          <a:lstStyle/>
+          <a:p>
+            <a:pPr indent="0" marL="0">
+              <a:buNone/>
+            </a:pPr>
+            <a:r>
+              <a:rPr lang="en-US" sz="1400" b="1" dirty="0">
+                <a:solidFill>
+                  <a:srgbClr val="1B2A4A"/>
+                </a:solidFill>
+                <a:latin typeface="Calibri" pitchFamily="34" charset="0"/>
+                <a:ea typeface="Calibri" pitchFamily="34" charset="-122"/>
+                <a:cs typeface="Calibri" pitchFamily="34" charset="-120"/>
+              </a:rPr>
+              <a:t>Synthetic data</a:t>
+            </a:r>
+            <a:endParaRPr lang="en-US" sz="1400" dirty="0"/>
+          </a:p>
+        </p:txBody>
+      </p:sp>
+      <p:sp>
+        <p:nvSpPr>
+          <p:cNvPr id="17" name="Text 15"/>
+          <p:cNvSpPr/>
+          <p:nvPr/>
+        </p:nvSpPr>
+        <p:spPr>
+          <a:xfrm>
+            <a:off x="777240" y="3858768"/>
+            <a:ext cx="4846320" cy="457200"/>
+          </a:xfrm>
+          <a:prstGeom prst="rect">
+            <a:avLst/>
+          </a:prstGeom>
+          <a:noFill/>
+          <a:ln/>
+        </p:spPr>
+        <p:txBody>
+          <a:bodyPr wrap="square" lIns="0" tIns="0" rIns="0" bIns="0" rtlCol="0" anchor="ctr"/>
+          <a:lstStyle/>
+          <a:p>
+            <a:pPr indent="0" marL="0">
+              <a:buNone/>
+            </a:pPr>
+            <a:r>
+              <a:rPr lang="en-US" sz="1050" dirty="0">
+                <a:solidFill>
+                  <a:srgbClr val="1E293B"/>
+                </a:solidFill>
+                <a:latin typeface="Calibri" pitchFamily="34" charset="0"/>
+                <a:ea typeface="Calibri" pitchFamily="34" charset="-122"/>
+                <a:cs typeface="Calibri" pitchFamily="34" charset="-120"/>
+              </a:rPr>
+              <a:t>All queries follow a known grammar; no production traffic, single domain — disclosed as the data's ceiling.</a:t>
+            </a:r>
+            <a:endParaRPr lang="en-US" sz="1050" dirty="0"/>
+          </a:p>
+        </p:txBody>
+      </p:sp>
+      <p:sp>
+        <p:nvSpPr>
+          <p:cNvPr id="18" name="Shape 16"/>
+          <p:cNvSpPr/>
+          <p:nvPr/>
+        </p:nvSpPr>
+        <p:spPr>
+          <a:xfrm>
+            <a:off x="5852160" y="1554480"/>
+            <a:ext cx="2880360" cy="2697480"/>
+          </a:xfrm>
+          <a:prstGeom prst="rect">
+            <a:avLst/>
+          </a:prstGeom>
+          <a:solidFill>
+            <a:srgbClr val="FFFFFF"/>
+          </a:solidFill>
+          <a:ln w="12700">
+            <a:solidFill>
+              <a:srgbClr val="DCE3EC"/>
+            </a:solidFill>
+            <a:prstDash val="solid"/>
+          </a:ln>
+          <a:effectLst>
+            <a:outerShdw sx="100000" sy="100000" kx="0" ky="0" algn="bl" rotWithShape="0" blurRad="88900" dist="38100" dir="8100000">
+              <a:srgbClr val="000000">
+                <a:alpha val="16000"/>
+              </a:srgbClr>
+            </a:outerShdw>
+          </a:effectLst>
+        </p:spPr>
+      </p:sp>
       <p:graphicFrame>
         <p:nvGraphicFramePr>
           <p:cNvPr id="19" name="Chart 0" descr=""/>
@@ -3034,7 +3939,7 @@
                 <a:ea typeface="Calibri" pitchFamily="34" charset="-122"/>
                 <a:cs typeface="Calibri" pitchFamily="34" charset="-120"/>
               </a:rPr>
-              <a:t>10</a:t>
+              <a:t>11</a:t>
             </a:r>
             <a:endParaRPr lang="en-US" sz="900" dirty="0"/>
           </a:p>
@@ -3048,9 +3953,9 @@
 </p:sld>
 </file>
 
-<file path=ppt/slides/slide11.xml><?xml version="1.0" encoding="utf-8"?>
+<file path=ppt/slides/slide12.xml><?xml version="1.0" encoding="utf-8"?>
 <p:sld xmlns:a="http://schemas.openxmlformats.org/drawingml/2006/main" xmlns:r="http://schemas.openxmlformats.org/officeDocument/2006/relationships" xmlns:p="http://schemas.openxmlformats.org/presentationml/2006/main">
-  <p:cSld name="Slide 11">
+  <p:cSld name="Slide 12">
     <p:bg>
       <p:bgPr>
         <a:solidFill>
@@ -7413,7 +8318,7 @@
         <p:spPr>
           <a:xfrm>
             <a:off x="502920" y="384048"/>
-            <a:ext cx="1303020" cy="310896"/>
+            <a:ext cx="2313432" cy="310896"/>
           </a:xfrm>
           <a:prstGeom prst="roundRect">
             <a:avLst>
@@ -7435,7 +8340,7 @@
         <p:spPr>
           <a:xfrm>
             <a:off x="502920" y="384048"/>
-            <a:ext cx="1303020" cy="310896"/>
+            <a:ext cx="2313432" cy="310896"/>
           </a:xfrm>
           <a:prstGeom prst="rect">
             <a:avLst/>
@@ -7459,7 +8364,7 @@
                 <a:ea typeface="Calibri" pitchFamily="34" charset="-122"/>
                 <a:cs typeface="Calibri" pitchFamily="34" charset="-120"/>
               </a:rPr>
-              <a:t>RIGOR</a:t>
+              <a:t>THE KEY COMPARISON</a:t>
             </a:r>
             <a:endParaRPr lang="en-US" sz="1000" dirty="0"/>
           </a:p>
@@ -7498,7 +8403,7 @@
                 <a:ea typeface="Georgia" pitchFamily="34" charset="-122"/>
                 <a:cs typeface="Georgia" pitchFamily="34" charset="-120"/>
               </a:rPr>
-              <a:t>The result survives the leakage control</a:t>
+              <a:t>Why route at all? Versus giving the LLM every tool</a:t>
             </a:r>
             <a:endParaRPr lang="en-US" sz="2600" dirty="0"/>
           </a:p>
@@ -7512,8 +8417,8 @@
         </p:nvSpPr>
         <p:spPr>
           <a:xfrm>
-            <a:off x="4242816" y="1898836"/>
-            <a:ext cx="4681728" cy="2054489"/>
+            <a:off x="640080" y="1554480"/>
+            <a:ext cx="3383280" cy="1234440"/>
           </a:xfrm>
           <a:prstGeom prst="rect">
             <a:avLst/>
@@ -7536,40 +8441,114 @@
           </a:effectLst>
         </p:spPr>
       </p:sp>
-      <p:pic>
-        <p:nvPicPr>
-          <p:cNvPr id="7" name="Image 0" descr="C:\Users\dimit\Desktop\GEORGAML\ToolFinder\experiments\results\figures\fig_loss_curves.png">    </p:cNvPr>
-          <p:cNvPicPr>
-            <a:picLocks noChangeAspect="1"/>
-          </p:cNvPicPr>
-          <p:nvPr/>
-        </p:nvPicPr>
-        <p:blipFill>
-          <a:blip r:embed="rId1"/>
-          <a:stretch>
-            <a:fillRect/>
-          </a:stretch>
-        </p:blipFill>
-        <p:spPr>
-          <a:xfrm>
-            <a:off x="4297680" y="1953700"/>
-            <a:ext cx="4572000" cy="1944761"/>
-          </a:xfrm>
-          <a:prstGeom prst="rect">
-            <a:avLst/>
-          </a:prstGeom>
-        </p:spPr>
-      </p:pic>
-      <p:sp>
-        <p:nvSpPr>
-          <p:cNvPr id="8" name="Shape 5"/>
+      <p:sp>
+        <p:nvSpPr>
+          <p:cNvPr id="7" name="Shape 5"/>
           <p:cNvSpPr/>
           <p:nvPr/>
         </p:nvSpPr>
         <p:spPr>
           <a:xfrm>
             <a:off x="640080" y="1554480"/>
-            <a:ext cx="3291840" cy="1234440"/>
+            <a:ext cx="64008" cy="1234440"/>
+          </a:xfrm>
+          <a:prstGeom prst="rect">
+            <a:avLst/>
+          </a:prstGeom>
+          <a:solidFill>
+            <a:srgbClr val="E1812C"/>
+          </a:solidFill>
+          <a:ln/>
+        </p:spPr>
+      </p:sp>
+      <p:sp>
+        <p:nvSpPr>
+          <p:cNvPr id="8" name="Text 6"/>
+          <p:cNvSpPr/>
+          <p:nvPr/>
+        </p:nvSpPr>
+        <p:spPr>
+          <a:xfrm>
+            <a:off x="804672" y="1664208"/>
+            <a:ext cx="3108960" cy="566928"/>
+          </a:xfrm>
+          <a:prstGeom prst="rect">
+            <a:avLst/>
+          </a:prstGeom>
+          <a:noFill/>
+          <a:ln/>
+        </p:spPr>
+        <p:txBody>
+          <a:bodyPr wrap="square" lIns="0" tIns="0" rIns="0" bIns="0" rtlCol="0" anchor="ctr"/>
+          <a:lstStyle/>
+          <a:p>
+            <a:pPr indent="0" marL="0">
+              <a:buNone/>
+            </a:pPr>
+            <a:r>
+              <a:rPr lang="en-US" sz="3000" b="1" dirty="0">
+                <a:solidFill>
+                  <a:srgbClr val="E1812C"/>
+                </a:solidFill>
+                <a:latin typeface="Georgia" pitchFamily="34" charset="0"/>
+                <a:ea typeface="Georgia" pitchFamily="34" charset="-122"/>
+                <a:cs typeface="Georgia" pitchFamily="34" charset="-120"/>
+              </a:rPr>
+              <a:t>0.99 vs 0.17</a:t>
+            </a:r>
+            <a:endParaRPr lang="en-US" sz="3000" dirty="0"/>
+          </a:p>
+        </p:txBody>
+      </p:sp>
+      <p:sp>
+        <p:nvSpPr>
+          <p:cNvPr id="9" name="Text 7"/>
+          <p:cNvSpPr/>
+          <p:nvPr/>
+        </p:nvSpPr>
+        <p:spPr>
+          <a:xfrm>
+            <a:off x="804672" y="2231136"/>
+            <a:ext cx="3108960" cy="457200"/>
+          </a:xfrm>
+          <a:prstGeom prst="rect">
+            <a:avLst/>
+          </a:prstGeom>
+          <a:noFill/>
+          <a:ln/>
+        </p:spPr>
+        <p:txBody>
+          <a:bodyPr wrap="square" lIns="0" tIns="0" rIns="0" bIns="0" rtlCol="0" anchor="t"/>
+          <a:lstStyle/>
+          <a:p>
+            <a:pPr indent="0" marL="0">
+              <a:buNone/>
+            </a:pPr>
+            <a:r>
+              <a:rPr lang="en-US" sz="1100" dirty="0">
+                <a:solidFill>
+                  <a:srgbClr val="1E293B"/>
+                </a:solidFill>
+                <a:latin typeface="Calibri" pitchFamily="34" charset="0"/>
+                <a:ea typeface="Calibri" pitchFamily="34" charset="-122"/>
+                <a:cs typeface="Calibri" pitchFamily="34" charset="-120"/>
+              </a:rPr>
+              <a:t>retrieval router vs llama3.2 reading all tools in-context — same 30-tool test set</a:t>
+            </a:r>
+            <a:endParaRPr lang="en-US" sz="1100" dirty="0"/>
+          </a:p>
+        </p:txBody>
+      </p:sp>
+      <p:sp>
+        <p:nvSpPr>
+          <p:cNvPr id="10" name="Shape 8"/>
+          <p:cNvSpPr/>
+          <p:nvPr/>
+        </p:nvSpPr>
+        <p:spPr>
+          <a:xfrm>
+            <a:off x="640080" y="2907792"/>
+            <a:ext cx="3383280" cy="1234440"/>
           </a:xfrm>
           <a:prstGeom prst="rect">
             <a:avLst/>
@@ -7594,13 +8573,13 @@
       </p:sp>
       <p:sp>
         <p:nvSpPr>
-          <p:cNvPr id="9" name="Shape 6"/>
-          <p:cNvSpPr/>
-          <p:nvPr/>
-        </p:nvSpPr>
-        <p:spPr>
-          <a:xfrm>
-            <a:off x="640080" y="1554480"/>
+          <p:cNvPr id="11" name="Shape 9"/>
+          <p:cNvSpPr/>
+          <p:nvPr/>
+        </p:nvSpPr>
+        <p:spPr>
+          <a:xfrm>
+            <a:off x="640080" y="2907792"/>
             <a:ext cx="64008" cy="1234440"/>
           </a:xfrm>
           <a:prstGeom prst="rect">
@@ -7614,14 +8593,14 @@
       </p:sp>
       <p:sp>
         <p:nvSpPr>
-          <p:cNvPr id="10" name="Text 7"/>
-          <p:cNvSpPr/>
-          <p:nvPr/>
-        </p:nvSpPr>
-        <p:spPr>
-          <a:xfrm>
-            <a:off x="804672" y="1664208"/>
-            <a:ext cx="3017520" cy="566928"/>
+          <p:cNvPr id="12" name="Text 10"/>
+          <p:cNvSpPr/>
+          <p:nvPr/>
+        </p:nvSpPr>
+        <p:spPr>
+          <a:xfrm>
+            <a:off x="804672" y="3017520"/>
+            <a:ext cx="3108960" cy="566928"/>
           </a:xfrm>
           <a:prstGeom prst="rect">
             <a:avLst/>
@@ -7645,7 +8624,7 @@
                 <a:ea typeface="Georgia" pitchFamily="34" charset="-122"/>
                 <a:cs typeface="Georgia" pitchFamily="34" charset="-120"/>
               </a:rPr>
-              <a:t>0.958 vs 0.650</a:t>
+              <a:t>1.0 → 4.6 s</a:t>
             </a:r>
             <a:endParaRPr lang="en-US" sz="3000" dirty="0"/>
           </a:p>
@@ -7653,14 +8632,14 @@
       </p:sp>
       <p:sp>
         <p:nvSpPr>
-          <p:cNvPr id="11" name="Text 8"/>
-          <p:cNvSpPr/>
-          <p:nvPr/>
-        </p:nvSpPr>
-        <p:spPr>
-          <a:xfrm>
-            <a:off x="804672" y="2231136"/>
-            <a:ext cx="3017520" cy="457200"/>
+          <p:cNvPr id="13" name="Text 11"/>
+          <p:cNvSpPr/>
+          <p:nvPr/>
+        </p:nvSpPr>
+        <p:spPr>
+          <a:xfrm>
+            <a:off x="804672" y="3584448"/>
+            <a:ext cx="3108960" cy="457200"/>
           </a:xfrm>
           <a:prstGeom prst="rect">
             <a:avLst/>
@@ -7684,7 +8663,7 @@
                 <a:ea typeface="Calibri" pitchFamily="34" charset="-122"/>
                 <a:cs typeface="Calibri" pitchFamily="34" charset="-120"/>
               </a:rPr>
-              <a:t>FT MiniLM vs 1-NN leakage probe on the template-disjoint split</a:t>
+              <a:t>LLM time per query as the catalog grows 5→30 tools (router: ~0.5 ms, and flat)</a:t>
             </a:r>
             <a:endParaRPr lang="en-US" sz="1100" dirty="0"/>
           </a:p>
@@ -7692,132 +8671,124 @@
       </p:sp>
       <p:sp>
         <p:nvSpPr>
-          <p:cNvPr id="12" name="Text 9"/>
-          <p:cNvSpPr/>
-          <p:nvPr/>
-        </p:nvSpPr>
-        <p:spPr>
-          <a:xfrm>
-            <a:off x="640080" y="2926080"/>
-            <a:ext cx="3383280" cy="1371600"/>
-          </a:xfrm>
-          <a:prstGeom prst="rect">
-            <a:avLst/>
-          </a:prstGeom>
-          <a:noFill/>
-          <a:ln/>
-        </p:spPr>
-        <p:txBody>
-          <a:bodyPr wrap="square" lIns="0" tIns="0" rIns="0" bIns="0" rtlCol="0" anchor="t"/>
-          <a:lstStyle/>
-          <a:p>
-            <a:pPr indent="0" marL="0">
-              <a:buNone/>
-            </a:pPr>
-            <a:r>
-              <a:rPr lang="en-US" sz="1300" dirty="0">
-                <a:solidFill>
-                  <a:srgbClr val="1E293B"/>
+          <p:cNvPr id="14" name="Shape 12"/>
+          <p:cNvSpPr/>
+          <p:nvPr/>
+        </p:nvSpPr>
+        <p:spPr>
+          <a:xfrm>
+            <a:off x="5852160" y="1554480"/>
+            <a:ext cx="2880360" cy="2697480"/>
+          </a:xfrm>
+          <a:prstGeom prst="rect">
+            <a:avLst/>
+          </a:prstGeom>
+          <a:solidFill>
+            <a:srgbClr val="FFFFFF"/>
+          </a:solidFill>
+          <a:ln w="12700">
+            <a:solidFill>
+              <a:srgbClr val="DCE3EC"/>
+            </a:solidFill>
+            <a:prstDash val="solid"/>
+          </a:ln>
+          <a:effectLst>
+            <a:outerShdw sx="100000" sy="100000" kx="0" ky="0" algn="bl" rotWithShape="0" blurRad="88900" dist="38100" dir="8100000">
+              <a:srgbClr val="000000">
+                <a:alpha val="16000"/>
+              </a:srgbClr>
+            </a:outerShdw>
+          </a:effectLst>
+        </p:spPr>
+      </p:sp>
+      <p:graphicFrame>
+        <p:nvGraphicFramePr>
+          <p:cNvPr id="15" name="Chart 0" descr=""/>
+          <p:cNvGraphicFramePr/>
+          <p:nvPr/>
+        </p:nvGraphicFramePr>
+        <p:xfrm>
+          <a:off x="5943600" y="1664208"/>
+          <a:ext cx="2697480" cy="2331720"/>
+        </p:xfrm>
+        <a:graphic xmlns:a="http://schemas.openxmlformats.org/drawingml/2006/main">
+          <a:graphicData uri="http://schemas.openxmlformats.org/drawingml/2006/chart">
+            <c:chart xmlns:c="http://schemas.openxmlformats.org/drawingml/2006/chart" r:id="rId1"/>
+          </a:graphicData>
+        </a:graphic>
+      </p:graphicFrame>
+      <p:sp>
+        <p:nvSpPr>
+          <p:cNvPr id="16" name="Text 13"/>
+          <p:cNvSpPr/>
+          <p:nvPr/>
+        </p:nvSpPr>
+        <p:spPr>
+          <a:xfrm>
+            <a:off x="5852160" y="4261104"/>
+            <a:ext cx="2880360" cy="457200"/>
+          </a:xfrm>
+          <a:prstGeom prst="rect">
+            <a:avLst/>
+          </a:prstGeom>
+          <a:noFill/>
+          <a:ln/>
+        </p:spPr>
+        <p:txBody>
+          <a:bodyPr wrap="square" lIns="0" tIns="0" rIns="0" bIns="0" rtlCol="0" anchor="ctr"/>
+          <a:lstStyle/>
+          <a:p>
+            <a:pPr algn="ctr" indent="0" marL="0">
+              <a:buNone/>
+            </a:pPr>
+            <a:r>
+              <a:rPr lang="en-US" sz="950" i="1" dirty="0">
+                <a:solidFill>
+                  <a:srgbClr val="64748B"/>
                 </a:solidFill>
                 <a:latin typeface="Calibri" pitchFamily="34" charset="0"/>
                 <a:ea typeface="Calibri" pitchFamily="34" charset="-122"/>
                 <a:cs typeface="Calibri" pitchFamily="34" charset="-120"/>
               </a:rPr>
-              <a:t>Regime 1's 1.000 was an in-grammar upper bound. </a:t>
-            </a:r>
-            <a:endParaRPr lang="en-US" sz="1300" dirty="0"/>
-          </a:p>
+              <a:t>Giving the model the whole catalog gets worse AND slower as it grows; retrieval stays accurate and fast — the case for separating selection from execution.</a:t>
+            </a:r>
+            <a:endParaRPr lang="en-US" sz="950" dirty="0"/>
+          </a:p>
+        </p:txBody>
+      </p:sp>
+      <p:sp>
+        <p:nvSpPr>
+          <p:cNvPr id="17" name="Text 14"/>
+          <p:cNvSpPr/>
+          <p:nvPr/>
+        </p:nvSpPr>
+        <p:spPr>
+          <a:xfrm>
+            <a:off x="502920" y="4777740"/>
+            <a:ext cx="6858000" cy="274320"/>
+          </a:xfrm>
+          <a:prstGeom prst="rect">
+            <a:avLst/>
+          </a:prstGeom>
+          <a:noFill/>
+          <a:ln/>
+        </p:spPr>
+        <p:txBody>
+          <a:bodyPr wrap="square" lIns="0" tIns="0" rIns="0" bIns="0" rtlCol="0" anchor="ctr"/>
+          <a:lstStyle/>
           <a:p>
             <a:pPr indent="0" marL="0">
               <a:buNone/>
             </a:pPr>
             <a:r>
-              <a:rPr lang="en-US" sz="1300" dirty="0">
-                <a:solidFill>
-                  <a:srgbClr val="1E293B"/>
+              <a:rPr lang="en-US" sz="800" dirty="0">
+                <a:solidFill>
+                  <a:srgbClr val="64748B"/>
                 </a:solidFill>
                 <a:latin typeface="Calibri" pitchFamily="34" charset="0"/>
                 <a:ea typeface="Calibri" pitchFamily="34" charset="-122"/>
                 <a:cs typeface="Calibri" pitchFamily="34" charset="-120"/>
               </a:rPr>
-              <a:t>Retraining on regime 1b (templates + scenarios both unseen) still gives 0.958 — the win is real, not leaked.</a:t>
-            </a:r>
-            <a:endParaRPr lang="en-US" sz="1300" dirty="0"/>
-          </a:p>
-        </p:txBody>
-      </p:sp>
-      <p:sp>
-        <p:nvSpPr>
-          <p:cNvPr id="13" name="Text 10"/>
-          <p:cNvSpPr/>
-          <p:nvPr/>
-        </p:nvSpPr>
-        <p:spPr>
-          <a:xfrm>
-            <a:off x="4297680" y="4160520"/>
-            <a:ext cx="4572000" cy="365760"/>
-          </a:xfrm>
-          <a:prstGeom prst="rect">
-            <a:avLst/>
-          </a:prstGeom>
-          <a:noFill/>
-          <a:ln/>
-        </p:spPr>
-        <p:txBody>
-          <a:bodyPr wrap="square" lIns="0" tIns="0" rIns="0" bIns="0" rtlCol="0" anchor="ctr"/>
-          <a:lstStyle/>
-          <a:p>
-            <a:pPr algn="ctr" indent="0" marL="0">
-              <a:buNone/>
-            </a:pPr>
-            <a:r>
-              <a:rPr lang="en-US" sz="1000" i="1" dirty="0">
-                <a:solidFill>
-                  <a:srgbClr val="64748B"/>
-                </a:solidFill>
-                <a:latin typeface="Calibri" pitchFamily="34" charset="0"/>
-                <a:ea typeface="Calibri" pitchFamily="34" charset="-122"/>
-                <a:cs typeface="Calibri" pitchFamily="34" charset="-120"/>
-              </a:rPr>
-              <a:t>Loss converges in 3–5 epochs; validation MRR tracks it — no overfitting.</a:t>
-            </a:r>
-            <a:endParaRPr lang="en-US" sz="1000" dirty="0"/>
-          </a:p>
-        </p:txBody>
-      </p:sp>
-      <p:sp>
-        <p:nvSpPr>
-          <p:cNvPr id="14" name="Text 11"/>
-          <p:cNvSpPr/>
-          <p:nvPr/>
-        </p:nvSpPr>
-        <p:spPr>
-          <a:xfrm>
-            <a:off x="502920" y="4777740"/>
-            <a:ext cx="6858000" cy="274320"/>
-          </a:xfrm>
-          <a:prstGeom prst="rect">
-            <a:avLst/>
-          </a:prstGeom>
-          <a:noFill/>
-          <a:ln/>
-        </p:spPr>
-        <p:txBody>
-          <a:bodyPr wrap="square" lIns="0" tIns="0" rIns="0" bIns="0" rtlCol="0" anchor="ctr"/>
-          <a:lstStyle/>
-          <a:p>
-            <a:pPr indent="0" marL="0">
-              <a:buNone/>
-            </a:pPr>
-            <a:r>
-              <a:rPr lang="en-US" sz="800" dirty="0">
-                <a:solidFill>
-                  <a:srgbClr val="64748B"/>
-                </a:solidFill>
-                <a:latin typeface="Calibri" pitchFamily="34" charset="0"/>
-                <a:ea typeface="Calibri" pitchFamily="34" charset="-122"/>
-                <a:cs typeface="Calibri" pitchFamily="34" charset="-120"/>
-              </a:rPr>
               <a:t>ToolFinder — Dense Retrieval for Open-Set MCP Tool Routing</a:t>
             </a:r>
             <a:endParaRPr lang="en-US" sz="800" dirty="0"/>
@@ -7826,7 +8797,7 @@
       </p:sp>
       <p:sp>
         <p:nvSpPr>
-          <p:cNvPr id="15" name="Text 12"/>
+          <p:cNvPr id="18" name="Text 15"/>
           <p:cNvSpPr/>
           <p:nvPr/>
         </p:nvSpPr>
@@ -7924,7 +8895,7 @@
         <p:spPr>
           <a:xfrm>
             <a:off x="502920" y="384048"/>
-            <a:ext cx="2157984" cy="310896"/>
+            <a:ext cx="1303020" cy="310896"/>
           </a:xfrm>
           <a:prstGeom prst="roundRect">
             <a:avLst>
@@ -7946,7 +8917,7 @@
         <p:spPr>
           <a:xfrm>
             <a:off x="502920" y="384048"/>
-            <a:ext cx="2157984" cy="310896"/>
+            <a:ext cx="1303020" cy="310896"/>
           </a:xfrm>
           <a:prstGeom prst="rect">
             <a:avLst/>
@@ -7970,7 +8941,7 @@
                 <a:ea typeface="Calibri" pitchFamily="34" charset="-122"/>
                 <a:cs typeface="Calibri" pitchFamily="34" charset="-120"/>
               </a:rPr>
-              <a:t>SAFETY &amp; SYSTEMS</a:t>
+              <a:t>RIGOR</a:t>
             </a:r>
             <a:endParaRPr lang="en-US" sz="1000" dirty="0"/>
           </a:p>
@@ -8009,7 +8980,7 @@
                 <a:ea typeface="Georgia" pitchFamily="34" charset="-122"/>
                 <a:cs typeface="Georgia" pitchFamily="34" charset="-120"/>
               </a:rPr>
-              <a:t>Rejection, robustness, and the right index</a:t>
+              <a:t>The result survives the leakage control</a:t>
             </a:r>
             <a:endParaRPr lang="en-US" sz="2600" dirty="0"/>
           </a:p>
@@ -8023,8 +8994,8 @@
         </p:nvSpPr>
         <p:spPr>
           <a:xfrm>
-            <a:off x="4288536" y="1910439"/>
-            <a:ext cx="4636008" cy="1985562"/>
+            <a:off x="4242816" y="1898836"/>
+            <a:ext cx="4681728" cy="2054489"/>
           </a:xfrm>
           <a:prstGeom prst="rect">
             <a:avLst/>
@@ -8049,7 +9020,7 @@
       </p:sp>
       <p:pic>
         <p:nvPicPr>
-          <p:cNvPr id="7" name="Image 0" descr="C:\Users\dimit\Desktop\GEORGAML\ToolFinder\experiments\results\figures\fig_scaling.png">    </p:cNvPr>
+          <p:cNvPr id="7" name="Image 0" descr="C:\Users\dimit\Desktop\GEORGAML\ToolFinder\experiments\results\figures\fig_loss_curves.png">    </p:cNvPr>
           <p:cNvPicPr>
             <a:picLocks noChangeAspect="1"/>
           </p:cNvPicPr>
@@ -8063,8 +9034,8 @@
         </p:blipFill>
         <p:spPr>
           <a:xfrm>
-            <a:off x="4343400" y="1965303"/>
-            <a:ext cx="4526280" cy="1875834"/>
+            <a:off x="4297680" y="1953700"/>
+            <a:ext cx="4572000" cy="1944761"/>
           </a:xfrm>
           <a:prstGeom prst="rect">
             <a:avLst/>
@@ -8079,8 +9050,8 @@
         </p:nvSpPr>
         <p:spPr>
           <a:xfrm>
-            <a:off x="640080" y="1508760"/>
-            <a:ext cx="3383280" cy="1234440"/>
+            <a:off x="640080" y="1554480"/>
+            <a:ext cx="3291840" cy="1234440"/>
           </a:xfrm>
           <a:prstGeom prst="rect">
             <a:avLst/>
@@ -8111,7 +9082,7 @@
         </p:nvSpPr>
         <p:spPr>
           <a:xfrm>
-            <a:off x="640080" y="1508760"/>
+            <a:off x="640080" y="1554480"/>
             <a:ext cx="64008" cy="1234440"/>
           </a:xfrm>
           <a:prstGeom prst="rect">
@@ -8131,8 +9102,8 @@
         </p:nvSpPr>
         <p:spPr>
           <a:xfrm>
-            <a:off x="804672" y="1618488"/>
-            <a:ext cx="3108960" cy="566928"/>
+            <a:off x="804672" y="1664208"/>
+            <a:ext cx="3017520" cy="566928"/>
           </a:xfrm>
           <a:prstGeom prst="rect">
             <a:avLst/>
@@ -8156,7 +9127,7 @@
                 <a:ea typeface="Georgia" pitchFamily="34" charset="-122"/>
                 <a:cs typeface="Georgia" pitchFamily="34" charset="-120"/>
               </a:rPr>
-              <a:t>0.99 ROC-AUC</a:t>
+              <a:t>0.958 vs 0.650</a:t>
             </a:r>
             <a:endParaRPr lang="en-US" sz="3000" dirty="0"/>
           </a:p>
@@ -8170,8 +9141,8 @@
         </p:nvSpPr>
         <p:spPr>
           <a:xfrm>
-            <a:off x="804672" y="2185416"/>
-            <a:ext cx="3108960" cy="457200"/>
+            <a:off x="804672" y="2231136"/>
+            <a:ext cx="3017520" cy="457200"/>
           </a:xfrm>
           <a:prstGeom prst="rect">
             <a:avLst/>
@@ -8195,7 +9166,7 @@
                 <a:ea typeface="Calibri" pitchFamily="34" charset="-122"/>
                 <a:cs typeface="Calibri" pitchFamily="34" charset="-120"/>
               </a:rPr>
-              <a:t>out-of-scope rejection (fine-tuned encoder)</a:t>
+              <a:t>FT MiniLM vs 1-NN leakage probe on the template-disjoint split</a:t>
             </a:r>
             <a:endParaRPr lang="en-US" sz="1100" dirty="0"/>
           </a:p>
@@ -8203,121 +9174,30 @@
       </p:sp>
       <p:sp>
         <p:nvSpPr>
-          <p:cNvPr id="12" name="Shape 9"/>
-          <p:cNvSpPr/>
-          <p:nvPr/>
-        </p:nvSpPr>
-        <p:spPr>
-          <a:xfrm>
-            <a:off x="640080" y="2852928"/>
-            <a:ext cx="3383280" cy="1234440"/>
-          </a:xfrm>
-          <a:prstGeom prst="rect">
-            <a:avLst/>
-          </a:prstGeom>
-          <a:solidFill>
-            <a:srgbClr val="FFFFFF"/>
-          </a:solidFill>
-          <a:ln w="12700">
-            <a:solidFill>
-              <a:srgbClr val="DCE3EC"/>
-            </a:solidFill>
-            <a:prstDash val="solid"/>
-          </a:ln>
-          <a:effectLst>
-            <a:outerShdw sx="100000" sy="100000" kx="0" ky="0" algn="bl" rotWithShape="0" blurRad="88900" dist="38100" dir="8100000">
-              <a:srgbClr val="000000">
-                <a:alpha val="16000"/>
-              </a:srgbClr>
-            </a:outerShdw>
-          </a:effectLst>
-        </p:spPr>
-      </p:sp>
-      <p:sp>
-        <p:nvSpPr>
-          <p:cNvPr id="13" name="Shape 10"/>
-          <p:cNvSpPr/>
-          <p:nvPr/>
-        </p:nvSpPr>
-        <p:spPr>
-          <a:xfrm>
-            <a:off x="640080" y="2852928"/>
-            <a:ext cx="64008" cy="1234440"/>
-          </a:xfrm>
-          <a:prstGeom prst="rect">
-            <a:avLst/>
-          </a:prstGeom>
-          <a:solidFill>
-            <a:srgbClr val="E1812C"/>
-          </a:solidFill>
-          <a:ln/>
-        </p:spPr>
-      </p:sp>
-      <p:sp>
-        <p:nvSpPr>
-          <p:cNvPr id="14" name="Text 11"/>
-          <p:cNvSpPr/>
-          <p:nvPr/>
-        </p:nvSpPr>
-        <p:spPr>
-          <a:xfrm>
-            <a:off x="804672" y="2962656"/>
-            <a:ext cx="3108960" cy="566928"/>
-          </a:xfrm>
-          <a:prstGeom prst="rect">
-            <a:avLst/>
-          </a:prstGeom>
-          <a:noFill/>
-          <a:ln/>
-        </p:spPr>
-        <p:txBody>
-          <a:bodyPr wrap="square" lIns="0" tIns="0" rIns="0" bIns="0" rtlCol="0" anchor="ctr"/>
+          <p:cNvPr id="12" name="Text 9"/>
+          <p:cNvSpPr/>
+          <p:nvPr/>
+        </p:nvSpPr>
+        <p:spPr>
+          <a:xfrm>
+            <a:off x="640080" y="2926080"/>
+            <a:ext cx="3383280" cy="1371600"/>
+          </a:xfrm>
+          <a:prstGeom prst="rect">
+            <a:avLst/>
+          </a:prstGeom>
+          <a:noFill/>
+          <a:ln/>
+        </p:spPr>
+        <p:txBody>
+          <a:bodyPr wrap="square" lIns="0" tIns="0" rIns="0" bIns="0" rtlCol="0" anchor="t"/>
           <a:lstStyle/>
           <a:p>
             <a:pPr indent="0" marL="0">
               <a:buNone/>
             </a:pPr>
             <a:r>
-              <a:rPr lang="en-US" sz="3000" b="1" dirty="0">
-                <a:solidFill>
-                  <a:srgbClr val="E1812C"/>
-                </a:solidFill>
-                <a:latin typeface="Georgia" pitchFamily="34" charset="0"/>
-                <a:ea typeface="Georgia" pitchFamily="34" charset="-122"/>
-                <a:cs typeface="Georgia" pitchFamily="34" charset="-120"/>
-              </a:rPr>
-              <a:t>0% vs 83%</a:t>
-            </a:r>
-            <a:endParaRPr lang="en-US" sz="3000" dirty="0"/>
-          </a:p>
-        </p:txBody>
-      </p:sp>
-      <p:sp>
-        <p:nvSpPr>
-          <p:cNvPr id="15" name="Text 12"/>
-          <p:cNvSpPr/>
-          <p:nvPr/>
-        </p:nvSpPr>
-        <p:spPr>
-          <a:xfrm>
-            <a:off x="804672" y="3529584"/>
-            <a:ext cx="3108960" cy="457200"/>
-          </a:xfrm>
-          <a:prstGeom prst="rect">
-            <a:avLst/>
-          </a:prstGeom>
-          <a:noFill/>
-          <a:ln/>
-        </p:spPr>
-        <p:txBody>
-          <a:bodyPr wrap="square" lIns="0" tIns="0" rIns="0" bIns="0" rtlCol="0" anchor="t"/>
-          <a:lstStyle/>
-          <a:p>
-            <a:pPr indent="0" marL="0">
-              <a:buNone/>
-            </a:pPr>
-            <a:r>
-              <a:rPr lang="en-US" sz="1100" dirty="0">
+              <a:rPr lang="en-US" sz="1300" dirty="0">
                 <a:solidFill>
                   <a:srgbClr val="1E293B"/>
                 </a:solidFill>
@@ -8325,61 +9205,39 @@
                 <a:ea typeface="Calibri" pitchFamily="34" charset="-122"/>
                 <a:cs typeface="Calibri" pitchFamily="34" charset="-120"/>
               </a:rPr>
-              <a:t>poisoning hijack: fine-tuned vs BM25 (fine-tuning is the defense)</a:t>
-            </a:r>
-            <a:endParaRPr lang="en-US" sz="1100" dirty="0"/>
-          </a:p>
-        </p:txBody>
-      </p:sp>
-      <p:sp>
-        <p:nvSpPr>
-          <p:cNvPr id="16" name="Text 13"/>
-          <p:cNvSpPr/>
-          <p:nvPr/>
-        </p:nvSpPr>
-        <p:spPr>
-          <a:xfrm>
-            <a:off x="4343400" y="4114800"/>
-            <a:ext cx="4526280" cy="548640"/>
-          </a:xfrm>
-          <a:prstGeom prst="rect">
-            <a:avLst/>
-          </a:prstGeom>
-          <a:noFill/>
-          <a:ln/>
-        </p:spPr>
-        <p:txBody>
-          <a:bodyPr wrap="square" lIns="0" tIns="0" rIns="0" bIns="0" rtlCol="0" anchor="ctr"/>
-          <a:lstStyle/>
-          <a:p>
-            <a:pPr algn="ctr" indent="0" marL="0">
-              <a:buNone/>
-            </a:pPr>
-            <a:r>
-              <a:rPr lang="en-US" sz="1000" i="1" dirty="0">
-                <a:solidFill>
-                  <a:srgbClr val="64748B"/>
+              <a:t>Regime 1's 1.000 was an in-grammar upper bound. </a:t>
+            </a:r>
+            <a:endParaRPr lang="en-US" sz="1300" dirty="0"/>
+          </a:p>
+          <a:p>
+            <a:pPr indent="0" marL="0">
+              <a:buNone/>
+            </a:pPr>
+            <a:r>
+              <a:rPr lang="en-US" sz="1300" dirty="0">
+                <a:solidFill>
+                  <a:srgbClr val="1E293B"/>
                 </a:solidFill>
                 <a:latin typeface="Calibri" pitchFamily="34" charset="0"/>
                 <a:ea typeface="Calibri" pitchFamily="34" charset="-122"/>
                 <a:cs typeface="Calibri" pitchFamily="34" charset="-120"/>
               </a:rPr>
-              <a:t>Query encoding (~86 ms CPU) dominates routing latency, so exact Flat is the right default; HNSW only cuts search time beyond ~10³ tools, at a recall cost.</a:t>
-            </a:r>
-            <a:endParaRPr lang="en-US" sz="1000" dirty="0"/>
-          </a:p>
-        </p:txBody>
-      </p:sp>
-      <p:sp>
-        <p:nvSpPr>
-          <p:cNvPr id="17" name="Text 14"/>
-          <p:cNvSpPr/>
-          <p:nvPr/>
-        </p:nvSpPr>
-        <p:spPr>
-          <a:xfrm>
-            <a:off x="502920" y="4777740"/>
-            <a:ext cx="6858000" cy="274320"/>
+              <a:t>Retraining on regime 1b (templates + scenarios both unseen) still gives 0.958 — the win is real, not leaked.</a:t>
+            </a:r>
+            <a:endParaRPr lang="en-US" sz="1300" dirty="0"/>
+          </a:p>
+        </p:txBody>
+      </p:sp>
+      <p:sp>
+        <p:nvSpPr>
+          <p:cNvPr id="13" name="Text 10"/>
+          <p:cNvSpPr/>
+          <p:nvPr/>
+        </p:nvSpPr>
+        <p:spPr>
+          <a:xfrm>
+            <a:off x="4297680" y="4160520"/>
+            <a:ext cx="4572000" cy="365760"/>
           </a:xfrm>
           <a:prstGeom prst="rect">
             <a:avLst/>
@@ -8391,11 +9249,11 @@
           <a:bodyPr wrap="square" lIns="0" tIns="0" rIns="0" bIns="0" rtlCol="0" anchor="ctr"/>
           <a:lstStyle/>
           <a:p>
-            <a:pPr indent="0" marL="0">
-              <a:buNone/>
-            </a:pPr>
-            <a:r>
-              <a:rPr lang="en-US" sz="800" dirty="0">
+            <a:pPr algn="ctr" indent="0" marL="0">
+              <a:buNone/>
+            </a:pPr>
+            <a:r>
+              <a:rPr lang="en-US" sz="1000" i="1" dirty="0">
                 <a:solidFill>
                   <a:srgbClr val="64748B"/>
                 </a:solidFill>
@@ -8403,6 +9261,45 @@
                 <a:ea typeface="Calibri" pitchFamily="34" charset="-122"/>
                 <a:cs typeface="Calibri" pitchFamily="34" charset="-120"/>
               </a:rPr>
+              <a:t>Loss converges in 3–5 epochs; validation MRR tracks it — no overfitting.</a:t>
+            </a:r>
+            <a:endParaRPr lang="en-US" sz="1000" dirty="0"/>
+          </a:p>
+        </p:txBody>
+      </p:sp>
+      <p:sp>
+        <p:nvSpPr>
+          <p:cNvPr id="14" name="Text 11"/>
+          <p:cNvSpPr/>
+          <p:nvPr/>
+        </p:nvSpPr>
+        <p:spPr>
+          <a:xfrm>
+            <a:off x="502920" y="4777740"/>
+            <a:ext cx="6858000" cy="274320"/>
+          </a:xfrm>
+          <a:prstGeom prst="rect">
+            <a:avLst/>
+          </a:prstGeom>
+          <a:noFill/>
+          <a:ln/>
+        </p:spPr>
+        <p:txBody>
+          <a:bodyPr wrap="square" lIns="0" tIns="0" rIns="0" bIns="0" rtlCol="0" anchor="ctr"/>
+          <a:lstStyle/>
+          <a:p>
+            <a:pPr indent="0" marL="0">
+              <a:buNone/>
+            </a:pPr>
+            <a:r>
+              <a:rPr lang="en-US" sz="800" dirty="0">
+                <a:solidFill>
+                  <a:srgbClr val="64748B"/>
+                </a:solidFill>
+                <a:latin typeface="Calibri" pitchFamily="34" charset="0"/>
+                <a:ea typeface="Calibri" pitchFamily="34" charset="-122"/>
+                <a:cs typeface="Calibri" pitchFamily="34" charset="-120"/>
+              </a:rPr>
               <a:t>ToolFinder — Dense Retrieval for Open-Set MCP Tool Routing</a:t>
             </a:r>
             <a:endParaRPr lang="en-US" sz="800" dirty="0"/>
@@ -8411,7 +9308,7 @@
       </p:sp>
       <p:sp>
         <p:nvSpPr>
-          <p:cNvPr id="18" name="Text 15"/>
+          <p:cNvPr id="15" name="Text 12"/>
           <p:cNvSpPr/>
           <p:nvPr/>
         </p:nvSpPr>

</xml_diff>

<commit_message>
Update ToolFinder presentation with latest findings and enhancements
</commit_message>
<xml_diff>
--- a/reports/ToolFinder_presentation.pptx
+++ b/reports/ToolFinder_presentation.pptx
@@ -4,6 +4,9 @@
   <p:sldMasterIdLst>
     <p:sldMasterId id="2147483648" r:id="rId1"/>
   </p:sldMasterIdLst>
+  <p:notesMasterIdLst>
+    <p:notesMasterId r:id="rId14"/>
+  </p:notesMasterIdLst>
   <p:sldIdLst>
     <p:sldId id="256" r:id="rId2"/>
     <p:sldId id="257" r:id="rId3"/>
@@ -18,10 +21,7 @@
     <p:sldId id="266" r:id="rId12"/>
     <p:sldId id="267" r:id="rId13"/>
   </p:sldIdLst>
-  <p:notesMasterIdLst>
-    <p:notesMasterId r:id="rId14"/>
-  </p:notesMasterIdLst>
-  <p:sldSz cx="9144000" cy="5143500"/>
+  <p:sldSz cx="9144000" cy="5143500" type="screen16x9"/>
   <p:notesSz cx="5143500" cy="9144000"/>
   <p:defaultTextStyle>
     <a:lvl1pPr marL="0" algn="l" defTabSz="914400" rtl="0" eaLnBrk="1" latinLnBrk="0" hangingPunct="1">
@@ -115,13 +115,20 @@
       </a:defRPr>
     </a:lvl9pPr>
   </p:defaultTextStyle>
+  <p:extLst>
+    <p:ext uri="{EFAFB233-063F-42B5-8137-9DF3F51BA10A}">
+      <p15:sldGuideLst xmlns:p15="http://schemas.microsoft.com/office/powerpoint/2012/main"/>
+    </p:ext>
+  </p:extLst>
 </p:presentation>
 </file>
 
 <file path=ppt/charts/chart1.xml><?xml version="1.0" encoding="utf-8"?>
-<c:chartSpace xmlns:c="http://schemas.openxmlformats.org/drawingml/2006/chart" xmlns:a="http://schemas.openxmlformats.org/drawingml/2006/main" xmlns:r="http://schemas.openxmlformats.org/officeDocument/2006/relationships">
+<c:chartSpace xmlns:c="http://schemas.openxmlformats.org/drawingml/2006/chart" xmlns:a="http://schemas.openxmlformats.org/drawingml/2006/main" xmlns:r="http://schemas.openxmlformats.org/officeDocument/2006/relationships" xmlns:c16r2="http://schemas.microsoft.com/office/drawing/2015/06/chart">
   <c:date1904 val="0"/>
+  <c:lang val="en-US"/>
   <c:roundedCorners val="1"/>
+  <c:style val="2"/>
   <c:chart>
     <c:autoTitleDeleted val="1"/>
     <c:plotArea>
@@ -153,18 +160,26 @@
           <c:invertIfNegative val="0"/>
           <c:dLbls>
             <c:numFmt formatCode="0.00" sourceLinked="0"/>
+            <c:spPr>
+              <a:noFill/>
+              <a:ln>
+                <a:noFill/>
+              </a:ln>
+              <a:effectLst/>
+            </c:spPr>
             <c:txPr>
               <a:bodyPr/>
               <a:lstStyle/>
               <a:p>
                 <a:pPr>
-                  <a:defRPr b="0" i="0" strike="noStrike" sz="800" u="none">
+                  <a:defRPr sz="800" b="0" i="0" u="none" strike="noStrike">
                     <a:solidFill>
                       <a:srgbClr val="1E293B"/>
                     </a:solidFill>
                     <a:latin typeface="Arial"/>
                   </a:defRPr>
                 </a:pPr>
+                <a:endParaRPr lang="el-GR"/>
               </a:p>
             </c:txPr>
             <c:showLegendKey val="0"/>
@@ -174,25 +189,28 @@
             <c:showPercent val="0"/>
             <c:showBubbleSize val="0"/>
             <c:showLeaderLines val="0"/>
+            <c:extLst>
+              <c:ext xmlns:c15="http://schemas.microsoft.com/office/drawing/2012/chart" uri="{CE6537A1-D6FC-4f65-9D91-7224C49458BB}">
+                <c15:showLeaderLines val="0"/>
+              </c:ext>
+            </c:extLst>
           </c:dLbls>
           <c:cat>
-            <c:multiLvlStrRef>
+            <c:strRef>
               <c:f>Sheet1!$A$2:$A$4</c:f>
-              <c:multiLvlStrCache>
+              <c:strCache>
                 <c:ptCount val="3"/>
-                <c:lvl>
-                  <c:pt idx="0">
-                    <c:v>5 tools</c:v>
-                  </c:pt>
-                  <c:pt idx="1">
-                    <c:v>15 tools</c:v>
-                  </c:pt>
-                  <c:pt idx="2">
-                    <c:v>30 tools</c:v>
-                  </c:pt>
-                </c:lvl>
-              </c:multiLvlStrCache>
-            </c:multiLvlStrRef>
+                <c:pt idx="0">
+                  <c:v>5 tools</c:v>
+                </c:pt>
+                <c:pt idx="1">
+                  <c:v>15 tools</c:v>
+                </c:pt>
+                <c:pt idx="2">
+                  <c:v>30 tools</c:v>
+                </c:pt>
+              </c:strCache>
+            </c:strRef>
           </c:cat>
           <c:val>
             <c:numRef>
@@ -204,44 +222,31 @@
                   <c:v>0.41</c:v>
                 </c:pt>
                 <c:pt idx="1">
-                  <c:v>0.299</c:v>
+                  <c:v>0.29899999999999999</c:v>
                 </c:pt>
                 <c:pt idx="2">
-                  <c:v>0.174</c:v>
+                  <c:v>0.17399999999999999</c:v>
                 </c:pt>
               </c:numCache>
             </c:numRef>
           </c:val>
+          <c:extLst>
+            <c:ext xmlns:c16="http://schemas.microsoft.com/office/drawing/2014/chart" uri="{C3380CC4-5D6E-409C-BE32-E72D297353CC}">
+              <c16:uniqueId val="{00000000-CF10-478B-A8EB-89BCC6C32072}"/>
+            </c:ext>
+          </c:extLst>
         </c:ser>
         <c:dLbls>
-          <c:numFmt formatCode="0.00" sourceLinked="0"/>
-          <c:txPr>
-            <a:bodyPr/>
-            <a:lstStyle/>
-            <a:p>
-              <a:pPr>
-                <a:defRPr b="0" i="0" strike="noStrike" sz="800" u="none">
-                  <a:solidFill>
-                    <a:srgbClr val="1E293B"/>
-                  </a:solidFill>
-                  <a:latin typeface="Arial"/>
-                </a:defRPr>
-              </a:pPr>
-            </a:p>
-          </c:txPr>
           <c:showLegendKey val="0"/>
           <c:showVal val="1"/>
           <c:showCatName val="0"/>
           <c:showSerName val="0"/>
           <c:showPercent val="0"/>
           <c:showBubbleSize val="0"/>
-          <c:showLeaderLines val="0"/>
         </c:dLbls>
         <c:gapWidth val="150"/>
-        <c:overlap val="0"/>
         <c:axId val="2094734554"/>
         <c:axId val="2094734552"/>
-        <c:axId val="2094734556"/>
       </c:barChart>
       <c:catAx>
         <c:axId val="2094734554"/>
@@ -282,6 +287,7 @@
         <c:crosses val="autoZero"/>
         <c:auto val="1"/>
         <c:lblAlgn val="ctr"/>
+        <c:lblOffset val="100"/>
         <c:noMultiLvlLbl val="1"/>
       </c:catAx>
       <c:valAx>
@@ -297,30 +303,6 @@
         <c:majorTickMark val="out"/>
         <c:minorTickMark val="none"/>
         <c:tickLblPos val="nextTo"/>
-        <c:spPr>
-          <a:ln w="12700" cap="flat">
-            <a:solidFill>
-              <a:srgbClr val="888888"/>
-            </a:solidFill>
-            <a:prstDash val="solid"/>
-            <a:round/>
-          </a:ln>
-        </c:spPr>
-        <c:txPr>
-          <a:bodyPr/>
-          <a:lstStyle/>
-          <a:p>
-            <a:pPr>
-              <a:defRPr sz="1200" b="0" i="0" u="none" strike="noStrike">
-                <a:solidFill>
-                  <a:srgbClr val="000000"/>
-                </a:solidFill>
-                <a:latin typeface="Arial"/>
-              </a:defRPr>
-            </a:pPr>
-            <a:endParaRPr lang="en-US"/>
-          </a:p>
-        </c:txPr>
         <c:crossAx val="2094734554"/>
         <c:crosses val="autoZero"/>
         <c:crossBetween val="between"/>
@@ -335,6 +317,7 @@
     </c:plotArea>
     <c:plotVisOnly val="1"/>
     <c:dispBlanksAs val="span"/>
+    <c:showDLblsOverMax val="1"/>
   </c:chart>
   <c:spPr>
     <a:noFill/>
@@ -350,9 +333,11 @@
 </file>
 
 <file path=ppt/charts/chart2.xml><?xml version="1.0" encoding="utf-8"?>
-<c:chartSpace xmlns:c="http://schemas.openxmlformats.org/drawingml/2006/chart" xmlns:a="http://schemas.openxmlformats.org/drawingml/2006/main" xmlns:r="http://schemas.openxmlformats.org/officeDocument/2006/relationships">
+<c:chartSpace xmlns:c="http://schemas.openxmlformats.org/drawingml/2006/chart" xmlns:a="http://schemas.openxmlformats.org/drawingml/2006/main" xmlns:r="http://schemas.openxmlformats.org/officeDocument/2006/relationships" xmlns:c16r2="http://schemas.microsoft.com/office/drawing/2015/06/chart">
   <c:date1904 val="0"/>
+  <c:lang val="en-US"/>
   <c:roundedCorners val="1"/>
+  <c:style val="2"/>
   <c:chart>
     <c:autoTitleDeleted val="1"/>
     <c:plotArea>
@@ -384,18 +369,26 @@
           <c:invertIfNegative val="0"/>
           <c:dLbls>
             <c:numFmt formatCode="0.00" sourceLinked="0"/>
+            <c:spPr>
+              <a:noFill/>
+              <a:ln>
+                <a:noFill/>
+              </a:ln>
+              <a:effectLst/>
+            </c:spPr>
             <c:txPr>
               <a:bodyPr/>
               <a:lstStyle/>
               <a:p>
                 <a:pPr>
-                  <a:defRPr b="0" i="0" strike="noStrike" sz="700" u="none">
+                  <a:defRPr sz="700" b="0" i="0" u="none" strike="noStrike">
                     <a:solidFill>
                       <a:srgbClr val="1E293B"/>
                     </a:solidFill>
                     <a:latin typeface="Arial"/>
                   </a:defRPr>
                 </a:pPr>
+                <a:endParaRPr lang="el-GR"/>
               </a:p>
             </c:txPr>
             <c:showLegendKey val="0"/>
@@ -405,25 +398,28 @@
             <c:showPercent val="0"/>
             <c:showBubbleSize val="0"/>
             <c:showLeaderLines val="0"/>
+            <c:extLst>
+              <c:ext xmlns:c15="http://schemas.microsoft.com/office/drawing/2012/chart" uri="{CE6537A1-D6FC-4f65-9D91-7224C49458BB}">
+                <c15:showLeaderLines val="0"/>
+              </c:ext>
+            </c:extLst>
           </c:dLbls>
           <c:cat>
-            <c:multiLvlStrRef>
+            <c:strRef>
               <c:f>Sheet1!$A$2:$A$4</c:f>
-              <c:multiLvlStrCache>
+              <c:strCache>
                 <c:ptCount val="3"/>
-                <c:lvl>
-                  <c:pt idx="0">
-                    <c:v>Regime 1</c:v>
-                  </c:pt>
-                  <c:pt idx="1">
-                    <c:v>Regime 2</c:v>
-                  </c:pt>
-                  <c:pt idx="2">
-                    <c:v>Regime 3</c:v>
-                  </c:pt>
-                </c:lvl>
-              </c:multiLvlStrCache>
-            </c:multiLvlStrRef>
+                <c:pt idx="0">
+                  <c:v>Regime 1</c:v>
+                </c:pt>
+                <c:pt idx="1">
+                  <c:v>Regime 2</c:v>
+                </c:pt>
+                <c:pt idx="2">
+                  <c:v>Regime 3</c:v>
+                </c:pt>
+              </c:strCache>
+            </c:strRef>
           </c:cat>
           <c:val>
             <c:numRef>
@@ -432,17 +428,22 @@
                 <c:formatCode>General</c:formatCode>
                 <c:ptCount val="3"/>
                 <c:pt idx="0">
-                  <c:v>0.988</c:v>
+                  <c:v>0.98799999999999999</c:v>
                 </c:pt>
                 <c:pt idx="1">
-                  <c:v>0.909</c:v>
+                  <c:v>0.90900000000000003</c:v>
                 </c:pt>
                 <c:pt idx="2">
-                  <c:v>0.667</c:v>
+                  <c:v>0.66700000000000004</c:v>
                 </c:pt>
               </c:numCache>
             </c:numRef>
           </c:val>
+          <c:extLst>
+            <c:ext xmlns:c16="http://schemas.microsoft.com/office/drawing/2014/chart" uri="{C3380CC4-5D6E-409C-BE32-E72D297353CC}">
+              <c16:uniqueId val="{00000000-F5CA-4159-85E2-6826A3987623}"/>
+            </c:ext>
+          </c:extLst>
         </c:ser>
         <c:ser>
           <c:idx val="1"/>
@@ -467,18 +468,26 @@
           <c:invertIfNegative val="0"/>
           <c:dLbls>
             <c:numFmt formatCode="0.00" sourceLinked="0"/>
+            <c:spPr>
+              <a:noFill/>
+              <a:ln>
+                <a:noFill/>
+              </a:ln>
+              <a:effectLst/>
+            </c:spPr>
             <c:txPr>
               <a:bodyPr/>
               <a:lstStyle/>
               <a:p>
                 <a:pPr>
-                  <a:defRPr b="0" i="0" strike="noStrike" sz="700" u="none">
+                  <a:defRPr sz="700" b="0" i="0" u="none" strike="noStrike">
                     <a:solidFill>
                       <a:srgbClr val="1E293B"/>
                     </a:solidFill>
                     <a:latin typeface="Arial"/>
                   </a:defRPr>
                 </a:pPr>
+                <a:endParaRPr lang="el-GR"/>
               </a:p>
             </c:txPr>
             <c:showLegendKey val="0"/>
@@ -488,25 +497,28 @@
             <c:showPercent val="0"/>
             <c:showBubbleSize val="0"/>
             <c:showLeaderLines val="0"/>
+            <c:extLst>
+              <c:ext xmlns:c15="http://schemas.microsoft.com/office/drawing/2012/chart" uri="{CE6537A1-D6FC-4f65-9D91-7224C49458BB}">
+                <c15:showLeaderLines val="0"/>
+              </c:ext>
+            </c:extLst>
           </c:dLbls>
           <c:cat>
-            <c:multiLvlStrRef>
+            <c:strRef>
               <c:f>Sheet1!$A$2:$A$4</c:f>
-              <c:multiLvlStrCache>
+              <c:strCache>
                 <c:ptCount val="3"/>
-                <c:lvl>
-                  <c:pt idx="0">
-                    <c:v>Regime 1</c:v>
-                  </c:pt>
-                  <c:pt idx="1">
-                    <c:v>Regime 2</c:v>
-                  </c:pt>
-                  <c:pt idx="2">
-                    <c:v>Regime 3</c:v>
-                  </c:pt>
-                </c:lvl>
-              </c:multiLvlStrCache>
-            </c:multiLvlStrRef>
+                <c:pt idx="0">
+                  <c:v>Regime 1</c:v>
+                </c:pt>
+                <c:pt idx="1">
+                  <c:v>Regime 2</c:v>
+                </c:pt>
+                <c:pt idx="2">
+                  <c:v>Regime 3</c:v>
+                </c:pt>
+              </c:strCache>
+            </c:strRef>
           </c:cat>
           <c:val>
             <c:numRef>
@@ -515,47 +527,34 @@
                 <c:formatCode>General</c:formatCode>
                 <c:ptCount val="3"/>
                 <c:pt idx="0">
-                  <c:v>0.944</c:v>
+                  <c:v>0.94399999999999995</c:v>
                 </c:pt>
                 <c:pt idx="1">
-                  <c:v>0.867</c:v>
+                  <c:v>0.86699999999999999</c:v>
                 </c:pt>
                 <c:pt idx="2">
-                  <c:v>0.632</c:v>
+                  <c:v>0.63200000000000001</c:v>
                 </c:pt>
               </c:numCache>
             </c:numRef>
           </c:val>
+          <c:extLst>
+            <c:ext xmlns:c16="http://schemas.microsoft.com/office/drawing/2014/chart" uri="{C3380CC4-5D6E-409C-BE32-E72D297353CC}">
+              <c16:uniqueId val="{00000001-F5CA-4159-85E2-6826A3987623}"/>
+            </c:ext>
+          </c:extLst>
         </c:ser>
         <c:dLbls>
-          <c:numFmt formatCode="0.00" sourceLinked="0"/>
-          <c:txPr>
-            <a:bodyPr/>
-            <a:lstStyle/>
-            <a:p>
-              <a:pPr>
-                <a:defRPr b="0" i="0" strike="noStrike" sz="700" u="none">
-                  <a:solidFill>
-                    <a:srgbClr val="1E293B"/>
-                  </a:solidFill>
-                  <a:latin typeface="Arial"/>
-                </a:defRPr>
-              </a:pPr>
-            </a:p>
-          </c:txPr>
           <c:showLegendKey val="0"/>
           <c:showVal val="1"/>
           <c:showCatName val="0"/>
           <c:showSerName val="0"/>
           <c:showPercent val="0"/>
           <c:showBubbleSize val="0"/>
-          <c:showLeaderLines val="0"/>
         </c:dLbls>
         <c:gapWidth val="150"/>
-        <c:overlap val="0"/>
         <c:axId val="2094734554"/>
         <c:axId val="2094734552"/>
-        <c:axId val="2094734556"/>
       </c:barChart>
       <c:catAx>
         <c:axId val="2094734554"/>
@@ -596,6 +595,7 @@
         <c:crosses val="autoZero"/>
         <c:auto val="1"/>
         <c:lblAlgn val="ctr"/>
+        <c:lblOffset val="100"/>
         <c:noMultiLvlLbl val="1"/>
       </c:catAx>
       <c:valAx>
@@ -611,30 +611,6 @@
         <c:majorTickMark val="out"/>
         <c:minorTickMark val="none"/>
         <c:tickLblPos val="nextTo"/>
-        <c:spPr>
-          <a:ln w="12700" cap="flat">
-            <a:solidFill>
-              <a:srgbClr val="888888"/>
-            </a:solidFill>
-            <a:prstDash val="solid"/>
-            <a:round/>
-          </a:ln>
-        </c:spPr>
-        <c:txPr>
-          <a:bodyPr/>
-          <a:lstStyle/>
-          <a:p>
-            <a:pPr>
-              <a:defRPr sz="1200" b="0" i="0" u="none" strike="noStrike">
-                <a:solidFill>
-                  <a:srgbClr val="000000"/>
-                </a:solidFill>
-                <a:latin typeface="Arial"/>
-              </a:defRPr>
-            </a:pPr>
-            <a:endParaRPr lang="en-US"/>
-          </a:p>
-        </c:txPr>
         <c:crossAx val="2094734554"/>
         <c:crosses val="autoZero"/>
         <c:crossBetween val="between"/>
@@ -668,6 +644,7 @@
     </c:legend>
     <c:plotVisOnly val="1"/>
     <c:dispBlanksAs val="span"/>
+    <c:showDLblsOverMax val="1"/>
   </c:chart>
   <c:spPr>
     <a:noFill/>
@@ -704,234 +681,10 @@
           <a:chExt cx="0" cy="0"/>
         </a:xfrm>
       </p:grpSpPr>
-      <p:sp>
-        <p:nvSpPr>
-          <p:cNvPr id="2" name="Header Placeholder 1"/>
-          <p:cNvSpPr>
-            <a:spLocks noGrp="1"/>
-          </p:cNvSpPr>
-          <p:nvPr>
-            <p:ph type="hdr" sz="quarter"/>
-          </p:nvPr>
-        </p:nvSpPr>
-        <p:spPr>
-          <a:xfrm>
-            <a:off x="0" y="0"/>
-            <a:ext cx="2971800" cy="458788"/>
-          </a:xfrm>
-          <a:prstGeom prst="rect">
-            <a:avLst/>
-          </a:prstGeom>
-        </p:spPr>
-        <p:txBody>
-          <a:bodyPr vert="horz" lIns="91440" tIns="45720" rIns="91440" bIns="45720" rtlCol="0"/>
-          <a:lstStyle>
-            <a:lvl1pPr algn="l">
-              <a:defRPr sz="1200"/>
-            </a:lvl1pPr>
-          </a:lstStyle>
-          <a:p>
-            <a:endParaRPr lang="en-US"/>
-          </a:p>
-        </p:txBody>
-      </p:sp>
-      <p:sp>
-        <p:nvSpPr>
-          <p:cNvPr id="3" name="Date Placeholder 2"/>
-          <p:cNvSpPr>
-            <a:spLocks noGrp="1"/>
-          </p:cNvSpPr>
-          <p:nvPr>
-            <p:ph type="dt" idx="1"/>
-          </p:nvPr>
-        </p:nvSpPr>
-        <p:spPr>
-          <a:xfrm>
-            <a:off x="3884613" y="0"/>
-            <a:ext cx="2971800" cy="458788"/>
-          </a:xfrm>
-          <a:prstGeom prst="rect">
-            <a:avLst/>
-          </a:prstGeom>
-        </p:spPr>
-        <p:txBody>
-          <a:bodyPr vert="horz" lIns="91440" tIns="45720" rIns="91440" bIns="45720" rtlCol="0"/>
-          <a:lstStyle>
-            <a:lvl1pPr algn="r">
-              <a:defRPr sz="1200"/>
-            </a:lvl1pPr>
-          </a:lstStyle>
-          <a:p>
-            <a:fld id="{5282F153-3F37-0F45-9E97-73ACFA13230C}" type="datetimeFigureOut">
-              <a:rPr lang="en-US"/>
-              <a:t>7/23/19</a:t>
-            </a:fld>
-            <a:endParaRPr lang="en-US"/>
-          </a:p>
-        </p:txBody>
-      </p:sp>
-      <p:sp>
-        <p:nvSpPr>
-          <p:cNvPr id="4" name="Slide Image Placeholder 3"/>
-          <p:cNvSpPr>
-            <a:spLocks noGrp="1" noRot="1" noChangeAspect="1"/>
-          </p:cNvSpPr>
-          <p:nvPr>
-            <p:ph type="sldImg" idx="2"/>
-          </p:nvPr>
-        </p:nvSpPr>
-        <p:spPr>
-          <a:xfrm>
-            <a:off x="685800" y="1143000"/>
-            <a:ext cx="5486400" cy="3086100"/>
-          </a:xfrm>
-          <a:prstGeom prst="rect">
-            <a:avLst/>
-          </a:prstGeom>
-          <a:noFill/>
-          <a:ln w="12700">
-            <a:solidFill>
-              <a:prstClr val="black"/>
-            </a:solidFill>
-          </a:ln>
-        </p:spPr>
-        <p:txBody>
-          <a:bodyPr vert="horz" lIns="91440" tIns="45720" rIns="91440" bIns="45720" rtlCol="0" anchor="ctr"/>
-          <a:lstStyle/>
-          <a:p>
-            <a:endParaRPr lang="en-US"/>
-          </a:p>
-        </p:txBody>
-      </p:sp>
-      <p:sp>
-        <p:nvSpPr>
-          <p:cNvPr id="5" name="Notes Placeholder 4"/>
-          <p:cNvSpPr>
-            <a:spLocks noGrp="1"/>
-          </p:cNvSpPr>
-          <p:nvPr>
-            <p:ph type="body" sz="quarter" idx="3"/>
-          </p:nvPr>
-        </p:nvSpPr>
-        <p:spPr>
-          <a:xfrm>
-            <a:off x="685800" y="4400550"/>
-            <a:ext cx="5486400" cy="3600450"/>
-          </a:xfrm>
-          <a:prstGeom prst="rect">
-            <a:avLst/>
-          </a:prstGeom>
-        </p:spPr>
-        <p:txBody>
-          <a:bodyPr vert="horz" lIns="91440" tIns="45720" rIns="91440" bIns="45720" rtlCol="0"/>
-          <a:lstStyle/>
-          <a:p>
-            <a:pPr lvl="0"/>
-            <a:r>
-              <a:rPr lang="en-US"/>
-              <a:t>Click to edit Master text styles</a:t>
-            </a:r>
-          </a:p>
-          <a:p>
-            <a:pPr lvl="1"/>
-            <a:r>
-              <a:rPr lang="en-US"/>
-              <a:t>Second level</a:t>
-            </a:r>
-          </a:p>
-          <a:p>
-            <a:pPr lvl="2"/>
-            <a:r>
-              <a:rPr lang="en-US"/>
-              <a:t>Third level</a:t>
-            </a:r>
-          </a:p>
-          <a:p>
-            <a:pPr lvl="3"/>
-            <a:r>
-              <a:rPr lang="en-US"/>
-              <a:t>Fourth level</a:t>
-            </a:r>
-          </a:p>
-          <a:p>
-            <a:pPr lvl="4"/>
-            <a:r>
-              <a:rPr lang="en-US"/>
-              <a:t>Fifth level</a:t>
-            </a:r>
-          </a:p>
-        </p:txBody>
-      </p:sp>
-      <p:sp>
-        <p:nvSpPr>
-          <p:cNvPr id="6" name="Footer Placeholder 5"/>
-          <p:cNvSpPr>
-            <a:spLocks noGrp="1"/>
-          </p:cNvSpPr>
-          <p:nvPr>
-            <p:ph type="ftr" sz="quarter" idx="4"/>
-          </p:nvPr>
-        </p:nvSpPr>
-        <p:spPr>
-          <a:xfrm>
-            <a:off x="0" y="8685213"/>
-            <a:ext cx="2971800" cy="458787"/>
-          </a:xfrm>
-          <a:prstGeom prst="rect">
-            <a:avLst/>
-          </a:prstGeom>
-        </p:spPr>
-        <p:txBody>
-          <a:bodyPr vert="horz" lIns="91440" tIns="45720" rIns="91440" bIns="45720" rtlCol="0" anchor="b"/>
-          <a:lstStyle>
-            <a:lvl1pPr algn="l">
-              <a:defRPr sz="1200"/>
-            </a:lvl1pPr>
-          </a:lstStyle>
-          <a:p>
-            <a:endParaRPr lang="en-US"/>
-          </a:p>
-        </p:txBody>
-      </p:sp>
-      <p:sp>
-        <p:nvSpPr>
-          <p:cNvPr id="7" name="Slide Number Placeholder 6"/>
-          <p:cNvSpPr>
-            <a:spLocks noGrp="1"/>
-          </p:cNvSpPr>
-          <p:nvPr>
-            <p:ph type="sldNum" sz="quarter" idx="5"/>
-          </p:nvPr>
-        </p:nvSpPr>
-        <p:spPr>
-          <a:xfrm>
-            <a:off x="3884613" y="8685213"/>
-            <a:ext cx="2971800" cy="458787"/>
-          </a:xfrm>
-          <a:prstGeom prst="rect">
-            <a:avLst/>
-          </a:prstGeom>
-        </p:spPr>
-        <p:txBody>
-          <a:bodyPr vert="horz" lIns="91440" tIns="45720" rIns="91440" bIns="45720" rtlCol="0" anchor="b"/>
-          <a:lstStyle>
-            <a:lvl1pPr algn="r">
-              <a:defRPr sz="1200"/>
-            </a:lvl1pPr>
-          </a:lstStyle>
-          <a:p>
-            <a:fld id="{CE5E9CC1-C706-0F49-92D6-E571CC5EEA8F}" type="slidenum">
-              <a:rPr lang="en-US"/>
-              <a:t>‹#›</a:t>
-            </a:fld>
-            <a:endParaRPr lang="en-US"/>
-          </a:p>
-        </p:txBody>
-      </p:sp>
     </p:spTree>
     <p:extLst>
       <p:ext uri="{BB962C8B-B14F-4D97-AF65-F5344CB8AC3E}">
-        <p14:creationId xmlns:p14="http://schemas.microsoft.com/office/powerpoint/2010/main" val="1024086991"/>
+        <p14:creationId xmlns:p14="http://schemas.microsoft.com/office/powerpoint/2010/main" val="3786525547"/>
       </p:ext>
     </p:extLst>
   </p:cSld>
@@ -1075,10 +828,6 @@
           <a:bodyPr/>
           <a:lstStyle/>
           <a:p>
-            <a:r>
-              <a:rPr lang="en-US" dirty="0"/>
-              <a:t/>
-            </a:r>
             <a:endParaRPr lang="en-US" dirty="0"/>
           </a:p>
         </p:txBody>
@@ -1163,10 +912,6 @@
           <a:bodyPr/>
           <a:lstStyle/>
           <a:p>
-            <a:r>
-              <a:rPr lang="en-US" dirty="0"/>
-              <a:t/>
-            </a:r>
             <a:endParaRPr lang="en-US" dirty="0"/>
           </a:p>
         </p:txBody>
@@ -1251,10 +996,6 @@
           <a:bodyPr/>
           <a:lstStyle/>
           <a:p>
-            <a:r>
-              <a:rPr lang="en-US" dirty="0"/>
-              <a:t/>
-            </a:r>
             <a:endParaRPr lang="en-US" dirty="0"/>
           </a:p>
         </p:txBody>
@@ -1339,10 +1080,6 @@
           <a:bodyPr/>
           <a:lstStyle/>
           <a:p>
-            <a:r>
-              <a:rPr lang="en-US" dirty="0"/>
-              <a:t/>
-            </a:r>
             <a:endParaRPr lang="en-US" dirty="0"/>
           </a:p>
         </p:txBody>
@@ -1427,10 +1164,6 @@
           <a:bodyPr/>
           <a:lstStyle/>
           <a:p>
-            <a:r>
-              <a:rPr lang="en-US" dirty="0"/>
-              <a:t/>
-            </a:r>
             <a:endParaRPr lang="en-US" dirty="0"/>
           </a:p>
         </p:txBody>
@@ -1515,10 +1248,6 @@
           <a:bodyPr/>
           <a:lstStyle/>
           <a:p>
-            <a:r>
-              <a:rPr lang="en-US" dirty="0"/>
-              <a:t/>
-            </a:r>
             <a:endParaRPr lang="en-US" dirty="0"/>
           </a:p>
         </p:txBody>
@@ -1603,10 +1332,6 @@
           <a:bodyPr/>
           <a:lstStyle/>
           <a:p>
-            <a:r>
-              <a:rPr lang="en-US" dirty="0"/>
-              <a:t/>
-            </a:r>
             <a:endParaRPr lang="en-US" dirty="0"/>
           </a:p>
         </p:txBody>
@@ -1691,10 +1416,6 @@
           <a:bodyPr/>
           <a:lstStyle/>
           <a:p>
-            <a:r>
-              <a:rPr lang="en-US" dirty="0"/>
-              <a:t/>
-            </a:r>
             <a:endParaRPr lang="en-US" dirty="0"/>
           </a:p>
         </p:txBody>
@@ -1779,10 +1500,6 @@
           <a:bodyPr/>
           <a:lstStyle/>
           <a:p>
-            <a:r>
-              <a:rPr lang="en-US" dirty="0"/>
-              <a:t/>
-            </a:r>
             <a:endParaRPr lang="en-US" dirty="0"/>
           </a:p>
         </p:txBody>
@@ -1867,10 +1584,6 @@
           <a:bodyPr/>
           <a:lstStyle/>
           <a:p>
-            <a:r>
-              <a:rPr lang="en-US" dirty="0"/>
-              <a:t/>
-            </a:r>
             <a:endParaRPr lang="en-US" dirty="0"/>
           </a:p>
         </p:txBody>
@@ -1955,10 +1668,6 @@
           <a:bodyPr/>
           <a:lstStyle/>
           <a:p>
-            <a:r>
-              <a:rPr lang="en-US" dirty="0"/>
-              <a:t/>
-            </a:r>
             <a:endParaRPr lang="en-US" dirty="0"/>
           </a:p>
         </p:txBody>
@@ -2043,10 +1752,6 @@
           <a:bodyPr/>
           <a:lstStyle/>
           <a:p>
-            <a:r>
-              <a:rPr lang="en-US" dirty="0"/>
-              <a:t/>
-            </a:r>
             <a:endParaRPr lang="en-US" dirty="0"/>
           </a:p>
         </p:txBody>
@@ -2120,6 +1825,11 @@
 <file path=ppt/slideMasters/slideMaster1.xml><?xml version="1.0" encoding="utf-8"?>
 <p:sldMaster xmlns:a="http://schemas.openxmlformats.org/drawingml/2006/main" xmlns:r="http://schemas.openxmlformats.org/officeDocument/2006/relationships" xmlns:p="http://schemas.openxmlformats.org/presentationml/2006/main">
   <p:cSld>
+    <p:bg>
+      <p:bgRef idx="1001">
+        <a:schemeClr val="bg1"/>
+      </p:bgRef>
+    </p:bg>
     <p:spTree>
       <p:nvGrpSpPr>
         <p:cNvPr id="1" name=""/>
@@ -2402,6 +2112,7 @@
         <a:solidFill>
           <a:srgbClr val="1B2A4A"/>
         </a:solidFill>
+        <a:effectLst/>
       </p:bgPr>
     </p:bg>
     <p:spTree>
@@ -2437,6 +2148,13 @@
           </a:solidFill>
           <a:ln/>
         </p:spPr>
+        <p:txBody>
+          <a:bodyPr/>
+          <a:lstStyle/>
+          <a:p>
+            <a:endParaRPr lang="el-GR"/>
+          </a:p>
+        </p:txBody>
       </p:sp>
       <p:sp>
         <p:nvSpPr>
@@ -2457,6 +2175,13 @@
           </a:solidFill>
           <a:ln/>
         </p:spPr>
+        <p:txBody>
+          <a:bodyPr/>
+          <a:lstStyle/>
+          <a:p>
+            <a:endParaRPr lang="el-GR"/>
+          </a:p>
+        </p:txBody>
       </p:sp>
       <p:sp>
         <p:nvSpPr>
@@ -2479,7 +2204,7 @@
           <a:bodyPr wrap="square" lIns="0" tIns="0" rIns="0" bIns="0" rtlCol="0" anchor="ctr"/>
           <a:lstStyle/>
           <a:p>
-            <a:pPr algn="ctr" indent="0" marL="0">
+            <a:pPr marL="0" indent="0" algn="ctr">
               <a:buNone/>
             </a:pPr>
             <a:r>
@@ -2518,7 +2243,7 @@
           <a:bodyPr wrap="square" lIns="0" tIns="0" rIns="0" bIns="0" rtlCol="0" anchor="ctr"/>
           <a:lstStyle/>
           <a:p>
-            <a:pPr algn="ctr" indent="0" marL="0">
+            <a:pPr marL="0" indent="0" algn="ctr">
               <a:buNone/>
             </a:pPr>
             <a:r>
@@ -2557,7 +2282,7 @@
           <a:bodyPr wrap="square" lIns="0" tIns="0" rIns="0" bIns="0" rtlCol="0" anchor="ctr"/>
           <a:lstStyle/>
           <a:p>
-            <a:pPr algn="ctr" indent="0" marL="0">
+            <a:pPr marL="0" indent="0" algn="ctr">
               <a:buNone/>
             </a:pPr>
             <a:r>
@@ -2596,7 +2321,7 @@
           <a:bodyPr wrap="square" lIns="0" tIns="0" rIns="0" bIns="0" rtlCol="0" anchor="ctr"/>
           <a:lstStyle/>
           <a:p>
-            <a:pPr algn="ctr" indent="0" marL="0">
+            <a:pPr marL="0" indent="0" algn="ctr">
               <a:buNone/>
             </a:pPr>
             <a:r>
@@ -2608,7 +2333,7 @@
                 <a:ea typeface="Calibri" pitchFamily="34" charset="-122"/>
                 <a:cs typeface="Calibri" pitchFamily="34" charset="-120"/>
               </a:rPr>
-              <a:t>[ Your name · Student ID · Course · Supervisor · Date ]</a:t>
+              <a:t> Dimitris Chatzipavlis · Machine &amp; Deep Learning · Supervisor: Sp. Georgakopoulos · June 2026</a:t>
             </a:r>
             <a:endParaRPr lang="en-US" sz="1400" dirty="0"/>
           </a:p>
@@ -2635,7 +2360,7 @@
           <a:bodyPr wrap="square" lIns="0" tIns="0" rIns="0" bIns="0" rtlCol="0" anchor="ctr"/>
           <a:lstStyle/>
           <a:p>
-            <a:pPr algn="ctr" indent="0" marL="0">
+            <a:pPr marL="0" indent="0" algn="ctr">
               <a:buNone/>
             </a:pPr>
             <a:r>
@@ -2669,6 +2394,7 @@
         <a:solidFill>
           <a:srgbClr val="F4F6F9"/>
         </a:solidFill>
+        <a:effectLst/>
       </p:bgPr>
     </p:bg>
     <p:spTree>
@@ -2704,6 +2430,13 @@
           </a:solidFill>
           <a:ln/>
         </p:spPr>
+        <p:txBody>
+          <a:bodyPr/>
+          <a:lstStyle/>
+          <a:p>
+            <a:endParaRPr lang="el-GR"/>
+          </a:p>
+        </p:txBody>
       </p:sp>
       <p:sp>
         <p:nvSpPr>
@@ -2726,6 +2459,13 @@
           </a:solidFill>
           <a:ln/>
         </p:spPr>
+        <p:txBody>
+          <a:bodyPr/>
+          <a:lstStyle/>
+          <a:p>
+            <a:endParaRPr lang="el-GR"/>
+          </a:p>
+        </p:txBody>
       </p:sp>
       <p:sp>
         <p:nvSpPr>
@@ -2748,11 +2488,11 @@
           <a:bodyPr wrap="square" lIns="0" tIns="0" rIns="0" bIns="0" rtlCol="0" anchor="ctr"/>
           <a:lstStyle/>
           <a:p>
-            <a:pPr algn="ctr" indent="0" marL="0">
-              <a:buNone/>
-            </a:pPr>
-            <a:r>
-              <a:rPr lang="en-US" sz="1000" b="1" spc="100" kern="0" dirty="0">
+            <a:pPr marL="0" indent="0" algn="ctr">
+              <a:buNone/>
+            </a:pPr>
+            <a:r>
+              <a:rPr lang="en-US" sz="1000" b="1" kern="0" spc="100" dirty="0">
                 <a:solidFill>
                   <a:srgbClr val="FFFFFF"/>
                 </a:solidFill>
@@ -2787,7 +2527,7 @@
           <a:bodyPr wrap="square" lIns="0" tIns="0" rIns="0" bIns="0" rtlCol="0" anchor="ctr"/>
           <a:lstStyle/>
           <a:p>
-            <a:pPr indent="0" marL="0">
+            <a:pPr marL="0" indent="0">
               <a:buNone/>
             </a:pPr>
             <a:r>
@@ -2829,24 +2569,31 @@
             <a:prstDash val="solid"/>
           </a:ln>
           <a:effectLst>
-            <a:outerShdw sx="100000" sy="100000" kx="0" ky="0" algn="bl" rotWithShape="0" blurRad="88900" dist="38100" dir="8100000">
+            <a:outerShdw blurRad="88900" dist="38100" dir="8100000" algn="bl" rotWithShape="0">
               <a:srgbClr val="000000">
                 <a:alpha val="16000"/>
               </a:srgbClr>
             </a:outerShdw>
           </a:effectLst>
         </p:spPr>
+        <p:txBody>
+          <a:bodyPr/>
+          <a:lstStyle/>
+          <a:p>
+            <a:endParaRPr lang="el-GR"/>
+          </a:p>
+        </p:txBody>
       </p:sp>
       <p:pic>
         <p:nvPicPr>
-          <p:cNvPr id="7" name="Image 0" descr="C:\Users\dimit\Desktop\GEORGAML\ToolFinder\experiments\results\figures\fig_scaling.png">    </p:cNvPr>
+          <p:cNvPr id="7" name="Image 0" descr="C:\Users\dimit\Desktop\GEORGAML\ToolFinder\experiments\results\figures\fig_scaling.png"/>
           <p:cNvPicPr>
             <a:picLocks noChangeAspect="1"/>
           </p:cNvPicPr>
           <p:nvPr/>
         </p:nvPicPr>
         <p:blipFill>
-          <a:blip r:embed="rId1"/>
+          <a:blip r:embed="rId3"/>
           <a:stretch>
             <a:fillRect/>
           </a:stretch>
@@ -2885,13 +2632,20 @@
             <a:prstDash val="solid"/>
           </a:ln>
           <a:effectLst>
-            <a:outerShdw sx="100000" sy="100000" kx="0" ky="0" algn="bl" rotWithShape="0" blurRad="88900" dist="38100" dir="8100000">
+            <a:outerShdw blurRad="88900" dist="38100" dir="8100000" algn="bl" rotWithShape="0">
               <a:srgbClr val="000000">
                 <a:alpha val="16000"/>
               </a:srgbClr>
             </a:outerShdw>
           </a:effectLst>
         </p:spPr>
+        <p:txBody>
+          <a:bodyPr/>
+          <a:lstStyle/>
+          <a:p>
+            <a:endParaRPr lang="el-GR"/>
+          </a:p>
+        </p:txBody>
       </p:sp>
       <p:sp>
         <p:nvSpPr>
@@ -2912,6 +2666,13 @@
           </a:solidFill>
           <a:ln/>
         </p:spPr>
+        <p:txBody>
+          <a:bodyPr/>
+          <a:lstStyle/>
+          <a:p>
+            <a:endParaRPr lang="el-GR"/>
+          </a:p>
+        </p:txBody>
       </p:sp>
       <p:sp>
         <p:nvSpPr>
@@ -2934,7 +2695,7 @@
           <a:bodyPr wrap="square" lIns="0" tIns="0" rIns="0" bIns="0" rtlCol="0" anchor="ctr"/>
           <a:lstStyle/>
           <a:p>
-            <a:pPr indent="0" marL="0">
+            <a:pPr marL="0" indent="0">
               <a:buNone/>
             </a:pPr>
             <a:r>
@@ -2973,7 +2734,7 @@
           <a:bodyPr wrap="square" lIns="0" tIns="0" rIns="0" bIns="0" rtlCol="0" anchor="t"/>
           <a:lstStyle/>
           <a:p>
-            <a:pPr indent="0" marL="0">
+            <a:pPr marL="0" indent="0">
               <a:buNone/>
             </a:pPr>
             <a:r>
@@ -3015,13 +2776,20 @@
             <a:prstDash val="solid"/>
           </a:ln>
           <a:effectLst>
-            <a:outerShdw sx="100000" sy="100000" kx="0" ky="0" algn="bl" rotWithShape="0" blurRad="88900" dist="38100" dir="8100000">
+            <a:outerShdw blurRad="88900" dist="38100" dir="8100000" algn="bl" rotWithShape="0">
               <a:srgbClr val="000000">
                 <a:alpha val="16000"/>
               </a:srgbClr>
             </a:outerShdw>
           </a:effectLst>
         </p:spPr>
+        <p:txBody>
+          <a:bodyPr/>
+          <a:lstStyle/>
+          <a:p>
+            <a:endParaRPr lang="el-GR"/>
+          </a:p>
+        </p:txBody>
       </p:sp>
       <p:sp>
         <p:nvSpPr>
@@ -3042,6 +2810,13 @@
           </a:solidFill>
           <a:ln/>
         </p:spPr>
+        <p:txBody>
+          <a:bodyPr/>
+          <a:lstStyle/>
+          <a:p>
+            <a:endParaRPr lang="el-GR"/>
+          </a:p>
+        </p:txBody>
       </p:sp>
       <p:sp>
         <p:nvSpPr>
@@ -3064,7 +2839,7 @@
           <a:bodyPr wrap="square" lIns="0" tIns="0" rIns="0" bIns="0" rtlCol="0" anchor="ctr"/>
           <a:lstStyle/>
           <a:p>
-            <a:pPr indent="0" marL="0">
+            <a:pPr marL="0" indent="0">
               <a:buNone/>
             </a:pPr>
             <a:r>
@@ -3103,7 +2878,7 @@
           <a:bodyPr wrap="square" lIns="0" tIns="0" rIns="0" bIns="0" rtlCol="0" anchor="t"/>
           <a:lstStyle/>
           <a:p>
-            <a:pPr indent="0" marL="0">
+            <a:pPr marL="0" indent="0">
               <a:buNone/>
             </a:pPr>
             <a:r>
@@ -3142,7 +2917,7 @@
           <a:bodyPr wrap="square" lIns="0" tIns="0" rIns="0" bIns="0" rtlCol="0" anchor="ctr"/>
           <a:lstStyle/>
           <a:p>
-            <a:pPr algn="ctr" indent="0" marL="0">
+            <a:pPr marL="0" indent="0" algn="ctr">
               <a:buNone/>
             </a:pPr>
             <a:r>
@@ -3181,7 +2956,7 @@
           <a:bodyPr wrap="square" lIns="0" tIns="0" rIns="0" bIns="0" rtlCol="0" anchor="ctr"/>
           <a:lstStyle/>
           <a:p>
-            <a:pPr indent="0" marL="0">
+            <a:pPr marL="0" indent="0">
               <a:buNone/>
             </a:pPr>
             <a:r>
@@ -3220,7 +2995,7 @@
           <a:bodyPr wrap="square" lIns="0" tIns="0" rIns="0" bIns="0" rtlCol="0" anchor="ctr"/>
           <a:lstStyle/>
           <a:p>
-            <a:pPr algn="r" indent="0" marL="0">
+            <a:pPr marL="0" indent="0" algn="r">
               <a:buNone/>
             </a:pPr>
             <a:r>
@@ -3254,6 +3029,7 @@
         <a:solidFill>
           <a:srgbClr val="F4F6F9"/>
         </a:solidFill>
+        <a:effectLst/>
       </p:bgPr>
     </p:bg>
     <p:spTree>
@@ -3289,6 +3065,13 @@
           </a:solidFill>
           <a:ln/>
         </p:spPr>
+        <p:txBody>
+          <a:bodyPr/>
+          <a:lstStyle/>
+          <a:p>
+            <a:endParaRPr lang="el-GR"/>
+          </a:p>
+        </p:txBody>
       </p:sp>
       <p:sp>
         <p:nvSpPr>
@@ -3311,6 +3094,13 @@
           </a:solidFill>
           <a:ln/>
         </p:spPr>
+        <p:txBody>
+          <a:bodyPr/>
+          <a:lstStyle/>
+          <a:p>
+            <a:endParaRPr lang="el-GR"/>
+          </a:p>
+        </p:txBody>
       </p:sp>
       <p:sp>
         <p:nvSpPr>
@@ -3333,11 +3123,11 @@
           <a:bodyPr wrap="square" lIns="0" tIns="0" rIns="0" bIns="0" rtlCol="0" anchor="ctr"/>
           <a:lstStyle/>
           <a:p>
-            <a:pPr algn="ctr" indent="0" marL="0">
-              <a:buNone/>
-            </a:pPr>
-            <a:r>
-              <a:rPr lang="en-US" sz="1000" b="1" spc="100" kern="0" dirty="0">
+            <a:pPr marL="0" indent="0" algn="ctr">
+              <a:buNone/>
+            </a:pPr>
+            <a:r>
+              <a:rPr lang="en-US" sz="1000" b="1" kern="0" spc="100" dirty="0">
                 <a:solidFill>
                   <a:srgbClr val="FFFFFF"/>
                 </a:solidFill>
@@ -3372,7 +3162,7 @@
           <a:bodyPr wrap="square" lIns="0" tIns="0" rIns="0" bIns="0" rtlCol="0" anchor="ctr"/>
           <a:lstStyle/>
           <a:p>
-            <a:pPr indent="0" marL="0">
+            <a:pPr marL="0" indent="0">
               <a:buNone/>
             </a:pPr>
             <a:r>
@@ -3414,13 +3204,20 @@
             <a:prstDash val="solid"/>
           </a:ln>
           <a:effectLst>
-            <a:outerShdw sx="100000" sy="100000" kx="0" ky="0" algn="bl" rotWithShape="0" blurRad="88900" dist="38100" dir="8100000">
+            <a:outerShdw blurRad="88900" dist="38100" dir="8100000" algn="bl" rotWithShape="0">
               <a:srgbClr val="000000">
                 <a:alpha val="16000"/>
               </a:srgbClr>
             </a:outerShdw>
           </a:effectLst>
         </p:spPr>
+        <p:txBody>
+          <a:bodyPr/>
+          <a:lstStyle/>
+          <a:p>
+            <a:endParaRPr lang="el-GR"/>
+          </a:p>
+        </p:txBody>
       </p:sp>
       <p:sp>
         <p:nvSpPr>
@@ -3441,6 +3238,13 @@
           </a:solidFill>
           <a:ln/>
         </p:spPr>
+        <p:txBody>
+          <a:bodyPr/>
+          <a:lstStyle/>
+          <a:p>
+            <a:endParaRPr lang="el-GR"/>
+          </a:p>
+        </p:txBody>
       </p:sp>
       <p:sp>
         <p:nvSpPr>
@@ -3463,7 +3267,7 @@
           <a:bodyPr wrap="square" lIns="0" tIns="0" rIns="0" bIns="0" rtlCol="0" anchor="ctr"/>
           <a:lstStyle/>
           <a:p>
-            <a:pPr indent="0" marL="0">
+            <a:pPr marL="0" indent="0">
               <a:buNone/>
             </a:pPr>
             <a:r>
@@ -3502,7 +3306,7 @@
           <a:bodyPr wrap="square" lIns="0" tIns="0" rIns="0" bIns="0" rtlCol="0" anchor="ctr"/>
           <a:lstStyle/>
           <a:p>
-            <a:pPr indent="0" marL="0">
+            <a:pPr marL="0" indent="0">
               <a:buNone/>
             </a:pPr>
             <a:r>
@@ -3544,13 +3348,20 @@
             <a:prstDash val="solid"/>
           </a:ln>
           <a:effectLst>
-            <a:outerShdw sx="100000" sy="100000" kx="0" ky="0" algn="bl" rotWithShape="0" blurRad="88900" dist="38100" dir="8100000">
+            <a:outerShdw blurRad="88900" dist="38100" dir="8100000" algn="bl" rotWithShape="0">
               <a:srgbClr val="000000">
                 <a:alpha val="16000"/>
               </a:srgbClr>
             </a:outerShdw>
           </a:effectLst>
         </p:spPr>
+        <p:txBody>
+          <a:bodyPr/>
+          <a:lstStyle/>
+          <a:p>
+            <a:endParaRPr lang="el-GR"/>
+          </a:p>
+        </p:txBody>
       </p:sp>
       <p:sp>
         <p:nvSpPr>
@@ -3571,6 +3382,13 @@
           </a:solidFill>
           <a:ln/>
         </p:spPr>
+        <p:txBody>
+          <a:bodyPr/>
+          <a:lstStyle/>
+          <a:p>
+            <a:endParaRPr lang="el-GR"/>
+          </a:p>
+        </p:txBody>
       </p:sp>
       <p:sp>
         <p:nvSpPr>
@@ -3593,7 +3411,7 @@
           <a:bodyPr wrap="square" lIns="0" tIns="0" rIns="0" bIns="0" rtlCol="0" anchor="ctr"/>
           <a:lstStyle/>
           <a:p>
-            <a:pPr indent="0" marL="0">
+            <a:pPr marL="0" indent="0">
               <a:buNone/>
             </a:pPr>
             <a:r>
@@ -3632,7 +3450,7 @@
           <a:bodyPr wrap="square" lIns="0" tIns="0" rIns="0" bIns="0" rtlCol="0" anchor="ctr"/>
           <a:lstStyle/>
           <a:p>
-            <a:pPr indent="0" marL="0">
+            <a:pPr marL="0" indent="0">
               <a:buNone/>
             </a:pPr>
             <a:r>
@@ -3674,13 +3492,20 @@
             <a:prstDash val="solid"/>
           </a:ln>
           <a:effectLst>
-            <a:outerShdw sx="100000" sy="100000" kx="0" ky="0" algn="bl" rotWithShape="0" blurRad="88900" dist="38100" dir="8100000">
+            <a:outerShdw blurRad="88900" dist="38100" dir="8100000" algn="bl" rotWithShape="0">
               <a:srgbClr val="000000">
                 <a:alpha val="16000"/>
               </a:srgbClr>
             </a:outerShdw>
           </a:effectLst>
         </p:spPr>
+        <p:txBody>
+          <a:bodyPr/>
+          <a:lstStyle/>
+          <a:p>
+            <a:endParaRPr lang="el-GR"/>
+          </a:p>
+        </p:txBody>
       </p:sp>
       <p:sp>
         <p:nvSpPr>
@@ -3701,6 +3526,13 @@
           </a:solidFill>
           <a:ln/>
         </p:spPr>
+        <p:txBody>
+          <a:bodyPr/>
+          <a:lstStyle/>
+          <a:p>
+            <a:endParaRPr lang="el-GR"/>
+          </a:p>
+        </p:txBody>
       </p:sp>
       <p:sp>
         <p:nvSpPr>
@@ -3723,7 +3555,7 @@
           <a:bodyPr wrap="square" lIns="0" tIns="0" rIns="0" bIns="0" rtlCol="0" anchor="ctr"/>
           <a:lstStyle/>
           <a:p>
-            <a:pPr indent="0" marL="0">
+            <a:pPr marL="0" indent="0">
               <a:buNone/>
             </a:pPr>
             <a:r>
@@ -3762,7 +3594,7 @@
           <a:bodyPr wrap="square" lIns="0" tIns="0" rIns="0" bIns="0" rtlCol="0" anchor="ctr"/>
           <a:lstStyle/>
           <a:p>
-            <a:pPr indent="0" marL="0">
+            <a:pPr marL="0" indent="0">
               <a:buNone/>
             </a:pPr>
             <a:r>
@@ -3804,17 +3636,24 @@
             <a:prstDash val="solid"/>
           </a:ln>
           <a:effectLst>
-            <a:outerShdw sx="100000" sy="100000" kx="0" ky="0" algn="bl" rotWithShape="0" blurRad="88900" dist="38100" dir="8100000">
+            <a:outerShdw blurRad="88900" dist="38100" dir="8100000" algn="bl" rotWithShape="0">
               <a:srgbClr val="000000">
                 <a:alpha val="16000"/>
               </a:srgbClr>
             </a:outerShdw>
           </a:effectLst>
         </p:spPr>
+        <p:txBody>
+          <a:bodyPr/>
+          <a:lstStyle/>
+          <a:p>
+            <a:endParaRPr lang="el-GR"/>
+          </a:p>
+        </p:txBody>
       </p:sp>
       <p:graphicFrame>
         <p:nvGraphicFramePr>
-          <p:cNvPr id="19" name="Chart 0" descr=""/>
+          <p:cNvPr id="19" name="Chart 0"/>
           <p:cNvGraphicFramePr/>
           <p:nvPr/>
         </p:nvGraphicFramePr>
@@ -3822,9 +3661,9 @@
           <a:off x="5943600" y="1627632"/>
           <a:ext cx="2697480" cy="2542032"/>
         </p:xfrm>
-        <a:graphic xmlns:a="http://schemas.openxmlformats.org/drawingml/2006/main">
+        <a:graphic>
           <a:graphicData uri="http://schemas.openxmlformats.org/drawingml/2006/chart">
-            <c:chart xmlns:c="http://schemas.openxmlformats.org/drawingml/2006/chart" r:id="rId1"/>
+            <c:chart xmlns:c="http://schemas.openxmlformats.org/drawingml/2006/chart" xmlns:r="http://schemas.openxmlformats.org/officeDocument/2006/relationships" r:id="rId3"/>
           </a:graphicData>
         </a:graphic>
       </p:graphicFrame>
@@ -3849,7 +3688,7 @@
           <a:bodyPr wrap="square" lIns="0" tIns="0" rIns="0" bIns="0" rtlCol="0" anchor="ctr"/>
           <a:lstStyle/>
           <a:p>
-            <a:pPr algn="ctr" indent="0" marL="0">
+            <a:pPr marL="0" indent="0" algn="ctr">
               <a:buNone/>
             </a:pPr>
             <a:r>
@@ -3888,7 +3727,7 @@
           <a:bodyPr wrap="square" lIns="0" tIns="0" rIns="0" bIns="0" rtlCol="0" anchor="ctr"/>
           <a:lstStyle/>
           <a:p>
-            <a:pPr indent="0" marL="0">
+            <a:pPr marL="0" indent="0">
               <a:buNone/>
             </a:pPr>
             <a:r>
@@ -3927,7 +3766,7 @@
           <a:bodyPr wrap="square" lIns="0" tIns="0" rIns="0" bIns="0" rtlCol="0" anchor="ctr"/>
           <a:lstStyle/>
           <a:p>
-            <a:pPr algn="r" indent="0" marL="0">
+            <a:pPr marL="0" indent="0" algn="r">
               <a:buNone/>
             </a:pPr>
             <a:r>
@@ -3961,6 +3800,7 @@
         <a:solidFill>
           <a:srgbClr val="1B2A4A"/>
         </a:solidFill>
+        <a:effectLst/>
       </p:bgPr>
     </p:bg>
     <p:spTree>
@@ -3996,6 +3836,13 @@
           </a:solidFill>
           <a:ln/>
         </p:spPr>
+        <p:txBody>
+          <a:bodyPr/>
+          <a:lstStyle/>
+          <a:p>
+            <a:endParaRPr lang="el-GR"/>
+          </a:p>
+        </p:txBody>
       </p:sp>
       <p:sp>
         <p:nvSpPr>
@@ -4018,7 +3865,7 @@
           <a:bodyPr wrap="square" lIns="0" tIns="0" rIns="0" bIns="0" rtlCol="0" anchor="ctr"/>
           <a:lstStyle/>
           <a:p>
-            <a:pPr indent="0" marL="0">
+            <a:pPr marL="0" indent="0">
               <a:buNone/>
             </a:pPr>
             <a:r>
@@ -4166,6 +4013,13 @@
             <a:prstDash val="solid"/>
           </a:ln>
         </p:spPr>
+        <p:txBody>
+          <a:bodyPr/>
+          <a:lstStyle/>
+          <a:p>
+            <a:endParaRPr lang="el-GR"/>
+          </a:p>
+        </p:txBody>
       </p:sp>
       <p:sp>
         <p:nvSpPr>
@@ -4188,7 +4042,7 @@
           <a:bodyPr wrap="square" lIns="0" tIns="0" rIns="0" bIns="0" rtlCol="0" anchor="ctr"/>
           <a:lstStyle/>
           <a:p>
-            <a:pPr indent="0" marL="0">
+            <a:pPr marL="0" indent="0">
               <a:buNone/>
             </a:pPr>
             <a:r>
@@ -4200,7 +4054,18 @@
                 <a:ea typeface="Calibri" pitchFamily="34" charset="-122"/>
                 <a:cs typeface="Calibri" pitchFamily="34" charset="-120"/>
               </a:rPr>
-              <a:t>Limitations: synthetic queries (known grammar), single training domain, LLM-in-context arm not run (environment-blocked). All disclosed; none inflate the reported numbers.</a:t>
+              <a:t>Limitations: synthetic queries (known grammar), single </a:t>
+            </a:r>
+            <a:r>
+              <a:rPr lang="en-US" sz="1200" i="1">
+                <a:solidFill>
+                  <a:srgbClr val="9FB3D1"/>
+                </a:solidFill>
+                <a:latin typeface="Calibri" pitchFamily="34" charset="0"/>
+                <a:ea typeface="Calibri" pitchFamily="34" charset="-122"/>
+                <a:cs typeface="Calibri" pitchFamily="34" charset="-120"/>
+              </a:rPr>
+              <a:t>training domain.</a:t>
             </a:r>
             <a:endParaRPr lang="en-US" sz="1200" dirty="0"/>
           </a:p>
@@ -4227,7 +4092,7 @@
           <a:bodyPr wrap="square" lIns="0" tIns="0" rIns="0" bIns="0" rtlCol="0" anchor="ctr"/>
           <a:lstStyle/>
           <a:p>
-            <a:pPr algn="ctr" indent="0" marL="0">
+            <a:pPr marL="0" indent="0" algn="ctr">
               <a:buNone/>
             </a:pPr>
             <a:r>
@@ -4261,6 +4126,7 @@
         <a:solidFill>
           <a:srgbClr val="F4F6F9"/>
         </a:solidFill>
+        <a:effectLst/>
       </p:bgPr>
     </p:bg>
     <p:spTree>
@@ -4296,6 +4162,13 @@
           </a:solidFill>
           <a:ln/>
         </p:spPr>
+        <p:txBody>
+          <a:bodyPr/>
+          <a:lstStyle/>
+          <a:p>
+            <a:endParaRPr lang="el-GR"/>
+          </a:p>
+        </p:txBody>
       </p:sp>
       <p:sp>
         <p:nvSpPr>
@@ -4318,6 +4191,13 @@
           </a:solidFill>
           <a:ln/>
         </p:spPr>
+        <p:txBody>
+          <a:bodyPr/>
+          <a:lstStyle/>
+          <a:p>
+            <a:endParaRPr lang="el-GR"/>
+          </a:p>
+        </p:txBody>
       </p:sp>
       <p:sp>
         <p:nvSpPr>
@@ -4340,11 +4220,11 @@
           <a:bodyPr wrap="square" lIns="0" tIns="0" rIns="0" bIns="0" rtlCol="0" anchor="ctr"/>
           <a:lstStyle/>
           <a:p>
-            <a:pPr algn="ctr" indent="0" marL="0">
-              <a:buNone/>
-            </a:pPr>
-            <a:r>
-              <a:rPr lang="en-US" sz="1000" b="1" spc="100" kern="0" dirty="0">
+            <a:pPr marL="0" indent="0" algn="ctr">
+              <a:buNone/>
+            </a:pPr>
+            <a:r>
+              <a:rPr lang="en-US" sz="1000" b="1" kern="0" spc="100" dirty="0">
                 <a:solidFill>
                   <a:srgbClr val="FFFFFF"/>
                 </a:solidFill>
@@ -4379,7 +4259,7 @@
           <a:bodyPr wrap="square" lIns="0" tIns="0" rIns="0" bIns="0" rtlCol="0" anchor="ctr"/>
           <a:lstStyle/>
           <a:p>
-            <a:pPr indent="0" marL="0">
+            <a:pPr marL="0" indent="0">
               <a:buNone/>
             </a:pPr>
             <a:r>
@@ -4416,254 +4296,17 @@
           </a:solidFill>
           <a:ln/>
         </p:spPr>
+        <p:txBody>
+          <a:bodyPr/>
+          <a:lstStyle/>
+          <a:p>
+            <a:endParaRPr lang="el-GR"/>
+          </a:p>
+        </p:txBody>
       </p:sp>
       <p:pic>
         <p:nvPicPr>
-          <p:cNvPr id="7" name="Image 0" descr="preencoded.png">    </p:cNvPr>
-          <p:cNvPicPr>
-            <a:picLocks noChangeAspect="1"/>
-          </p:cNvPicPr>
-          <p:nvPr/>
-        </p:nvPicPr>
-        <p:blipFill>
-          <a:blip r:embed="rId1"/>
-          <a:stretch>
-            <a:fillRect/>
-          </a:stretch>
-        </p:blipFill>
-        <p:spPr>
-          <a:xfrm>
-            <a:off x="740664" y="1655064"/>
-            <a:ext cx="182880" cy="182880"/>
-          </a:xfrm>
-          <a:prstGeom prst="rect">
-            <a:avLst/>
-          </a:prstGeom>
-        </p:spPr>
-      </p:pic>
-      <p:sp>
-        <p:nvSpPr>
-          <p:cNvPr id="8" name="Text 5"/>
-          <p:cNvSpPr/>
-          <p:nvPr/>
-        </p:nvSpPr>
-        <p:spPr>
-          <a:xfrm>
-            <a:off x="1188720" y="1536192"/>
-            <a:ext cx="3931920" cy="310896"/>
-          </a:xfrm>
-          <a:prstGeom prst="rect">
-            <a:avLst/>
-          </a:prstGeom>
-          <a:noFill/>
-          <a:ln/>
-        </p:spPr>
-        <p:txBody>
-          <a:bodyPr wrap="square" lIns="0" tIns="0" rIns="0" bIns="0" rtlCol="0" anchor="ctr"/>
-          <a:lstStyle/>
-          <a:p>
-            <a:pPr indent="0" marL="0">
-              <a:buNone/>
-            </a:pPr>
-            <a:r>
-              <a:rPr lang="en-US" sz="1500" b="1" dirty="0">
-                <a:solidFill>
-                  <a:srgbClr val="1B2A4A"/>
-                </a:solidFill>
-                <a:latin typeface="Calibri" pitchFamily="34" charset="0"/>
-                <a:ea typeface="Calibri" pitchFamily="34" charset="-122"/>
-                <a:cs typeface="Calibri" pitchFamily="34" charset="-120"/>
-              </a:rPr>
-              <a:t>Context bloat</a:t>
-            </a:r>
-            <a:endParaRPr lang="en-US" sz="1500" dirty="0"/>
-          </a:p>
-        </p:txBody>
-      </p:sp>
-      <p:sp>
-        <p:nvSpPr>
-          <p:cNvPr id="9" name="Text 6"/>
-          <p:cNvSpPr/>
-          <p:nvPr/>
-        </p:nvSpPr>
-        <p:spPr>
-          <a:xfrm>
-            <a:off x="1188720" y="1847088"/>
-            <a:ext cx="4023360" cy="457200"/>
-          </a:xfrm>
-          <a:prstGeom prst="rect">
-            <a:avLst/>
-          </a:prstGeom>
-          <a:noFill/>
-          <a:ln/>
-        </p:spPr>
-        <p:txBody>
-          <a:bodyPr wrap="square" lIns="0" tIns="0" rIns="0" bIns="0" rtlCol="0" anchor="ctr"/>
-          <a:lstStyle/>
-          <a:p>
-            <a:pPr indent="0" marL="0">
-              <a:buNone/>
-            </a:pPr>
-            <a:r>
-              <a:rPr lang="en-US" sz="1200" dirty="0">
-                <a:solidFill>
-                  <a:srgbClr val="1E293B"/>
-                </a:solidFill>
-                <a:latin typeface="Calibri" pitchFamily="34" charset="0"/>
-                <a:ea typeface="Calibri" pitchFamily="34" charset="-122"/>
-                <a:cs typeface="Calibri" pitchFamily="34" charset="-120"/>
-              </a:rPr>
-              <a:t>Binding every MCP schema fills the window before reasoning begins.</a:t>
-            </a:r>
-            <a:endParaRPr lang="en-US" sz="1200" dirty="0"/>
-          </a:p>
-        </p:txBody>
-      </p:sp>
-      <p:sp>
-        <p:nvSpPr>
-          <p:cNvPr id="10" name="Shape 7"/>
-          <p:cNvSpPr/>
-          <p:nvPr/>
-        </p:nvSpPr>
-        <p:spPr>
-          <a:xfrm>
-            <a:off x="640080" y="2395728"/>
-            <a:ext cx="384048" cy="384048"/>
-          </a:xfrm>
-          <a:prstGeom prst="ellipse">
-            <a:avLst/>
-          </a:prstGeom>
-          <a:solidFill>
-            <a:srgbClr val="4878A8"/>
-          </a:solidFill>
-          <a:ln/>
-        </p:spPr>
-      </p:sp>
-      <p:pic>
-        <p:nvPicPr>
-          <p:cNvPr id="11" name="Image 1" descr="preencoded.png">    </p:cNvPr>
-          <p:cNvPicPr>
-            <a:picLocks noChangeAspect="1"/>
-          </p:cNvPicPr>
-          <p:nvPr/>
-        </p:nvPicPr>
-        <p:blipFill>
-          <a:blip r:embed="rId2"/>
-          <a:stretch>
-            <a:fillRect/>
-          </a:stretch>
-        </p:blipFill>
-        <p:spPr>
-          <a:xfrm>
-            <a:off x="740664" y="2496312"/>
-            <a:ext cx="182880" cy="182880"/>
-          </a:xfrm>
-          <a:prstGeom prst="rect">
-            <a:avLst/>
-          </a:prstGeom>
-        </p:spPr>
-      </p:pic>
-      <p:sp>
-        <p:nvSpPr>
-          <p:cNvPr id="12" name="Text 8"/>
-          <p:cNvSpPr/>
-          <p:nvPr/>
-        </p:nvSpPr>
-        <p:spPr>
-          <a:xfrm>
-            <a:off x="1188720" y="2377440"/>
-            <a:ext cx="3931920" cy="310896"/>
-          </a:xfrm>
-          <a:prstGeom prst="rect">
-            <a:avLst/>
-          </a:prstGeom>
-          <a:noFill/>
-          <a:ln/>
-        </p:spPr>
-        <p:txBody>
-          <a:bodyPr wrap="square" lIns="0" tIns="0" rIns="0" bIns="0" rtlCol="0" anchor="ctr"/>
-          <a:lstStyle/>
-          <a:p>
-            <a:pPr indent="0" marL="0">
-              <a:buNone/>
-            </a:pPr>
-            <a:r>
-              <a:rPr lang="en-US" sz="1500" b="1" dirty="0">
-                <a:solidFill>
-                  <a:srgbClr val="1B2A4A"/>
-                </a:solidFill>
-                <a:latin typeface="Calibri" pitchFamily="34" charset="0"/>
-                <a:ea typeface="Calibri" pitchFamily="34" charset="-122"/>
-                <a:cs typeface="Calibri" pitchFamily="34" charset="-120"/>
-              </a:rPr>
-              <a:t>Lost in the middle</a:t>
-            </a:r>
-            <a:endParaRPr lang="en-US" sz="1500" dirty="0"/>
-          </a:p>
-        </p:txBody>
-      </p:sp>
-      <p:sp>
-        <p:nvSpPr>
-          <p:cNvPr id="13" name="Text 9"/>
-          <p:cNvSpPr/>
-          <p:nvPr/>
-        </p:nvSpPr>
-        <p:spPr>
-          <a:xfrm>
-            <a:off x="1188720" y="2688336"/>
-            <a:ext cx="4023360" cy="457200"/>
-          </a:xfrm>
-          <a:prstGeom prst="rect">
-            <a:avLst/>
-          </a:prstGeom>
-          <a:noFill/>
-          <a:ln/>
-        </p:spPr>
-        <p:txBody>
-          <a:bodyPr wrap="square" lIns="0" tIns="0" rIns="0" bIns="0" rtlCol="0" anchor="ctr"/>
-          <a:lstStyle/>
-          <a:p>
-            <a:pPr indent="0" marL="0">
-              <a:buNone/>
-            </a:pPr>
-            <a:r>
-              <a:rPr lang="en-US" sz="1200" dirty="0">
-                <a:solidFill>
-                  <a:srgbClr val="1E293B"/>
-                </a:solidFill>
-                <a:latin typeface="Calibri" pitchFamily="34" charset="0"/>
-                <a:ea typeface="Calibri" pitchFamily="34" charset="-122"/>
-                <a:cs typeface="Calibri" pitchFamily="34" charset="-120"/>
-              </a:rPr>
-              <a:t>Similar APIs collide in-context, raising tool-selection errors.</a:t>
-            </a:r>
-            <a:endParaRPr lang="en-US" sz="1200" dirty="0"/>
-          </a:p>
-        </p:txBody>
-      </p:sp>
-      <p:sp>
-        <p:nvSpPr>
-          <p:cNvPr id="14" name="Shape 10"/>
-          <p:cNvSpPr/>
-          <p:nvPr/>
-        </p:nvSpPr>
-        <p:spPr>
-          <a:xfrm>
-            <a:off x="640080" y="3236976"/>
-            <a:ext cx="384048" cy="384048"/>
-          </a:xfrm>
-          <a:prstGeom prst="ellipse">
-            <a:avLst/>
-          </a:prstGeom>
-          <a:solidFill>
-            <a:srgbClr val="4878A8"/>
-          </a:solidFill>
-          <a:ln/>
-        </p:spPr>
-      </p:sp>
-      <p:pic>
-        <p:nvPicPr>
-          <p:cNvPr id="15" name="Image 2" descr="preencoded.png">    </p:cNvPr>
+          <p:cNvPr id="7" name="Image 0" descr="preencoded.png"/>
           <p:cNvPicPr>
             <a:picLocks noChangeAspect="1"/>
           </p:cNvPicPr>
@@ -4677,7 +4320,7 @@
         </p:blipFill>
         <p:spPr>
           <a:xfrm>
-            <a:off x="740664" y="3337560"/>
+            <a:off x="740664" y="1655064"/>
             <a:ext cx="182880" cy="182880"/>
           </a:xfrm>
           <a:prstGeom prst="rect">
@@ -4687,13 +4330,13 @@
       </p:pic>
       <p:sp>
         <p:nvSpPr>
-          <p:cNvPr id="16" name="Text 11"/>
-          <p:cNvSpPr/>
-          <p:nvPr/>
-        </p:nvSpPr>
-        <p:spPr>
-          <a:xfrm>
-            <a:off x="1188720" y="3218688"/>
+          <p:cNvPr id="8" name="Text 5"/>
+          <p:cNvSpPr/>
+          <p:nvPr/>
+        </p:nvSpPr>
+        <p:spPr>
+          <a:xfrm>
+            <a:off x="1188720" y="1536192"/>
             <a:ext cx="3931920" cy="310896"/>
           </a:xfrm>
           <a:prstGeom prst="rect">
@@ -4706,7 +4349,7 @@
           <a:bodyPr wrap="square" lIns="0" tIns="0" rIns="0" bIns="0" rtlCol="0" anchor="ctr"/>
           <a:lstStyle/>
           <a:p>
-            <a:pPr indent="0" marL="0">
+            <a:pPr marL="0" indent="0">
               <a:buNone/>
             </a:pPr>
             <a:r>
@@ -4718,7 +4361,7 @@
                 <a:ea typeface="Calibri" pitchFamily="34" charset="-122"/>
                 <a:cs typeface="Calibri" pitchFamily="34" charset="-120"/>
               </a:rPr>
-              <a:t>Small models break</a:t>
+              <a:t>Context bloat</a:t>
             </a:r>
             <a:endParaRPr lang="en-US" sz="1500" dirty="0"/>
           </a:p>
@@ -4726,13 +4369,13 @@
       </p:sp>
       <p:sp>
         <p:nvSpPr>
-          <p:cNvPr id="17" name="Text 12"/>
-          <p:cNvSpPr/>
-          <p:nvPr/>
-        </p:nvSpPr>
-        <p:spPr>
-          <a:xfrm>
-            <a:off x="1188720" y="3529584"/>
+          <p:cNvPr id="9" name="Text 6"/>
+          <p:cNvSpPr/>
+          <p:nvPr/>
+        </p:nvSpPr>
+        <p:spPr>
+          <a:xfrm>
+            <a:off x="1188720" y="1847088"/>
             <a:ext cx="4023360" cy="457200"/>
           </a:xfrm>
           <a:prstGeom prst="rect">
@@ -4745,7 +4388,7 @@
           <a:bodyPr wrap="square" lIns="0" tIns="0" rIns="0" bIns="0" rtlCol="0" anchor="ctr"/>
           <a:lstStyle/>
           <a:p>
-            <a:pPr indent="0" marL="0">
+            <a:pPr marL="0" indent="0">
               <a:buNone/>
             </a:pPr>
             <a:r>
@@ -4757,6 +4400,264 @@
                 <a:ea typeface="Calibri" pitchFamily="34" charset="-122"/>
                 <a:cs typeface="Calibri" pitchFamily="34" charset="-120"/>
               </a:rPr>
+              <a:t>Binding every MCP schema fills the window before reasoning begins.</a:t>
+            </a:r>
+            <a:endParaRPr lang="en-US" sz="1200" dirty="0"/>
+          </a:p>
+        </p:txBody>
+      </p:sp>
+      <p:sp>
+        <p:nvSpPr>
+          <p:cNvPr id="10" name="Shape 7"/>
+          <p:cNvSpPr/>
+          <p:nvPr/>
+        </p:nvSpPr>
+        <p:spPr>
+          <a:xfrm>
+            <a:off x="640080" y="2395728"/>
+            <a:ext cx="384048" cy="384048"/>
+          </a:xfrm>
+          <a:prstGeom prst="ellipse">
+            <a:avLst/>
+          </a:prstGeom>
+          <a:solidFill>
+            <a:srgbClr val="4878A8"/>
+          </a:solidFill>
+          <a:ln/>
+        </p:spPr>
+        <p:txBody>
+          <a:bodyPr/>
+          <a:lstStyle/>
+          <a:p>
+            <a:endParaRPr lang="el-GR"/>
+          </a:p>
+        </p:txBody>
+      </p:sp>
+      <p:pic>
+        <p:nvPicPr>
+          <p:cNvPr id="11" name="Image 1" descr="preencoded.png"/>
+          <p:cNvPicPr>
+            <a:picLocks noChangeAspect="1"/>
+          </p:cNvPicPr>
+          <p:nvPr/>
+        </p:nvPicPr>
+        <p:blipFill>
+          <a:blip r:embed="rId4"/>
+          <a:stretch>
+            <a:fillRect/>
+          </a:stretch>
+        </p:blipFill>
+        <p:spPr>
+          <a:xfrm>
+            <a:off x="740664" y="2496312"/>
+            <a:ext cx="182880" cy="182880"/>
+          </a:xfrm>
+          <a:prstGeom prst="rect">
+            <a:avLst/>
+          </a:prstGeom>
+        </p:spPr>
+      </p:pic>
+      <p:sp>
+        <p:nvSpPr>
+          <p:cNvPr id="12" name="Text 8"/>
+          <p:cNvSpPr/>
+          <p:nvPr/>
+        </p:nvSpPr>
+        <p:spPr>
+          <a:xfrm>
+            <a:off x="1188720" y="2377440"/>
+            <a:ext cx="3931920" cy="310896"/>
+          </a:xfrm>
+          <a:prstGeom prst="rect">
+            <a:avLst/>
+          </a:prstGeom>
+          <a:noFill/>
+          <a:ln/>
+        </p:spPr>
+        <p:txBody>
+          <a:bodyPr wrap="square" lIns="0" tIns="0" rIns="0" bIns="0" rtlCol="0" anchor="ctr"/>
+          <a:lstStyle/>
+          <a:p>
+            <a:pPr marL="0" indent="0">
+              <a:buNone/>
+            </a:pPr>
+            <a:r>
+              <a:rPr lang="en-US" sz="1500" b="1" dirty="0">
+                <a:solidFill>
+                  <a:srgbClr val="1B2A4A"/>
+                </a:solidFill>
+                <a:latin typeface="Calibri" pitchFamily="34" charset="0"/>
+                <a:ea typeface="Calibri" pitchFamily="34" charset="-122"/>
+                <a:cs typeface="Calibri" pitchFamily="34" charset="-120"/>
+              </a:rPr>
+              <a:t>Lost in the middle</a:t>
+            </a:r>
+            <a:endParaRPr lang="en-US" sz="1500" dirty="0"/>
+          </a:p>
+        </p:txBody>
+      </p:sp>
+      <p:sp>
+        <p:nvSpPr>
+          <p:cNvPr id="13" name="Text 9"/>
+          <p:cNvSpPr/>
+          <p:nvPr/>
+        </p:nvSpPr>
+        <p:spPr>
+          <a:xfrm>
+            <a:off x="1188720" y="2688336"/>
+            <a:ext cx="4023360" cy="457200"/>
+          </a:xfrm>
+          <a:prstGeom prst="rect">
+            <a:avLst/>
+          </a:prstGeom>
+          <a:noFill/>
+          <a:ln/>
+        </p:spPr>
+        <p:txBody>
+          <a:bodyPr wrap="square" lIns="0" tIns="0" rIns="0" bIns="0" rtlCol="0" anchor="ctr"/>
+          <a:lstStyle/>
+          <a:p>
+            <a:pPr marL="0" indent="0">
+              <a:buNone/>
+            </a:pPr>
+            <a:r>
+              <a:rPr lang="en-US" sz="1200" dirty="0">
+                <a:solidFill>
+                  <a:srgbClr val="1E293B"/>
+                </a:solidFill>
+                <a:latin typeface="Calibri" pitchFamily="34" charset="0"/>
+                <a:ea typeface="Calibri" pitchFamily="34" charset="-122"/>
+                <a:cs typeface="Calibri" pitchFamily="34" charset="-120"/>
+              </a:rPr>
+              <a:t>Similar APIs collide in-context, raising tool-selection errors.</a:t>
+            </a:r>
+            <a:endParaRPr lang="en-US" sz="1200" dirty="0"/>
+          </a:p>
+        </p:txBody>
+      </p:sp>
+      <p:sp>
+        <p:nvSpPr>
+          <p:cNvPr id="14" name="Shape 10"/>
+          <p:cNvSpPr/>
+          <p:nvPr/>
+        </p:nvSpPr>
+        <p:spPr>
+          <a:xfrm>
+            <a:off x="640080" y="3236976"/>
+            <a:ext cx="384048" cy="384048"/>
+          </a:xfrm>
+          <a:prstGeom prst="ellipse">
+            <a:avLst/>
+          </a:prstGeom>
+          <a:solidFill>
+            <a:srgbClr val="4878A8"/>
+          </a:solidFill>
+          <a:ln/>
+        </p:spPr>
+        <p:txBody>
+          <a:bodyPr/>
+          <a:lstStyle/>
+          <a:p>
+            <a:endParaRPr lang="el-GR"/>
+          </a:p>
+        </p:txBody>
+      </p:sp>
+      <p:pic>
+        <p:nvPicPr>
+          <p:cNvPr id="15" name="Image 2" descr="preencoded.png"/>
+          <p:cNvPicPr>
+            <a:picLocks noChangeAspect="1"/>
+          </p:cNvPicPr>
+          <p:nvPr/>
+        </p:nvPicPr>
+        <p:blipFill>
+          <a:blip r:embed="rId5"/>
+          <a:stretch>
+            <a:fillRect/>
+          </a:stretch>
+        </p:blipFill>
+        <p:spPr>
+          <a:xfrm>
+            <a:off x="740664" y="3337560"/>
+            <a:ext cx="182880" cy="182880"/>
+          </a:xfrm>
+          <a:prstGeom prst="rect">
+            <a:avLst/>
+          </a:prstGeom>
+        </p:spPr>
+      </p:pic>
+      <p:sp>
+        <p:nvSpPr>
+          <p:cNvPr id="16" name="Text 11"/>
+          <p:cNvSpPr/>
+          <p:nvPr/>
+        </p:nvSpPr>
+        <p:spPr>
+          <a:xfrm>
+            <a:off x="1188720" y="3218688"/>
+            <a:ext cx="3931920" cy="310896"/>
+          </a:xfrm>
+          <a:prstGeom prst="rect">
+            <a:avLst/>
+          </a:prstGeom>
+          <a:noFill/>
+          <a:ln/>
+        </p:spPr>
+        <p:txBody>
+          <a:bodyPr wrap="square" lIns="0" tIns="0" rIns="0" bIns="0" rtlCol="0" anchor="ctr"/>
+          <a:lstStyle/>
+          <a:p>
+            <a:pPr marL="0" indent="0">
+              <a:buNone/>
+            </a:pPr>
+            <a:r>
+              <a:rPr lang="en-US" sz="1500" b="1" dirty="0">
+                <a:solidFill>
+                  <a:srgbClr val="1B2A4A"/>
+                </a:solidFill>
+                <a:latin typeface="Calibri" pitchFamily="34" charset="0"/>
+                <a:ea typeface="Calibri" pitchFamily="34" charset="-122"/>
+                <a:cs typeface="Calibri" pitchFamily="34" charset="-120"/>
+              </a:rPr>
+              <a:t>Small models break</a:t>
+            </a:r>
+            <a:endParaRPr lang="en-US" sz="1500" dirty="0"/>
+          </a:p>
+        </p:txBody>
+      </p:sp>
+      <p:sp>
+        <p:nvSpPr>
+          <p:cNvPr id="17" name="Text 12"/>
+          <p:cNvSpPr/>
+          <p:nvPr/>
+        </p:nvSpPr>
+        <p:spPr>
+          <a:xfrm>
+            <a:off x="1188720" y="3529584"/>
+            <a:ext cx="4023360" cy="457200"/>
+          </a:xfrm>
+          <a:prstGeom prst="rect">
+            <a:avLst/>
+          </a:prstGeom>
+          <a:noFill/>
+          <a:ln/>
+        </p:spPr>
+        <p:txBody>
+          <a:bodyPr wrap="square" lIns="0" tIns="0" rIns="0" bIns="0" rtlCol="0" anchor="ctr"/>
+          <a:lstStyle/>
+          <a:p>
+            <a:pPr marL="0" indent="0">
+              <a:buNone/>
+            </a:pPr>
+            <a:r>
+              <a:rPr lang="en-US" sz="1200" dirty="0">
+                <a:solidFill>
+                  <a:srgbClr val="1E293B"/>
+                </a:solidFill>
+                <a:latin typeface="Calibri" pitchFamily="34" charset="0"/>
+                <a:ea typeface="Calibri" pitchFamily="34" charset="-122"/>
+                <a:cs typeface="Calibri" pitchFamily="34" charset="-120"/>
+              </a:rPr>
               <a:t>3B local models emit malformed calls under long-prompt pressure.</a:t>
             </a:r>
             <a:endParaRPr lang="en-US" sz="1200" dirty="0"/>
@@ -4782,13 +4683,20 @@
           </a:solidFill>
           <a:ln/>
           <a:effectLst>
-            <a:outerShdw sx="100000" sy="100000" kx="0" ky="0" algn="bl" rotWithShape="0" blurRad="88900" dist="38100" dir="8100000">
+            <a:outerShdw blurRad="88900" dist="38100" dir="8100000" algn="bl" rotWithShape="0">
               <a:srgbClr val="000000">
                 <a:alpha val="16000"/>
               </a:srgbClr>
             </a:outerShdw>
           </a:effectLst>
         </p:spPr>
+        <p:txBody>
+          <a:bodyPr/>
+          <a:lstStyle/>
+          <a:p>
+            <a:endParaRPr lang="el-GR"/>
+          </a:p>
+        </p:txBody>
       </p:sp>
       <p:sp>
         <p:nvSpPr>
@@ -4811,7 +4719,7 @@
           <a:bodyPr wrap="square" lIns="0" tIns="0" rIns="0" bIns="0" rtlCol="0" anchor="ctr"/>
           <a:lstStyle/>
           <a:p>
-            <a:pPr indent="0" marL="0">
+            <a:pPr marL="0" indent="0">
               <a:buNone/>
             </a:pPr>
             <a:r>
@@ -4850,7 +4758,7 @@
           <a:bodyPr wrap="square" lIns="0" tIns="0" rIns="0" bIns="0" rtlCol="0" anchor="ctr"/>
           <a:lstStyle/>
           <a:p>
-            <a:pPr indent="0" marL="0">
+            <a:pPr marL="0" indent="0">
               <a:buNone/>
             </a:pPr>
             <a:r>
@@ -4889,7 +4797,7 @@
           <a:bodyPr wrap="square" lIns="0" tIns="0" rIns="0" bIns="0" rtlCol="0" anchor="ctr"/>
           <a:lstStyle/>
           <a:p>
-            <a:pPr indent="0" marL="0">
+            <a:pPr marL="0" indent="0">
               <a:buNone/>
             </a:pPr>
             <a:r>
@@ -4928,7 +4836,7 @@
           <a:bodyPr wrap="square" lIns="0" tIns="0" rIns="0" bIns="0" rtlCol="0" anchor="ctr"/>
           <a:lstStyle/>
           <a:p>
-            <a:pPr algn="r" indent="0" marL="0">
+            <a:pPr marL="0" indent="0" algn="r">
               <a:buNone/>
             </a:pPr>
             <a:r>
@@ -4962,6 +4870,7 @@
         <a:solidFill>
           <a:srgbClr val="F4F6F9"/>
         </a:solidFill>
+        <a:effectLst/>
       </p:bgPr>
     </p:bg>
     <p:spTree>
@@ -4997,6 +4906,13 @@
           </a:solidFill>
           <a:ln/>
         </p:spPr>
+        <p:txBody>
+          <a:bodyPr/>
+          <a:lstStyle/>
+          <a:p>
+            <a:endParaRPr lang="el-GR"/>
+          </a:p>
+        </p:txBody>
       </p:sp>
       <p:sp>
         <p:nvSpPr>
@@ -5019,6 +4935,13 @@
           </a:solidFill>
           <a:ln/>
         </p:spPr>
+        <p:txBody>
+          <a:bodyPr/>
+          <a:lstStyle/>
+          <a:p>
+            <a:endParaRPr lang="el-GR"/>
+          </a:p>
+        </p:txBody>
       </p:sp>
       <p:sp>
         <p:nvSpPr>
@@ -5041,11 +4964,11 @@
           <a:bodyPr wrap="square" lIns="0" tIns="0" rIns="0" bIns="0" rtlCol="0" anchor="ctr"/>
           <a:lstStyle/>
           <a:p>
-            <a:pPr algn="ctr" indent="0" marL="0">
-              <a:buNone/>
-            </a:pPr>
-            <a:r>
-              <a:rPr lang="en-US" sz="1000" b="1" spc="100" kern="0" dirty="0">
+            <a:pPr marL="0" indent="0" algn="ctr">
+              <a:buNone/>
+            </a:pPr>
+            <a:r>
+              <a:rPr lang="en-US" sz="1000" b="1" kern="0" spc="100" dirty="0">
                 <a:solidFill>
                   <a:srgbClr val="FFFFFF"/>
                 </a:solidFill>
@@ -5080,7 +5003,7 @@
           <a:bodyPr wrap="square" lIns="0" tIns="0" rIns="0" bIns="0" rtlCol="0" anchor="ctr"/>
           <a:lstStyle/>
           <a:p>
-            <a:pPr indent="0" marL="0">
+            <a:pPr marL="0" indent="0">
               <a:buNone/>
             </a:pPr>
             <a:r>
@@ -5122,13 +5045,20 @@
             <a:prstDash val="solid"/>
           </a:ln>
           <a:effectLst>
-            <a:outerShdw sx="100000" sy="100000" kx="0" ky="0" algn="bl" rotWithShape="0" blurRad="88900" dist="38100" dir="8100000">
+            <a:outerShdw blurRad="88900" dist="38100" dir="8100000" algn="bl" rotWithShape="0">
               <a:srgbClr val="000000">
                 <a:alpha val="16000"/>
               </a:srgbClr>
             </a:outerShdw>
           </a:effectLst>
         </p:spPr>
+        <p:txBody>
+          <a:bodyPr/>
+          <a:lstStyle/>
+          <a:p>
+            <a:endParaRPr lang="el-GR"/>
+          </a:p>
+        </p:txBody>
       </p:sp>
       <p:sp>
         <p:nvSpPr>
@@ -5149,6 +5079,13 @@
           </a:solidFill>
           <a:ln/>
         </p:spPr>
+        <p:txBody>
+          <a:bodyPr/>
+          <a:lstStyle/>
+          <a:p>
+            <a:endParaRPr lang="el-GR"/>
+          </a:p>
+        </p:txBody>
       </p:sp>
       <p:sp>
         <p:nvSpPr>
@@ -5171,7 +5108,7 @@
           <a:bodyPr wrap="square" lIns="0" tIns="0" rIns="0" bIns="0" rtlCol="0" anchor="ctr"/>
           <a:lstStyle/>
           <a:p>
-            <a:pPr indent="0" marL="0">
+            <a:pPr marL="0" indent="0">
               <a:buNone/>
             </a:pPr>
             <a:r>
@@ -5319,13 +5256,20 @@
             <a:prstDash val="solid"/>
           </a:ln>
           <a:effectLst>
-            <a:outerShdw sx="100000" sy="100000" kx="0" ky="0" algn="bl" rotWithShape="0" blurRad="88900" dist="38100" dir="8100000">
+            <a:outerShdw blurRad="88900" dist="38100" dir="8100000" algn="bl" rotWithShape="0">
               <a:srgbClr val="000000">
                 <a:alpha val="16000"/>
               </a:srgbClr>
             </a:outerShdw>
           </a:effectLst>
         </p:spPr>
+        <p:txBody>
+          <a:bodyPr/>
+          <a:lstStyle/>
+          <a:p>
+            <a:endParaRPr lang="el-GR"/>
+          </a:p>
+        </p:txBody>
       </p:sp>
       <p:sp>
         <p:nvSpPr>
@@ -5346,6 +5290,13 @@
           </a:solidFill>
           <a:ln/>
         </p:spPr>
+        <p:txBody>
+          <a:bodyPr/>
+          <a:lstStyle/>
+          <a:p>
+            <a:endParaRPr lang="el-GR"/>
+          </a:p>
+        </p:txBody>
       </p:sp>
       <p:sp>
         <p:nvSpPr>
@@ -5368,7 +5319,7 @@
           <a:bodyPr wrap="square" lIns="0" tIns="0" rIns="0" bIns="0" rtlCol="0" anchor="ctr"/>
           <a:lstStyle/>
           <a:p>
-            <a:pPr indent="0" marL="0">
+            <a:pPr marL="0" indent="0">
               <a:buNone/>
             </a:pPr>
             <a:r>
@@ -5511,6 +5462,13 @@
           </a:solidFill>
           <a:ln/>
         </p:spPr>
+        <p:txBody>
+          <a:bodyPr/>
+          <a:lstStyle/>
+          <a:p>
+            <a:endParaRPr lang="el-GR"/>
+          </a:p>
+        </p:txBody>
       </p:sp>
       <p:sp>
         <p:nvSpPr>
@@ -5533,7 +5491,7 @@
           <a:bodyPr wrap="square" lIns="0" tIns="0" rIns="0" bIns="0" rtlCol="0" anchor="ctr"/>
           <a:lstStyle/>
           <a:p>
-            <a:pPr indent="0" marL="0">
+            <a:pPr marL="0" indent="0">
               <a:buNone/>
             </a:pPr>
             <a:r>
@@ -5572,7 +5530,7 @@
           <a:bodyPr wrap="square" lIns="0" tIns="0" rIns="0" bIns="0" rtlCol="0" anchor="ctr"/>
           <a:lstStyle/>
           <a:p>
-            <a:pPr indent="0" marL="0">
+            <a:pPr marL="0" indent="0">
               <a:buNone/>
             </a:pPr>
             <a:r>
@@ -5611,7 +5569,7 @@
           <a:bodyPr wrap="square" lIns="0" tIns="0" rIns="0" bIns="0" rtlCol="0" anchor="ctr"/>
           <a:lstStyle/>
           <a:p>
-            <a:pPr algn="r" indent="0" marL="0">
+            <a:pPr marL="0" indent="0" algn="r">
               <a:buNone/>
             </a:pPr>
             <a:r>
@@ -5645,6 +5603,7 @@
         <a:solidFill>
           <a:srgbClr val="F4F6F9"/>
         </a:solidFill>
+        <a:effectLst/>
       </p:bgPr>
     </p:bg>
     <p:spTree>
@@ -5680,6 +5639,13 @@
           </a:solidFill>
           <a:ln/>
         </p:spPr>
+        <p:txBody>
+          <a:bodyPr/>
+          <a:lstStyle/>
+          <a:p>
+            <a:endParaRPr lang="el-GR"/>
+          </a:p>
+        </p:txBody>
       </p:sp>
       <p:sp>
         <p:nvSpPr>
@@ -5702,6 +5668,13 @@
           </a:solidFill>
           <a:ln/>
         </p:spPr>
+        <p:txBody>
+          <a:bodyPr/>
+          <a:lstStyle/>
+          <a:p>
+            <a:endParaRPr lang="el-GR"/>
+          </a:p>
+        </p:txBody>
       </p:sp>
       <p:sp>
         <p:nvSpPr>
@@ -5724,11 +5697,11 @@
           <a:bodyPr wrap="square" lIns="0" tIns="0" rIns="0" bIns="0" rtlCol="0" anchor="ctr"/>
           <a:lstStyle/>
           <a:p>
-            <a:pPr algn="ctr" indent="0" marL="0">
-              <a:buNone/>
-            </a:pPr>
-            <a:r>
-              <a:rPr lang="en-US" sz="1000" b="1" spc="100" kern="0" dirty="0">
+            <a:pPr marL="0" indent="0" algn="ctr">
+              <a:buNone/>
+            </a:pPr>
+            <a:r>
+              <a:rPr lang="en-US" sz="1000" b="1" kern="0" spc="100" dirty="0">
                 <a:solidFill>
                   <a:srgbClr val="FFFFFF"/>
                 </a:solidFill>
@@ -5763,7 +5736,7 @@
           <a:bodyPr wrap="square" lIns="0" tIns="0" rIns="0" bIns="0" rtlCol="0" anchor="ctr"/>
           <a:lstStyle/>
           <a:p>
-            <a:pPr indent="0" marL="0">
+            <a:pPr marL="0" indent="0">
               <a:buNone/>
             </a:pPr>
             <a:r>
@@ -5805,24 +5778,31 @@
             <a:prstDash val="solid"/>
           </a:ln>
           <a:effectLst>
-            <a:outerShdw sx="100000" sy="100000" kx="0" ky="0" algn="bl" rotWithShape="0" blurRad="88900" dist="38100" dir="8100000">
+            <a:outerShdw blurRad="88900" dist="38100" dir="8100000" algn="bl" rotWithShape="0">
               <a:srgbClr val="000000">
                 <a:alpha val="16000"/>
               </a:srgbClr>
             </a:outerShdw>
           </a:effectLst>
         </p:spPr>
+        <p:txBody>
+          <a:bodyPr/>
+          <a:lstStyle/>
+          <a:p>
+            <a:endParaRPr lang="el-GR"/>
+          </a:p>
+        </p:txBody>
       </p:sp>
       <p:pic>
         <p:nvPicPr>
-          <p:cNvPr id="7" name="Image 0" descr="C:\Users\dimit\Desktop\GEORGAML\ToolFinder\experiments\results\figures\fig_leakage_audit.png">    </p:cNvPr>
+          <p:cNvPr id="7" name="Image 0" descr="C:\Users\dimit\Desktop\GEORGAML\ToolFinder\experiments\results\figures\fig_leakage_audit.png"/>
           <p:cNvPicPr>
             <a:picLocks noChangeAspect="1"/>
           </p:cNvPicPr>
           <p:nvPr/>
         </p:nvPicPr>
         <p:blipFill>
-          <a:blip r:embed="rId1"/>
+          <a:blip r:embed="rId3"/>
           <a:stretch>
             <a:fillRect/>
           </a:stretch>
@@ -5858,7 +5838,7 @@
           <a:bodyPr wrap="square" lIns="0" tIns="0" rIns="0" bIns="0" rtlCol="0" anchor="t"/>
           <a:lstStyle/>
           <a:p>
-            <a:pPr indent="0" marL="0">
+            <a:pPr marL="0" indent="0">
               <a:buNone/>
             </a:pPr>
             <a:r>
@@ -5875,7 +5855,7 @@
             <a:endParaRPr lang="en-US" sz="3000" dirty="0"/>
           </a:p>
           <a:p>
-            <a:pPr indent="0" marL="0">
+            <a:pPr marL="0" indent="0">
               <a:buNone/>
             </a:pPr>
             <a:r>
@@ -5911,7 +5891,7 @@
           <a:bodyPr wrap="square" lIns="0" tIns="0" rIns="0" bIns="0" rtlCol="0" anchor="t"/>
           <a:lstStyle/>
           <a:p>
-            <a:pPr indent="0" marL="0">
+            <a:pPr marL="0" indent="0">
               <a:buNone/>
             </a:pPr>
             <a:r>
@@ -5928,7 +5908,7 @@
             <a:endParaRPr lang="en-US" sz="3000" dirty="0"/>
           </a:p>
           <a:p>
-            <a:pPr indent="0" marL="0">
+            <a:pPr marL="0" indent="0">
               <a:buNone/>
             </a:pPr>
             <a:r>
@@ -5962,13 +5942,20 @@
           </a:solidFill>
           <a:ln/>
           <a:effectLst>
-            <a:outerShdw sx="100000" sy="100000" kx="0" ky="0" algn="bl" rotWithShape="0" blurRad="88900" dist="38100" dir="8100000">
+            <a:outerShdw blurRad="88900" dist="38100" dir="8100000" algn="bl" rotWithShape="0">
               <a:srgbClr val="000000">
                 <a:alpha val="16000"/>
               </a:srgbClr>
             </a:outerShdw>
           </a:effectLst>
         </p:spPr>
+        <p:txBody>
+          <a:bodyPr/>
+          <a:lstStyle/>
+          <a:p>
+            <a:endParaRPr lang="el-GR"/>
+          </a:p>
+        </p:txBody>
       </p:sp>
       <p:sp>
         <p:nvSpPr>
@@ -5991,7 +5978,7 @@
           <a:bodyPr wrap="square" lIns="0" tIns="0" rIns="0" bIns="0" rtlCol="0" anchor="t"/>
           <a:lstStyle/>
           <a:p>
-            <a:pPr indent="0" marL="0">
+            <a:pPr marL="0" indent="0">
               <a:buNone/>
             </a:pPr>
             <a:r>
@@ -6008,7 +5995,7 @@
             <a:endParaRPr lang="en-US" sz="2200" dirty="0"/>
           </a:p>
           <a:p>
-            <a:pPr indent="0" marL="0">
+            <a:pPr marL="0" indent="0">
               <a:buNone/>
             </a:pPr>
             <a:r>
@@ -6022,7 +6009,7 @@
             <a:endParaRPr lang="en-US" sz="2200" dirty="0"/>
           </a:p>
           <a:p>
-            <a:pPr indent="0" marL="0">
+            <a:pPr marL="0" indent="0">
               <a:buNone/>
             </a:pPr>
             <a:r>
@@ -6058,7 +6045,7 @@
           <a:bodyPr wrap="square" lIns="0" tIns="0" rIns="0" bIns="0" rtlCol="0" anchor="ctr"/>
           <a:lstStyle/>
           <a:p>
-            <a:pPr algn="ctr" indent="0" marL="0">
+            <a:pPr marL="0" indent="0" algn="ctr">
               <a:buNone/>
             </a:pPr>
             <a:r>
@@ -6097,7 +6084,7 @@
           <a:bodyPr wrap="square" lIns="0" tIns="0" rIns="0" bIns="0" rtlCol="0" anchor="ctr"/>
           <a:lstStyle/>
           <a:p>
-            <a:pPr indent="0" marL="0">
+            <a:pPr marL="0" indent="0">
               <a:buNone/>
             </a:pPr>
             <a:r>
@@ -6136,7 +6123,7 @@
           <a:bodyPr wrap="square" lIns="0" tIns="0" rIns="0" bIns="0" rtlCol="0" anchor="ctr"/>
           <a:lstStyle/>
           <a:p>
-            <a:pPr algn="r" indent="0" marL="0">
+            <a:pPr marL="0" indent="0" algn="r">
               <a:buNone/>
             </a:pPr>
             <a:r>
@@ -6170,6 +6157,7 @@
         <a:solidFill>
           <a:srgbClr val="F4F6F9"/>
         </a:solidFill>
+        <a:effectLst/>
       </p:bgPr>
     </p:bg>
     <p:spTree>
@@ -6205,6 +6193,13 @@
           </a:solidFill>
           <a:ln/>
         </p:spPr>
+        <p:txBody>
+          <a:bodyPr/>
+          <a:lstStyle/>
+          <a:p>
+            <a:endParaRPr lang="el-GR"/>
+          </a:p>
+        </p:txBody>
       </p:sp>
       <p:sp>
         <p:nvSpPr>
@@ -6227,6 +6222,13 @@
           </a:solidFill>
           <a:ln/>
         </p:spPr>
+        <p:txBody>
+          <a:bodyPr/>
+          <a:lstStyle/>
+          <a:p>
+            <a:endParaRPr lang="el-GR"/>
+          </a:p>
+        </p:txBody>
       </p:sp>
       <p:sp>
         <p:nvSpPr>
@@ -6249,11 +6251,11 @@
           <a:bodyPr wrap="square" lIns="0" tIns="0" rIns="0" bIns="0" rtlCol="0" anchor="ctr"/>
           <a:lstStyle/>
           <a:p>
-            <a:pPr algn="ctr" indent="0" marL="0">
-              <a:buNone/>
-            </a:pPr>
-            <a:r>
-              <a:rPr lang="en-US" sz="1000" b="1" spc="100" kern="0" dirty="0">
+            <a:pPr marL="0" indent="0" algn="ctr">
+              <a:buNone/>
+            </a:pPr>
+            <a:r>
+              <a:rPr lang="en-US" sz="1000" b="1" kern="0" spc="100" dirty="0">
                 <a:solidFill>
                   <a:srgbClr val="FFFFFF"/>
                 </a:solidFill>
@@ -6288,7 +6290,7 @@
           <a:bodyPr wrap="square" lIns="0" tIns="0" rIns="0" bIns="0" rtlCol="0" anchor="ctr"/>
           <a:lstStyle/>
           <a:p>
-            <a:pPr indent="0" marL="0">
+            <a:pPr marL="0" indent="0">
               <a:buNone/>
             </a:pPr>
             <a:r>
@@ -6330,13 +6332,20 @@
             <a:prstDash val="solid"/>
           </a:ln>
           <a:effectLst>
-            <a:outerShdw sx="100000" sy="100000" kx="0" ky="0" algn="bl" rotWithShape="0" blurRad="88900" dist="38100" dir="8100000">
+            <a:outerShdw blurRad="88900" dist="38100" dir="8100000" algn="bl" rotWithShape="0">
               <a:srgbClr val="000000">
                 <a:alpha val="16000"/>
               </a:srgbClr>
             </a:outerShdw>
           </a:effectLst>
         </p:spPr>
+        <p:txBody>
+          <a:bodyPr/>
+          <a:lstStyle/>
+          <a:p>
+            <a:endParaRPr lang="el-GR"/>
+          </a:p>
+        </p:txBody>
       </p:sp>
       <p:sp>
         <p:nvSpPr>
@@ -6357,6 +6366,13 @@
           </a:solidFill>
           <a:ln/>
         </p:spPr>
+        <p:txBody>
+          <a:bodyPr/>
+          <a:lstStyle/>
+          <a:p>
+            <a:endParaRPr lang="el-GR"/>
+          </a:p>
+        </p:txBody>
       </p:sp>
       <p:sp>
         <p:nvSpPr>
@@ -6379,7 +6395,7 @@
           <a:bodyPr wrap="square" lIns="0" tIns="0" rIns="0" bIns="0" rtlCol="0" anchor="ctr"/>
           <a:lstStyle/>
           <a:p>
-            <a:pPr indent="0" marL="0">
+            <a:pPr marL="0" indent="0">
               <a:buNone/>
             </a:pPr>
             <a:r>
@@ -6393,9 +6409,6 @@
               </a:rPr>
               <a:t>Regime 1  </a:t>
             </a:r>
-            <a:pPr indent="0" marL="0">
-              <a:buNone/>
-            </a:pPr>
             <a:r>
               <a:rPr lang="en-US" sz="1400" b="1" dirty="0">
                 <a:solidFill>
@@ -6429,7 +6442,7 @@
           <a:bodyPr wrap="square" lIns="0" tIns="0" rIns="0" bIns="0" rtlCol="0" anchor="ctr"/>
           <a:lstStyle/>
           <a:p>
-            <a:pPr indent="0" marL="0">
+            <a:pPr marL="0" indent="0">
               <a:buNone/>
             </a:pPr>
             <a:r>
@@ -6471,13 +6484,20 @@
             <a:prstDash val="solid"/>
           </a:ln>
           <a:effectLst>
-            <a:outerShdw sx="100000" sy="100000" kx="0" ky="0" algn="bl" rotWithShape="0" blurRad="88900" dist="38100" dir="8100000">
+            <a:outerShdw blurRad="88900" dist="38100" dir="8100000" algn="bl" rotWithShape="0">
               <a:srgbClr val="000000">
                 <a:alpha val="16000"/>
               </a:srgbClr>
             </a:outerShdw>
           </a:effectLst>
         </p:spPr>
+        <p:txBody>
+          <a:bodyPr/>
+          <a:lstStyle/>
+          <a:p>
+            <a:endParaRPr lang="el-GR"/>
+          </a:p>
+        </p:txBody>
       </p:sp>
       <p:sp>
         <p:nvSpPr>
@@ -6498,6 +6518,13 @@
           </a:solidFill>
           <a:ln/>
         </p:spPr>
+        <p:txBody>
+          <a:bodyPr/>
+          <a:lstStyle/>
+          <a:p>
+            <a:endParaRPr lang="el-GR"/>
+          </a:p>
+        </p:txBody>
       </p:sp>
       <p:sp>
         <p:nvSpPr>
@@ -6520,7 +6547,7 @@
           <a:bodyPr wrap="square" lIns="0" tIns="0" rIns="0" bIns="0" rtlCol="0" anchor="ctr"/>
           <a:lstStyle/>
           <a:p>
-            <a:pPr indent="0" marL="0">
+            <a:pPr marL="0" indent="0">
               <a:buNone/>
             </a:pPr>
             <a:r>
@@ -6534,9 +6561,6 @@
               </a:rPr>
               <a:t>Regime 1b  </a:t>
             </a:r>
-            <a:pPr indent="0" marL="0">
-              <a:buNone/>
-            </a:pPr>
             <a:r>
               <a:rPr lang="en-US" sz="1400" b="1" dirty="0">
                 <a:solidFill>
@@ -6570,7 +6594,7 @@
           <a:bodyPr wrap="square" lIns="0" tIns="0" rIns="0" bIns="0" rtlCol="0" anchor="ctr"/>
           <a:lstStyle/>
           <a:p>
-            <a:pPr indent="0" marL="0">
+            <a:pPr marL="0" indent="0">
               <a:buNone/>
             </a:pPr>
             <a:r>
@@ -6612,13 +6636,20 @@
             <a:prstDash val="solid"/>
           </a:ln>
           <a:effectLst>
-            <a:outerShdw sx="100000" sy="100000" kx="0" ky="0" algn="bl" rotWithShape="0" blurRad="88900" dist="38100" dir="8100000">
+            <a:outerShdw blurRad="88900" dist="38100" dir="8100000" algn="bl" rotWithShape="0">
               <a:srgbClr val="000000">
                 <a:alpha val="16000"/>
               </a:srgbClr>
             </a:outerShdw>
           </a:effectLst>
         </p:spPr>
+        <p:txBody>
+          <a:bodyPr/>
+          <a:lstStyle/>
+          <a:p>
+            <a:endParaRPr lang="el-GR"/>
+          </a:p>
+        </p:txBody>
       </p:sp>
       <p:sp>
         <p:nvSpPr>
@@ -6639,6 +6670,13 @@
           </a:solidFill>
           <a:ln/>
         </p:spPr>
+        <p:txBody>
+          <a:bodyPr/>
+          <a:lstStyle/>
+          <a:p>
+            <a:endParaRPr lang="el-GR"/>
+          </a:p>
+        </p:txBody>
       </p:sp>
       <p:sp>
         <p:nvSpPr>
@@ -6661,7 +6699,7 @@
           <a:bodyPr wrap="square" lIns="0" tIns="0" rIns="0" bIns="0" rtlCol="0" anchor="ctr"/>
           <a:lstStyle/>
           <a:p>
-            <a:pPr indent="0" marL="0">
+            <a:pPr marL="0" indent="0">
               <a:buNone/>
             </a:pPr>
             <a:r>
@@ -6675,9 +6713,6 @@
               </a:rPr>
               <a:t>Regime 2  </a:t>
             </a:r>
-            <a:pPr indent="0" marL="0">
-              <a:buNone/>
-            </a:pPr>
             <a:r>
               <a:rPr lang="en-US" sz="1400" b="1" dirty="0">
                 <a:solidFill>
@@ -6711,7 +6746,7 @@
           <a:bodyPr wrap="square" lIns="0" tIns="0" rIns="0" bIns="0" rtlCol="0" anchor="ctr"/>
           <a:lstStyle/>
           <a:p>
-            <a:pPr indent="0" marL="0">
+            <a:pPr marL="0" indent="0">
               <a:buNone/>
             </a:pPr>
             <a:r>
@@ -6753,13 +6788,20 @@
             <a:prstDash val="solid"/>
           </a:ln>
           <a:effectLst>
-            <a:outerShdw sx="100000" sy="100000" kx="0" ky="0" algn="bl" rotWithShape="0" blurRad="88900" dist="38100" dir="8100000">
+            <a:outerShdw blurRad="88900" dist="38100" dir="8100000" algn="bl" rotWithShape="0">
               <a:srgbClr val="000000">
                 <a:alpha val="16000"/>
               </a:srgbClr>
             </a:outerShdw>
           </a:effectLst>
         </p:spPr>
+        <p:txBody>
+          <a:bodyPr/>
+          <a:lstStyle/>
+          <a:p>
+            <a:endParaRPr lang="el-GR"/>
+          </a:p>
+        </p:txBody>
       </p:sp>
       <p:sp>
         <p:nvSpPr>
@@ -6780,6 +6822,13 @@
           </a:solidFill>
           <a:ln/>
         </p:spPr>
+        <p:txBody>
+          <a:bodyPr/>
+          <a:lstStyle/>
+          <a:p>
+            <a:endParaRPr lang="el-GR"/>
+          </a:p>
+        </p:txBody>
       </p:sp>
       <p:sp>
         <p:nvSpPr>
@@ -6802,7 +6851,7 @@
           <a:bodyPr wrap="square" lIns="0" tIns="0" rIns="0" bIns="0" rtlCol="0" anchor="ctr"/>
           <a:lstStyle/>
           <a:p>
-            <a:pPr indent="0" marL="0">
+            <a:pPr marL="0" indent="0">
               <a:buNone/>
             </a:pPr>
             <a:r>
@@ -6816,9 +6865,6 @@
               </a:rPr>
               <a:t>Regime 3  </a:t>
             </a:r>
-            <a:pPr indent="0" marL="0">
-              <a:buNone/>
-            </a:pPr>
             <a:r>
               <a:rPr lang="en-US" sz="1400" b="1" dirty="0">
                 <a:solidFill>
@@ -6852,7 +6898,7 @@
           <a:bodyPr wrap="square" lIns="0" tIns="0" rIns="0" bIns="0" rtlCol="0" anchor="ctr"/>
           <a:lstStyle/>
           <a:p>
-            <a:pPr indent="0" marL="0">
+            <a:pPr marL="0" indent="0">
               <a:buNone/>
             </a:pPr>
             <a:r>
@@ -6891,7 +6937,7 @@
           <a:bodyPr wrap="square" lIns="0" tIns="0" rIns="0" bIns="0" rtlCol="0" anchor="ctr"/>
           <a:lstStyle/>
           <a:p>
-            <a:pPr indent="0" marL="0">
+            <a:pPr marL="0" indent="0">
               <a:buNone/>
             </a:pPr>
             <a:r>
@@ -6930,7 +6976,7 @@
           <a:bodyPr wrap="square" lIns="0" tIns="0" rIns="0" bIns="0" rtlCol="0" anchor="ctr"/>
           <a:lstStyle/>
           <a:p>
-            <a:pPr indent="0" marL="0">
+            <a:pPr marL="0" indent="0">
               <a:buNone/>
             </a:pPr>
             <a:r>
@@ -6969,7 +7015,7 @@
           <a:bodyPr wrap="square" lIns="0" tIns="0" rIns="0" bIns="0" rtlCol="0" anchor="ctr"/>
           <a:lstStyle/>
           <a:p>
-            <a:pPr algn="r" indent="0" marL="0">
+            <a:pPr marL="0" indent="0" algn="r">
               <a:buNone/>
             </a:pPr>
             <a:r>
@@ -7003,6 +7049,7 @@
         <a:solidFill>
           <a:srgbClr val="F4F6F9"/>
         </a:solidFill>
+        <a:effectLst/>
       </p:bgPr>
     </p:bg>
     <p:spTree>
@@ -7038,6 +7085,13 @@
           </a:solidFill>
           <a:ln/>
         </p:spPr>
+        <p:txBody>
+          <a:bodyPr/>
+          <a:lstStyle/>
+          <a:p>
+            <a:endParaRPr lang="el-GR"/>
+          </a:p>
+        </p:txBody>
       </p:sp>
       <p:sp>
         <p:nvSpPr>
@@ -7060,6 +7114,13 @@
           </a:solidFill>
           <a:ln/>
         </p:spPr>
+        <p:txBody>
+          <a:bodyPr/>
+          <a:lstStyle/>
+          <a:p>
+            <a:endParaRPr lang="el-GR"/>
+          </a:p>
+        </p:txBody>
       </p:sp>
       <p:sp>
         <p:nvSpPr>
@@ -7082,11 +7143,11 @@
           <a:bodyPr wrap="square" lIns="0" tIns="0" rIns="0" bIns="0" rtlCol="0" anchor="ctr"/>
           <a:lstStyle/>
           <a:p>
-            <a:pPr algn="ctr" indent="0" marL="0">
-              <a:buNone/>
-            </a:pPr>
-            <a:r>
-              <a:rPr lang="en-US" sz="1000" b="1" spc="100" kern="0" dirty="0">
+            <a:pPr marL="0" indent="0" algn="ctr">
+              <a:buNone/>
+            </a:pPr>
+            <a:r>
+              <a:rPr lang="en-US" sz="1000" b="1" kern="0" spc="100" dirty="0">
                 <a:solidFill>
                   <a:srgbClr val="FFFFFF"/>
                 </a:solidFill>
@@ -7121,7 +7182,7 @@
           <a:bodyPr wrap="square" lIns="0" tIns="0" rIns="0" bIns="0" rtlCol="0" anchor="ctr"/>
           <a:lstStyle/>
           <a:p>
-            <a:pPr indent="0" marL="0">
+            <a:pPr marL="0" indent="0">
               <a:buNone/>
             </a:pPr>
             <a:r>
@@ -7163,13 +7224,20 @@
             <a:prstDash val="solid"/>
           </a:ln>
           <a:effectLst>
-            <a:outerShdw sx="100000" sy="100000" kx="0" ky="0" algn="bl" rotWithShape="0" blurRad="88900" dist="38100" dir="8100000">
+            <a:outerShdw blurRad="88900" dist="38100" dir="8100000" algn="bl" rotWithShape="0">
               <a:srgbClr val="000000">
                 <a:alpha val="16000"/>
               </a:srgbClr>
             </a:outerShdw>
           </a:effectLst>
         </p:spPr>
+        <p:txBody>
+          <a:bodyPr/>
+          <a:lstStyle/>
+          <a:p>
+            <a:endParaRPr lang="el-GR"/>
+          </a:p>
+        </p:txBody>
       </p:sp>
       <p:sp>
         <p:nvSpPr>
@@ -7190,6 +7258,13 @@
           </a:solidFill>
           <a:ln/>
         </p:spPr>
+        <p:txBody>
+          <a:bodyPr/>
+          <a:lstStyle/>
+          <a:p>
+            <a:endParaRPr lang="el-GR"/>
+          </a:p>
+        </p:txBody>
       </p:sp>
       <p:sp>
         <p:nvSpPr>
@@ -7212,7 +7287,7 @@
           <a:bodyPr wrap="square" lIns="0" tIns="0" rIns="0" bIns="0" rtlCol="0" anchor="ctr"/>
           <a:lstStyle/>
           <a:p>
-            <a:pPr indent="0" marL="0">
+            <a:pPr marL="0" indent="0">
               <a:buNone/>
             </a:pPr>
             <a:r>
@@ -7223,9 +7298,6 @@
               </a:rPr>
               <a:t>MODEL A  </a:t>
             </a:r>
-            <a:pPr indent="0" marL="0">
-              <a:buNone/>
-            </a:pPr>
             <a:r>
               <a:rPr lang="en-US" sz="1500" b="1" dirty="0">
                 <a:solidFill>
@@ -7371,13 +7443,20 @@
             <a:prstDash val="solid"/>
           </a:ln>
           <a:effectLst>
-            <a:outerShdw sx="100000" sy="100000" kx="0" ky="0" algn="bl" rotWithShape="0" blurRad="88900" dist="38100" dir="8100000">
+            <a:outerShdw blurRad="88900" dist="38100" dir="8100000" algn="bl" rotWithShape="0">
               <a:srgbClr val="000000">
                 <a:alpha val="16000"/>
               </a:srgbClr>
             </a:outerShdw>
           </a:effectLst>
         </p:spPr>
+        <p:txBody>
+          <a:bodyPr/>
+          <a:lstStyle/>
+          <a:p>
+            <a:endParaRPr lang="el-GR"/>
+          </a:p>
+        </p:txBody>
       </p:sp>
       <p:sp>
         <p:nvSpPr>
@@ -7398,6 +7477,13 @@
           </a:solidFill>
           <a:ln/>
         </p:spPr>
+        <p:txBody>
+          <a:bodyPr/>
+          <a:lstStyle/>
+          <a:p>
+            <a:endParaRPr lang="el-GR"/>
+          </a:p>
+        </p:txBody>
       </p:sp>
       <p:sp>
         <p:nvSpPr>
@@ -7420,7 +7506,7 @@
           <a:bodyPr wrap="square" lIns="0" tIns="0" rIns="0" bIns="0" rtlCol="0" anchor="ctr"/>
           <a:lstStyle/>
           <a:p>
-            <a:pPr indent="0" marL="0">
+            <a:pPr marL="0" indent="0">
               <a:buNone/>
             </a:pPr>
             <a:r>
@@ -7431,9 +7517,6 @@
               </a:rPr>
               <a:t>MODEL B  </a:t>
             </a:r>
-            <a:pPr indent="0" marL="0">
-              <a:buNone/>
-            </a:pPr>
             <a:r>
               <a:rPr lang="en-US" sz="1500" b="1" dirty="0">
                 <a:solidFill>
@@ -7576,7 +7659,7 @@
           <a:bodyPr wrap="square" lIns="0" tIns="0" rIns="0" bIns="0" rtlCol="0" anchor="ctr"/>
           <a:lstStyle/>
           <a:p>
-            <a:pPr indent="0" marL="0">
+            <a:pPr marL="0" indent="0">
               <a:buNone/>
             </a:pPr>
             <a:r>
@@ -7615,7 +7698,7 @@
           <a:bodyPr wrap="square" lIns="0" tIns="0" rIns="0" bIns="0" rtlCol="0" anchor="ctr"/>
           <a:lstStyle/>
           <a:p>
-            <a:pPr indent="0" marL="0">
+            <a:pPr marL="0" indent="0">
               <a:buNone/>
             </a:pPr>
             <a:r>
@@ -7654,7 +7737,7 @@
           <a:bodyPr wrap="square" lIns="0" tIns="0" rIns="0" bIns="0" rtlCol="0" anchor="ctr"/>
           <a:lstStyle/>
           <a:p>
-            <a:pPr algn="r" indent="0" marL="0">
+            <a:pPr marL="0" indent="0" algn="r">
               <a:buNone/>
             </a:pPr>
             <a:r>
@@ -7688,6 +7771,7 @@
         <a:solidFill>
           <a:srgbClr val="F4F6F9"/>
         </a:solidFill>
+        <a:effectLst/>
       </p:bgPr>
     </p:bg>
     <p:spTree>
@@ -7723,6 +7807,13 @@
           </a:solidFill>
           <a:ln/>
         </p:spPr>
+        <p:txBody>
+          <a:bodyPr/>
+          <a:lstStyle/>
+          <a:p>
+            <a:endParaRPr lang="el-GR"/>
+          </a:p>
+        </p:txBody>
       </p:sp>
       <p:sp>
         <p:nvSpPr>
@@ -7745,6 +7836,13 @@
           </a:solidFill>
           <a:ln/>
         </p:spPr>
+        <p:txBody>
+          <a:bodyPr/>
+          <a:lstStyle/>
+          <a:p>
+            <a:endParaRPr lang="el-GR"/>
+          </a:p>
+        </p:txBody>
       </p:sp>
       <p:sp>
         <p:nvSpPr>
@@ -7767,11 +7865,11 @@
           <a:bodyPr wrap="square" lIns="0" tIns="0" rIns="0" bIns="0" rtlCol="0" anchor="ctr"/>
           <a:lstStyle/>
           <a:p>
-            <a:pPr algn="ctr" indent="0" marL="0">
-              <a:buNone/>
-            </a:pPr>
-            <a:r>
-              <a:rPr lang="en-US" sz="1000" b="1" spc="100" kern="0" dirty="0">
+            <a:pPr marL="0" indent="0" algn="ctr">
+              <a:buNone/>
+            </a:pPr>
+            <a:r>
+              <a:rPr lang="en-US" sz="1000" b="1" kern="0" spc="100" dirty="0">
                 <a:solidFill>
                   <a:srgbClr val="FFFFFF"/>
                 </a:solidFill>
@@ -7806,7 +7904,7 @@
           <a:bodyPr wrap="square" lIns="0" tIns="0" rIns="0" bIns="0" rtlCol="0" anchor="ctr"/>
           <a:lstStyle/>
           <a:p>
-            <a:pPr indent="0" marL="0">
+            <a:pPr marL="0" indent="0">
               <a:buNone/>
             </a:pPr>
             <a:r>
@@ -7848,24 +7946,31 @@
             <a:prstDash val="solid"/>
           </a:ln>
           <a:effectLst>
-            <a:outerShdw sx="100000" sy="100000" kx="0" ky="0" algn="bl" rotWithShape="0" blurRad="88900" dist="38100" dir="8100000">
+            <a:outerShdw blurRad="88900" dist="38100" dir="8100000" algn="bl" rotWithShape="0">
               <a:srgbClr val="000000">
                 <a:alpha val="16000"/>
               </a:srgbClr>
             </a:outerShdw>
           </a:effectLst>
         </p:spPr>
+        <p:txBody>
+          <a:bodyPr/>
+          <a:lstStyle/>
+          <a:p>
+            <a:endParaRPr lang="el-GR"/>
+          </a:p>
+        </p:txBody>
       </p:sp>
       <p:pic>
         <p:nvPicPr>
-          <p:cNvPr id="7" name="Image 0" descr="C:\Users\dimit\Desktop\GEORGAML\ToolFinder\experiments\results\figures\fig_main_results.png">    </p:cNvPr>
+          <p:cNvPr id="7" name="Image 0" descr="C:\Users\dimit\Desktop\GEORGAML\ToolFinder\experiments\results\figures\fig_main_results.png"/>
           <p:cNvPicPr>
             <a:picLocks noChangeAspect="1"/>
           </p:cNvPicPr>
           <p:nvPr/>
         </p:nvPicPr>
         <p:blipFill>
-          <a:blip r:embed="rId1"/>
+          <a:blip r:embed="rId3"/>
           <a:stretch>
             <a:fillRect/>
           </a:stretch>
@@ -7904,13 +8009,20 @@
             <a:prstDash val="solid"/>
           </a:ln>
           <a:effectLst>
-            <a:outerShdw sx="100000" sy="100000" kx="0" ky="0" algn="bl" rotWithShape="0" blurRad="88900" dist="38100" dir="8100000">
+            <a:outerShdw blurRad="88900" dist="38100" dir="8100000" algn="bl" rotWithShape="0">
               <a:srgbClr val="000000">
                 <a:alpha val="16000"/>
               </a:srgbClr>
             </a:outerShdw>
           </a:effectLst>
         </p:spPr>
+        <p:txBody>
+          <a:bodyPr/>
+          <a:lstStyle/>
+          <a:p>
+            <a:endParaRPr lang="el-GR"/>
+          </a:p>
+        </p:txBody>
       </p:sp>
       <p:sp>
         <p:nvSpPr>
@@ -7931,6 +8043,13 @@
           </a:solidFill>
           <a:ln/>
         </p:spPr>
+        <p:txBody>
+          <a:bodyPr/>
+          <a:lstStyle/>
+          <a:p>
+            <a:endParaRPr lang="el-GR"/>
+          </a:p>
+        </p:txBody>
       </p:sp>
       <p:sp>
         <p:nvSpPr>
@@ -7953,7 +8072,7 @@
           <a:bodyPr wrap="square" lIns="0" tIns="0" rIns="0" bIns="0" rtlCol="0" anchor="ctr"/>
           <a:lstStyle/>
           <a:p>
-            <a:pPr indent="0" marL="0">
+            <a:pPr marL="0" indent="0">
               <a:buNone/>
             </a:pPr>
             <a:r>
@@ -7992,7 +8111,7 @@
           <a:bodyPr wrap="square" lIns="0" tIns="0" rIns="0" bIns="0" rtlCol="0" anchor="t"/>
           <a:lstStyle/>
           <a:p>
-            <a:pPr indent="0" marL="0">
+            <a:pPr marL="0" indent="0">
               <a:buNone/>
             </a:pPr>
             <a:r>
@@ -8034,13 +8153,20 @@
             <a:prstDash val="solid"/>
           </a:ln>
           <a:effectLst>
-            <a:outerShdw sx="100000" sy="100000" kx="0" ky="0" algn="bl" rotWithShape="0" blurRad="88900" dist="38100" dir="8100000">
+            <a:outerShdw blurRad="88900" dist="38100" dir="8100000" algn="bl" rotWithShape="0">
               <a:srgbClr val="000000">
                 <a:alpha val="16000"/>
               </a:srgbClr>
             </a:outerShdw>
           </a:effectLst>
         </p:spPr>
+        <p:txBody>
+          <a:bodyPr/>
+          <a:lstStyle/>
+          <a:p>
+            <a:endParaRPr lang="el-GR"/>
+          </a:p>
+        </p:txBody>
       </p:sp>
       <p:sp>
         <p:nvSpPr>
@@ -8061,6 +8187,13 @@
           </a:solidFill>
           <a:ln/>
         </p:spPr>
+        <p:txBody>
+          <a:bodyPr/>
+          <a:lstStyle/>
+          <a:p>
+            <a:endParaRPr lang="el-GR"/>
+          </a:p>
+        </p:txBody>
       </p:sp>
       <p:sp>
         <p:nvSpPr>
@@ -8083,7 +8216,7 @@
           <a:bodyPr wrap="square" lIns="0" tIns="0" rIns="0" bIns="0" rtlCol="0" anchor="ctr"/>
           <a:lstStyle/>
           <a:p>
-            <a:pPr indent="0" marL="0">
+            <a:pPr marL="0" indent="0">
               <a:buNone/>
             </a:pPr>
             <a:r>
@@ -8122,7 +8255,7 @@
           <a:bodyPr wrap="square" lIns="0" tIns="0" rIns="0" bIns="0" rtlCol="0" anchor="t"/>
           <a:lstStyle/>
           <a:p>
-            <a:pPr indent="0" marL="0">
+            <a:pPr marL="0" indent="0">
               <a:buNone/>
             </a:pPr>
             <a:r>
@@ -8161,7 +8294,7 @@
           <a:bodyPr wrap="square" lIns="0" tIns="0" rIns="0" bIns="0" rtlCol="0" anchor="ctr"/>
           <a:lstStyle/>
           <a:p>
-            <a:pPr indent="0" marL="0">
+            <a:pPr marL="0" indent="0">
               <a:buNone/>
             </a:pPr>
             <a:r>
@@ -8200,7 +8333,7 @@
           <a:bodyPr wrap="square" lIns="0" tIns="0" rIns="0" bIns="0" rtlCol="0" anchor="ctr"/>
           <a:lstStyle/>
           <a:p>
-            <a:pPr indent="0" marL="0">
+            <a:pPr marL="0" indent="0">
               <a:buNone/>
             </a:pPr>
             <a:r>
@@ -8239,7 +8372,7 @@
           <a:bodyPr wrap="square" lIns="0" tIns="0" rIns="0" bIns="0" rtlCol="0" anchor="ctr"/>
           <a:lstStyle/>
           <a:p>
-            <a:pPr algn="r" indent="0" marL="0">
+            <a:pPr marL="0" indent="0" algn="r">
               <a:buNone/>
             </a:pPr>
             <a:r>
@@ -8273,6 +8406,7 @@
         <a:solidFill>
           <a:srgbClr val="F4F6F9"/>
         </a:solidFill>
+        <a:effectLst/>
       </p:bgPr>
     </p:bg>
     <p:spTree>
@@ -8308,6 +8442,13 @@
           </a:solidFill>
           <a:ln/>
         </p:spPr>
+        <p:txBody>
+          <a:bodyPr/>
+          <a:lstStyle/>
+          <a:p>
+            <a:endParaRPr lang="el-GR"/>
+          </a:p>
+        </p:txBody>
       </p:sp>
       <p:sp>
         <p:nvSpPr>
@@ -8330,6 +8471,13 @@
           </a:solidFill>
           <a:ln/>
         </p:spPr>
+        <p:txBody>
+          <a:bodyPr/>
+          <a:lstStyle/>
+          <a:p>
+            <a:endParaRPr lang="el-GR"/>
+          </a:p>
+        </p:txBody>
       </p:sp>
       <p:sp>
         <p:nvSpPr>
@@ -8352,11 +8500,11 @@
           <a:bodyPr wrap="square" lIns="0" tIns="0" rIns="0" bIns="0" rtlCol="0" anchor="ctr"/>
           <a:lstStyle/>
           <a:p>
-            <a:pPr algn="ctr" indent="0" marL="0">
-              <a:buNone/>
-            </a:pPr>
-            <a:r>
-              <a:rPr lang="en-US" sz="1000" b="1" spc="100" kern="0" dirty="0">
+            <a:pPr marL="0" indent="0" algn="ctr">
+              <a:buNone/>
+            </a:pPr>
+            <a:r>
+              <a:rPr lang="en-US" sz="1000" b="1" kern="0" spc="100" dirty="0">
                 <a:solidFill>
                   <a:srgbClr val="FFFFFF"/>
                 </a:solidFill>
@@ -8391,7 +8539,7 @@
           <a:bodyPr wrap="square" lIns="0" tIns="0" rIns="0" bIns="0" rtlCol="0" anchor="ctr"/>
           <a:lstStyle/>
           <a:p>
-            <a:pPr indent="0" marL="0">
+            <a:pPr marL="0" indent="0">
               <a:buNone/>
             </a:pPr>
             <a:r>
@@ -8403,7 +8551,7 @@
                 <a:ea typeface="Georgia" pitchFamily="34" charset="-122"/>
                 <a:cs typeface="Georgia" pitchFamily="34" charset="-120"/>
               </a:rPr>
-              <a:t>Why route at all? Versus giving the LLM every tool</a:t>
+              <a:t>Why route at all? Router Vs giving the LLM every tool</a:t>
             </a:r>
             <a:endParaRPr lang="en-US" sz="2600" dirty="0"/>
           </a:p>
@@ -8433,13 +8581,20 @@
             <a:prstDash val="solid"/>
           </a:ln>
           <a:effectLst>
-            <a:outerShdw sx="100000" sy="100000" kx="0" ky="0" algn="bl" rotWithShape="0" blurRad="88900" dist="38100" dir="8100000">
+            <a:outerShdw blurRad="88900" dist="38100" dir="8100000" algn="bl" rotWithShape="0">
               <a:srgbClr val="000000">
                 <a:alpha val="16000"/>
               </a:srgbClr>
             </a:outerShdw>
           </a:effectLst>
         </p:spPr>
+        <p:txBody>
+          <a:bodyPr/>
+          <a:lstStyle/>
+          <a:p>
+            <a:endParaRPr lang="el-GR"/>
+          </a:p>
+        </p:txBody>
       </p:sp>
       <p:sp>
         <p:nvSpPr>
@@ -8460,6 +8615,13 @@
           </a:solidFill>
           <a:ln/>
         </p:spPr>
+        <p:txBody>
+          <a:bodyPr/>
+          <a:lstStyle/>
+          <a:p>
+            <a:endParaRPr lang="el-GR"/>
+          </a:p>
+        </p:txBody>
       </p:sp>
       <p:sp>
         <p:nvSpPr>
@@ -8482,7 +8644,7 @@
           <a:bodyPr wrap="square" lIns="0" tIns="0" rIns="0" bIns="0" rtlCol="0" anchor="ctr"/>
           <a:lstStyle/>
           <a:p>
-            <a:pPr indent="0" marL="0">
+            <a:pPr marL="0" indent="0">
               <a:buNone/>
             </a:pPr>
             <a:r>
@@ -8521,7 +8683,7 @@
           <a:bodyPr wrap="square" lIns="0" tIns="0" rIns="0" bIns="0" rtlCol="0" anchor="t"/>
           <a:lstStyle/>
           <a:p>
-            <a:pPr indent="0" marL="0">
+            <a:pPr marL="0" indent="0">
               <a:buNone/>
             </a:pPr>
             <a:r>
@@ -8563,13 +8725,20 @@
             <a:prstDash val="solid"/>
           </a:ln>
           <a:effectLst>
-            <a:outerShdw sx="100000" sy="100000" kx="0" ky="0" algn="bl" rotWithShape="0" blurRad="88900" dist="38100" dir="8100000">
+            <a:outerShdw blurRad="88900" dist="38100" dir="8100000" algn="bl" rotWithShape="0">
               <a:srgbClr val="000000">
                 <a:alpha val="16000"/>
               </a:srgbClr>
             </a:outerShdw>
           </a:effectLst>
         </p:spPr>
+        <p:txBody>
+          <a:bodyPr/>
+          <a:lstStyle/>
+          <a:p>
+            <a:endParaRPr lang="el-GR"/>
+          </a:p>
+        </p:txBody>
       </p:sp>
       <p:sp>
         <p:nvSpPr>
@@ -8590,6 +8759,13 @@
           </a:solidFill>
           <a:ln/>
         </p:spPr>
+        <p:txBody>
+          <a:bodyPr/>
+          <a:lstStyle/>
+          <a:p>
+            <a:endParaRPr lang="el-GR"/>
+          </a:p>
+        </p:txBody>
       </p:sp>
       <p:sp>
         <p:nvSpPr>
@@ -8612,7 +8788,7 @@
           <a:bodyPr wrap="square" lIns="0" tIns="0" rIns="0" bIns="0" rtlCol="0" anchor="ctr"/>
           <a:lstStyle/>
           <a:p>
-            <a:pPr indent="0" marL="0">
+            <a:pPr marL="0" indent="0">
               <a:buNone/>
             </a:pPr>
             <a:r>
@@ -8651,7 +8827,7 @@
           <a:bodyPr wrap="square" lIns="0" tIns="0" rIns="0" bIns="0" rtlCol="0" anchor="t"/>
           <a:lstStyle/>
           <a:p>
-            <a:pPr indent="0" marL="0">
+            <a:pPr marL="0" indent="0">
               <a:buNone/>
             </a:pPr>
             <a:r>
@@ -8693,17 +8869,24 @@
             <a:prstDash val="solid"/>
           </a:ln>
           <a:effectLst>
-            <a:outerShdw sx="100000" sy="100000" kx="0" ky="0" algn="bl" rotWithShape="0" blurRad="88900" dist="38100" dir="8100000">
+            <a:outerShdw blurRad="88900" dist="38100" dir="8100000" algn="bl" rotWithShape="0">
               <a:srgbClr val="000000">
                 <a:alpha val="16000"/>
               </a:srgbClr>
             </a:outerShdw>
           </a:effectLst>
         </p:spPr>
+        <p:txBody>
+          <a:bodyPr/>
+          <a:lstStyle/>
+          <a:p>
+            <a:endParaRPr lang="el-GR"/>
+          </a:p>
+        </p:txBody>
       </p:sp>
       <p:graphicFrame>
         <p:nvGraphicFramePr>
-          <p:cNvPr id="15" name="Chart 0" descr=""/>
+          <p:cNvPr id="15" name="Chart 0"/>
           <p:cNvGraphicFramePr/>
           <p:nvPr/>
         </p:nvGraphicFramePr>
@@ -8711,9 +8894,9 @@
           <a:off x="5943600" y="1664208"/>
           <a:ext cx="2697480" cy="2331720"/>
         </p:xfrm>
-        <a:graphic xmlns:a="http://schemas.openxmlformats.org/drawingml/2006/main">
+        <a:graphic>
           <a:graphicData uri="http://schemas.openxmlformats.org/drawingml/2006/chart">
-            <c:chart xmlns:c="http://schemas.openxmlformats.org/drawingml/2006/chart" r:id="rId1"/>
+            <c:chart xmlns:c="http://schemas.openxmlformats.org/drawingml/2006/chart" xmlns:r="http://schemas.openxmlformats.org/officeDocument/2006/relationships" r:id="rId3"/>
           </a:graphicData>
         </a:graphic>
       </p:graphicFrame>
@@ -8738,7 +8921,7 @@
           <a:bodyPr wrap="square" lIns="0" tIns="0" rIns="0" bIns="0" rtlCol="0" anchor="ctr"/>
           <a:lstStyle/>
           <a:p>
-            <a:pPr algn="ctr" indent="0" marL="0">
+            <a:pPr marL="0" indent="0" algn="ctr">
               <a:buNone/>
             </a:pPr>
             <a:r>
@@ -8777,7 +8960,7 @@
           <a:bodyPr wrap="square" lIns="0" tIns="0" rIns="0" bIns="0" rtlCol="0" anchor="ctr"/>
           <a:lstStyle/>
           <a:p>
-            <a:pPr indent="0" marL="0">
+            <a:pPr marL="0" indent="0">
               <a:buNone/>
             </a:pPr>
             <a:r>
@@ -8816,7 +8999,7 @@
           <a:bodyPr wrap="square" lIns="0" tIns="0" rIns="0" bIns="0" rtlCol="0" anchor="ctr"/>
           <a:lstStyle/>
           <a:p>
-            <a:pPr algn="r" indent="0" marL="0">
+            <a:pPr marL="0" indent="0" algn="r">
               <a:buNone/>
             </a:pPr>
             <a:r>
@@ -8850,6 +9033,7 @@
         <a:solidFill>
           <a:srgbClr val="F4F6F9"/>
         </a:solidFill>
+        <a:effectLst/>
       </p:bgPr>
     </p:bg>
     <p:spTree>
@@ -8885,6 +9069,13 @@
           </a:solidFill>
           <a:ln/>
         </p:spPr>
+        <p:txBody>
+          <a:bodyPr/>
+          <a:lstStyle/>
+          <a:p>
+            <a:endParaRPr lang="el-GR"/>
+          </a:p>
+        </p:txBody>
       </p:sp>
       <p:sp>
         <p:nvSpPr>
@@ -8907,6 +9098,13 @@
           </a:solidFill>
           <a:ln/>
         </p:spPr>
+        <p:txBody>
+          <a:bodyPr/>
+          <a:lstStyle/>
+          <a:p>
+            <a:endParaRPr lang="el-GR"/>
+          </a:p>
+        </p:txBody>
       </p:sp>
       <p:sp>
         <p:nvSpPr>
@@ -8929,11 +9127,11 @@
           <a:bodyPr wrap="square" lIns="0" tIns="0" rIns="0" bIns="0" rtlCol="0" anchor="ctr"/>
           <a:lstStyle/>
           <a:p>
-            <a:pPr algn="ctr" indent="0" marL="0">
-              <a:buNone/>
-            </a:pPr>
-            <a:r>
-              <a:rPr lang="en-US" sz="1000" b="1" spc="100" kern="0" dirty="0">
+            <a:pPr marL="0" indent="0" algn="ctr">
+              <a:buNone/>
+            </a:pPr>
+            <a:r>
+              <a:rPr lang="en-US" sz="1000" b="1" kern="0" spc="100" dirty="0">
                 <a:solidFill>
                   <a:srgbClr val="FFFFFF"/>
                 </a:solidFill>
@@ -8968,7 +9166,7 @@
           <a:bodyPr wrap="square" lIns="0" tIns="0" rIns="0" bIns="0" rtlCol="0" anchor="ctr"/>
           <a:lstStyle/>
           <a:p>
-            <a:pPr indent="0" marL="0">
+            <a:pPr marL="0" indent="0">
               <a:buNone/>
             </a:pPr>
             <a:r>
@@ -9010,24 +9208,31 @@
             <a:prstDash val="solid"/>
           </a:ln>
           <a:effectLst>
-            <a:outerShdw sx="100000" sy="100000" kx="0" ky="0" algn="bl" rotWithShape="0" blurRad="88900" dist="38100" dir="8100000">
+            <a:outerShdw blurRad="88900" dist="38100" dir="8100000" algn="bl" rotWithShape="0">
               <a:srgbClr val="000000">
                 <a:alpha val="16000"/>
               </a:srgbClr>
             </a:outerShdw>
           </a:effectLst>
         </p:spPr>
+        <p:txBody>
+          <a:bodyPr/>
+          <a:lstStyle/>
+          <a:p>
+            <a:endParaRPr lang="el-GR"/>
+          </a:p>
+        </p:txBody>
       </p:sp>
       <p:pic>
         <p:nvPicPr>
-          <p:cNvPr id="7" name="Image 0" descr="C:\Users\dimit\Desktop\GEORGAML\ToolFinder\experiments\results\figures\fig_loss_curves.png">    </p:cNvPr>
+          <p:cNvPr id="7" name="Image 0" descr="C:\Users\dimit\Desktop\GEORGAML\ToolFinder\experiments\results\figures\fig_loss_curves.png"/>
           <p:cNvPicPr>
             <a:picLocks noChangeAspect="1"/>
           </p:cNvPicPr>
           <p:nvPr/>
         </p:nvPicPr>
         <p:blipFill>
-          <a:blip r:embed="rId1"/>
+          <a:blip r:embed="rId3"/>
           <a:stretch>
             <a:fillRect/>
           </a:stretch>
@@ -9066,13 +9271,20 @@
             <a:prstDash val="solid"/>
           </a:ln>
           <a:effectLst>
-            <a:outerShdw sx="100000" sy="100000" kx="0" ky="0" algn="bl" rotWithShape="0" blurRad="88900" dist="38100" dir="8100000">
+            <a:outerShdw blurRad="88900" dist="38100" dir="8100000" algn="bl" rotWithShape="0">
               <a:srgbClr val="000000">
                 <a:alpha val="16000"/>
               </a:srgbClr>
             </a:outerShdw>
           </a:effectLst>
         </p:spPr>
+        <p:txBody>
+          <a:bodyPr/>
+          <a:lstStyle/>
+          <a:p>
+            <a:endParaRPr lang="el-GR"/>
+          </a:p>
+        </p:txBody>
       </p:sp>
       <p:sp>
         <p:nvSpPr>
@@ -9093,6 +9305,13 @@
           </a:solidFill>
           <a:ln/>
         </p:spPr>
+        <p:txBody>
+          <a:bodyPr/>
+          <a:lstStyle/>
+          <a:p>
+            <a:endParaRPr lang="el-GR"/>
+          </a:p>
+        </p:txBody>
       </p:sp>
       <p:sp>
         <p:nvSpPr>
@@ -9115,7 +9334,7 @@
           <a:bodyPr wrap="square" lIns="0" tIns="0" rIns="0" bIns="0" rtlCol="0" anchor="ctr"/>
           <a:lstStyle/>
           <a:p>
-            <a:pPr indent="0" marL="0">
+            <a:pPr marL="0" indent="0">
               <a:buNone/>
             </a:pPr>
             <a:r>
@@ -9154,7 +9373,7 @@
           <a:bodyPr wrap="square" lIns="0" tIns="0" rIns="0" bIns="0" rtlCol="0" anchor="t"/>
           <a:lstStyle/>
           <a:p>
-            <a:pPr indent="0" marL="0">
+            <a:pPr marL="0" indent="0">
               <a:buNone/>
             </a:pPr>
             <a:r>
@@ -9193,7 +9412,7 @@
           <a:bodyPr wrap="square" lIns="0" tIns="0" rIns="0" bIns="0" rtlCol="0" anchor="t"/>
           <a:lstStyle/>
           <a:p>
-            <a:pPr indent="0" marL="0">
+            <a:pPr marL="0" indent="0">
               <a:buNone/>
             </a:pPr>
             <a:r>
@@ -9210,7 +9429,7 @@
             <a:endParaRPr lang="en-US" sz="1300" dirty="0"/>
           </a:p>
           <a:p>
-            <a:pPr indent="0" marL="0">
+            <a:pPr marL="0" indent="0">
               <a:buNone/>
             </a:pPr>
             <a:r>
@@ -9249,7 +9468,7 @@
           <a:bodyPr wrap="square" lIns="0" tIns="0" rIns="0" bIns="0" rtlCol="0" anchor="ctr"/>
           <a:lstStyle/>
           <a:p>
-            <a:pPr algn="ctr" indent="0" marL="0">
+            <a:pPr marL="0" indent="0" algn="ctr">
               <a:buNone/>
             </a:pPr>
             <a:r>
@@ -9288,7 +9507,7 @@
           <a:bodyPr wrap="square" lIns="0" tIns="0" rIns="0" bIns="0" rtlCol="0" anchor="ctr"/>
           <a:lstStyle/>
           <a:p>
-            <a:pPr indent="0" marL="0">
+            <a:pPr marL="0" indent="0">
               <a:buNone/>
             </a:pPr>
             <a:r>
@@ -9327,7 +9546,7 @@
           <a:bodyPr wrap="square" lIns="0" tIns="0" rIns="0" bIns="0" rtlCol="0" anchor="ctr"/>
           <a:lstStyle/>
           <a:p>
-            <a:pPr algn="r" indent="0" marL="0">
+            <a:pPr marL="0" indent="0" algn="r">
               <a:buNone/>
             </a:pPr>
             <a:r>
@@ -9646,4 +9865,319 @@
     </a:ext>
   </a:extLst>
 </a:theme>
+</file>
+
+<file path=ppt/theme/theme2.xml><?xml version="1.0" encoding="utf-8"?>
+<a:theme xmlns:a="http://schemas.openxmlformats.org/drawingml/2006/main" name="Office Theme">
+  <a:themeElements>
+    <a:clrScheme name="Office">
+      <a:dk1>
+        <a:sysClr val="windowText" lastClr="000000"/>
+      </a:dk1>
+      <a:lt1>
+        <a:sysClr val="window" lastClr="FFFFFF"/>
+      </a:lt1>
+      <a:dk2>
+        <a:srgbClr val="0E2841"/>
+      </a:dk2>
+      <a:lt2>
+        <a:srgbClr val="E8E8E8"/>
+      </a:lt2>
+      <a:accent1>
+        <a:srgbClr val="156082"/>
+      </a:accent1>
+      <a:accent2>
+        <a:srgbClr val="E97132"/>
+      </a:accent2>
+      <a:accent3>
+        <a:srgbClr val="196B24"/>
+      </a:accent3>
+      <a:accent4>
+        <a:srgbClr val="0F9ED5"/>
+      </a:accent4>
+      <a:accent5>
+        <a:srgbClr val="A02B93"/>
+      </a:accent5>
+      <a:accent6>
+        <a:srgbClr val="4EA72E"/>
+      </a:accent6>
+      <a:hlink>
+        <a:srgbClr val="467886"/>
+      </a:hlink>
+      <a:folHlink>
+        <a:srgbClr val="96607D"/>
+      </a:folHlink>
+    </a:clrScheme>
+    <a:fontScheme name="Office">
+      <a:majorFont>
+        <a:latin typeface="Aptos Display" panose="02110004020202020204"/>
+        <a:ea typeface=""/>
+        <a:cs typeface=""/>
+        <a:font script="Jpan" typeface="游ゴシック Light"/>
+        <a:font script="Hang" typeface="맑은 고딕"/>
+        <a:font script="Hans" typeface="等线 Light"/>
+        <a:font script="Hant" typeface="新細明體"/>
+        <a:font script="Arab" typeface="Times New Roman"/>
+        <a:font script="Hebr" typeface="Times New Roman"/>
+        <a:font script="Thai" typeface="Angsana New"/>
+        <a:font script="Ethi" typeface="Nyala"/>
+        <a:font script="Beng" typeface="Vrinda"/>
+        <a:font script="Gujr" typeface="Shruti"/>
+        <a:font script="Khmr" typeface="MoolBoran"/>
+        <a:font script="Knda" typeface="Tunga"/>
+        <a:font script="Guru" typeface="Raavi"/>
+        <a:font script="Cans" typeface="Euphemia"/>
+        <a:font script="Cher" typeface="Plantagenet Cherokee"/>
+        <a:font script="Yiii" typeface="Microsoft Yi Baiti"/>
+        <a:font script="Tibt" typeface="Microsoft Himalaya"/>
+        <a:font script="Thaa" typeface="MV Boli"/>
+        <a:font script="Deva" typeface="Mangal"/>
+        <a:font script="Telu" typeface="Gautami"/>
+        <a:font script="Taml" typeface="Latha"/>
+        <a:font script="Syrc" typeface="Estrangelo Edessa"/>
+        <a:font script="Orya" typeface="Kalinga"/>
+        <a:font script="Mlym" typeface="Kartika"/>
+        <a:font script="Laoo" typeface="DokChampa"/>
+        <a:font script="Sinh" typeface="Iskoola Pota"/>
+        <a:font script="Mong" typeface="Mongolian Baiti"/>
+        <a:font script="Viet" typeface="Times New Roman"/>
+        <a:font script="Uigh" typeface="Microsoft Uighur"/>
+        <a:font script="Geor" typeface="Sylfaen"/>
+        <a:font script="Armn" typeface="Arial"/>
+        <a:font script="Bugi" typeface="Leelawadee UI"/>
+        <a:font script="Bopo" typeface="Microsoft JhengHei"/>
+        <a:font script="Java" typeface="Javanese Text"/>
+        <a:font script="Lisu" typeface="Segoe UI"/>
+        <a:font script="Mymr" typeface="Myanmar Text"/>
+        <a:font script="Nkoo" typeface="Ebrima"/>
+        <a:font script="Olck" typeface="Nirmala UI"/>
+        <a:font script="Osma" typeface="Ebrima"/>
+        <a:font script="Phag" typeface="Phagspa"/>
+        <a:font script="Syrn" typeface="Estrangelo Edessa"/>
+        <a:font script="Syrj" typeface="Estrangelo Edessa"/>
+        <a:font script="Syre" typeface="Estrangelo Edessa"/>
+        <a:font script="Sora" typeface="Nirmala UI"/>
+        <a:font script="Tale" typeface="Microsoft Tai Le"/>
+        <a:font script="Talu" typeface="Microsoft New Tai Lue"/>
+        <a:font script="Tfng" typeface="Ebrima"/>
+      </a:majorFont>
+      <a:minorFont>
+        <a:latin typeface="Aptos" panose="02110004020202020204"/>
+        <a:ea typeface=""/>
+        <a:cs typeface=""/>
+        <a:font script="Jpan" typeface="游ゴシック"/>
+        <a:font script="Hang" typeface="맑은 고딕"/>
+        <a:font script="Hans" typeface="等线"/>
+        <a:font script="Hant" typeface="新細明體"/>
+        <a:font script="Arab" typeface="Arial"/>
+        <a:font script="Hebr" typeface="Arial"/>
+        <a:font script="Thai" typeface="Cordia New"/>
+        <a:font script="Ethi" typeface="Nyala"/>
+        <a:font script="Beng" typeface="Vrinda"/>
+        <a:font script="Gujr" typeface="Shruti"/>
+        <a:font script="Khmr" typeface="DaunPenh"/>
+        <a:font script="Knda" typeface="Tunga"/>
+        <a:font script="Guru" typeface="Raavi"/>
+        <a:font script="Cans" typeface="Euphemia"/>
+        <a:font script="Cher" typeface="Plantagenet Cherokee"/>
+        <a:font script="Yiii" typeface="Microsoft Yi Baiti"/>
+        <a:font script="Tibt" typeface="Microsoft Himalaya"/>
+        <a:font script="Thaa" typeface="MV Boli"/>
+        <a:font script="Deva" typeface="Mangal"/>
+        <a:font script="Telu" typeface="Gautami"/>
+        <a:font script="Taml" typeface="Latha"/>
+        <a:font script="Syrc" typeface="Estrangelo Edessa"/>
+        <a:font script="Orya" typeface="Kalinga"/>
+        <a:font script="Mlym" typeface="Kartika"/>
+        <a:font script="Laoo" typeface="DokChampa"/>
+        <a:font script="Sinh" typeface="Iskoola Pota"/>
+        <a:font script="Mong" typeface="Mongolian Baiti"/>
+        <a:font script="Viet" typeface="Arial"/>
+        <a:font script="Uigh" typeface="Microsoft Uighur"/>
+        <a:font script="Geor" typeface="Sylfaen"/>
+        <a:font script="Armn" typeface="Arial"/>
+        <a:font script="Bugi" typeface="Leelawadee UI"/>
+        <a:font script="Bopo" typeface="Microsoft JhengHei"/>
+        <a:font script="Java" typeface="Javanese Text"/>
+        <a:font script="Lisu" typeface="Segoe UI"/>
+        <a:font script="Mymr" typeface="Myanmar Text"/>
+        <a:font script="Nkoo" typeface="Ebrima"/>
+        <a:font script="Olck" typeface="Nirmala UI"/>
+        <a:font script="Osma" typeface="Ebrima"/>
+        <a:font script="Phag" typeface="Phagspa"/>
+        <a:font script="Syrn" typeface="Estrangelo Edessa"/>
+        <a:font script="Syrj" typeface="Estrangelo Edessa"/>
+        <a:font script="Syre" typeface="Estrangelo Edessa"/>
+        <a:font script="Sora" typeface="Nirmala UI"/>
+        <a:font script="Tale" typeface="Microsoft Tai Le"/>
+        <a:font script="Talu" typeface="Microsoft New Tai Lue"/>
+        <a:font script="Tfng" typeface="Ebrima"/>
+      </a:minorFont>
+    </a:fontScheme>
+    <a:fmtScheme name="Office">
+      <a:fillStyleLst>
+        <a:solidFill>
+          <a:schemeClr val="phClr"/>
+        </a:solidFill>
+        <a:gradFill rotWithShape="1">
+          <a:gsLst>
+            <a:gs pos="0">
+              <a:schemeClr val="phClr">
+                <a:lumMod val="110000"/>
+                <a:satMod val="105000"/>
+                <a:tint val="67000"/>
+              </a:schemeClr>
+            </a:gs>
+            <a:gs pos="50000">
+              <a:schemeClr val="phClr">
+                <a:lumMod val="105000"/>
+                <a:satMod val="103000"/>
+                <a:tint val="73000"/>
+              </a:schemeClr>
+            </a:gs>
+            <a:gs pos="100000">
+              <a:schemeClr val="phClr">
+                <a:lumMod val="105000"/>
+                <a:satMod val="109000"/>
+                <a:tint val="81000"/>
+              </a:schemeClr>
+            </a:gs>
+          </a:gsLst>
+          <a:lin ang="5400000" scaled="0"/>
+        </a:gradFill>
+        <a:gradFill rotWithShape="1">
+          <a:gsLst>
+            <a:gs pos="0">
+              <a:schemeClr val="phClr">
+                <a:satMod val="103000"/>
+                <a:lumMod val="102000"/>
+                <a:tint val="94000"/>
+              </a:schemeClr>
+            </a:gs>
+            <a:gs pos="50000">
+              <a:schemeClr val="phClr">
+                <a:satMod val="110000"/>
+                <a:lumMod val="100000"/>
+                <a:shade val="100000"/>
+              </a:schemeClr>
+            </a:gs>
+            <a:gs pos="100000">
+              <a:schemeClr val="phClr">
+                <a:lumMod val="99000"/>
+                <a:satMod val="120000"/>
+                <a:shade val="78000"/>
+              </a:schemeClr>
+            </a:gs>
+          </a:gsLst>
+          <a:lin ang="5400000" scaled="0"/>
+        </a:gradFill>
+      </a:fillStyleLst>
+      <a:lnStyleLst>
+        <a:ln w="12700" cap="flat" cmpd="sng" algn="ctr">
+          <a:solidFill>
+            <a:schemeClr val="phClr"/>
+          </a:solidFill>
+          <a:prstDash val="solid"/>
+          <a:miter lim="800000"/>
+        </a:ln>
+        <a:ln w="19050" cap="flat" cmpd="sng" algn="ctr">
+          <a:solidFill>
+            <a:schemeClr val="phClr"/>
+          </a:solidFill>
+          <a:prstDash val="solid"/>
+          <a:miter lim="800000"/>
+        </a:ln>
+        <a:ln w="25400" cap="flat" cmpd="sng" algn="ctr">
+          <a:solidFill>
+            <a:schemeClr val="phClr"/>
+          </a:solidFill>
+          <a:prstDash val="solid"/>
+          <a:miter lim="800000"/>
+        </a:ln>
+      </a:lnStyleLst>
+      <a:effectStyleLst>
+        <a:effectStyle>
+          <a:effectLst/>
+        </a:effectStyle>
+        <a:effectStyle>
+          <a:effectLst/>
+        </a:effectStyle>
+        <a:effectStyle>
+          <a:effectLst>
+            <a:outerShdw blurRad="57150" dist="19050" dir="5400000" algn="ctr" rotWithShape="0">
+              <a:srgbClr val="000000">
+                <a:alpha val="63000"/>
+              </a:srgbClr>
+            </a:outerShdw>
+          </a:effectLst>
+        </a:effectStyle>
+      </a:effectStyleLst>
+      <a:bgFillStyleLst>
+        <a:solidFill>
+          <a:schemeClr val="phClr"/>
+        </a:solidFill>
+        <a:solidFill>
+          <a:schemeClr val="phClr">
+            <a:tint val="95000"/>
+            <a:satMod val="170000"/>
+          </a:schemeClr>
+        </a:solidFill>
+        <a:gradFill rotWithShape="1">
+          <a:gsLst>
+            <a:gs pos="0">
+              <a:schemeClr val="phClr">
+                <a:tint val="93000"/>
+                <a:satMod val="150000"/>
+                <a:shade val="98000"/>
+                <a:lumMod val="102000"/>
+              </a:schemeClr>
+            </a:gs>
+            <a:gs pos="50000">
+              <a:schemeClr val="phClr">
+                <a:tint val="98000"/>
+                <a:satMod val="130000"/>
+                <a:shade val="90000"/>
+                <a:lumMod val="103000"/>
+              </a:schemeClr>
+            </a:gs>
+            <a:gs pos="100000">
+              <a:schemeClr val="phClr">
+                <a:shade val="63000"/>
+                <a:satMod val="120000"/>
+              </a:schemeClr>
+            </a:gs>
+          </a:gsLst>
+          <a:lin ang="5400000" scaled="0"/>
+        </a:gradFill>
+      </a:bgFillStyleLst>
+    </a:fmtScheme>
+  </a:themeElements>
+  <a:objectDefaults>
+    <a:lnDef>
+      <a:spPr/>
+      <a:bodyPr/>
+      <a:lstStyle/>
+      <a:style>
+        <a:lnRef idx="2">
+          <a:schemeClr val="accent1"/>
+        </a:lnRef>
+        <a:fillRef idx="0">
+          <a:schemeClr val="accent1"/>
+        </a:fillRef>
+        <a:effectRef idx="1">
+          <a:schemeClr val="accent1"/>
+        </a:effectRef>
+        <a:fontRef idx="minor">
+          <a:schemeClr val="tx1"/>
+        </a:fontRef>
+      </a:style>
+    </a:lnDef>
+  </a:objectDefaults>
+  <a:extraClrSchemeLst/>
+  <a:extLst>
+    <a:ext uri="{05A4C25C-085E-4340-85A3-A5531E510DB2}">
+      <thm15:themeFamily xmlns:thm15="http://schemas.microsoft.com/office/thememl/2012/main" name="Office Theme" id="{2E142A2C-CD16-42D6-873A-C26D2A0506FA}" vid="{1BDDFF52-6CD6-40A5-AB3C-68EB2F1E4D0A}"/>
+    </a:ext>
+  </a:extLst>
+</a:theme>
 </file>
</xml_diff>